<commit_message>
PDF drag-and-drop upload; corrected and tightened video user guide
- New Generation form is now a drop zone: drag a PDF anywhere onto the
  Source box and it attaches (switches to PDF mode, shows the filename);
  chosen-file feedback added to the picker path too
- User guide regenerated: every workbench screenshot now shows its correct
  screen (the previous build accidentally used the New Generation form on
  all six screenshot slides), the opening no longer repeats the product
  name, and the narration covers drag-and-drop upload
- Opening line tightened using the studio's own script-revision loop

Co-Authored-By: Claude Fable 5 <noreply@anthropic.com>
</commit_message>
<xml_diff>
--- a/docs/user-guide.pptx
+++ b/docs/user-guide.pptx
@@ -22,6 +22,9 @@
     <p:sldId id="270" r:id="rId22"/>
     <p:sldId id="271" r:id="rId23"/>
     <p:sldId id="272" r:id="rId24"/>
+    <p:sldId id="273" r:id="rId25"/>
+    <p:sldId id="274" r:id="rId26"/>
+    <p:sldId id="275" r:id="rId27"/>
   </p:sldIdLst>
   <p:sldSz cx="12191695" cy="6858000" type="screen4x3"/>
   <p:notesSz cx="6858000" cy="9144000"/>
@@ -518,19 +521,7 @@
           <a:lstStyle/>
           <a:p>
             <a:r>
-              <a:t>Here's a complete read-through of the Fluent Agents Studio user guide — and if you're brand new to making videos or voice-overs, this is exactly where you want to start. As we go, you'll learn how to turn any article or PDF into a finished audio episode, slideshow, video, or PowerPoint, all without ever touching an editing tool. Let's begin.</a:t>
-            </a:r>
-          </a:p>
-          <a:p/>
-          <a:p>
-            <a:r>
-              <a:t>Welcome to Fluent Agents Studio — from zero to hero.</a:t>
-            </a:r>
-          </a:p>
-          <a:p/>
-          <a:p>
-            <a:r>
-              <a:t>Welcome to Fluent Agents Studio. This guide takes you from opening the app for the first time to producing a finished video with a professional voice-over — even if you have never made a podcast, a voice-over, or a slideshow in your life. Nothing here assumes experience. If you can paste a web address and describe what you want in a plain sentence, you have every skill this tool requires.</a:t>
+              <a:t>Welcome to your complete beginner's guide to Fluent Agents Studio — read start to finish. This guide takes you from opening the studio for the first time to producing a finished video with a professional voice-over, even if you have never made a podcast, a voice-over, or a slideshow in your life. Nothing here assumes experience. If you can paste a web address and describe what you want in a plain sentence, you have every skill this tool requires. And if you're brand new to this whole world, don't worry — I'll walk beside you the entire way, and you'll find the clearest help in the sections on writing your script, shaping your slides, and directing the voice.</a:t>
             </a:r>
           </a:p>
         </p:txBody>
@@ -600,13 +591,13 @@
           <a:lstStyle/>
           <a:p>
             <a:r>
-              <a:t>The Script tab shows every line the voice will speak, numbered, with a badge showing which speaker says it. Read it like a director reads a draft. If you want changes, do not edit text — describe what you want in the Revision Instructions box, exactly as you would tell a writer: "Open with a question instead of an announcement." "Cut the part about pricing." "Make host B funnier." The studio rewrites precisely what you asked for and leaves the rest word-for-word untouched. You can revise as many times as you like, and each round takes about a minute. This is the single most important habit in the studio: iterate on the cheap words before you spend time on audio and video.</a:t>
+              <a:t>Every production moves through the same four stations, and the job page shows them as a strip of lights: Script, Slides, Voice, Outputs. An amber light means that station is finished; a pulsing light means it is working right now. Click any light to jump to that station's page. The order matters, and it is the same order a human production team would use: first the words, then the visuals, then the recording, then the packaging. The workbench is built around one principle — you can stop at any station, change your mind in plain English, and everything downstream updates.</a:t>
             </a:r>
           </a:p>
           <a:p/>
           <a:p>
             <a:r>
-              <a:t>On to station two: the slides.</a:t>
+              <a:t>Let's visit station one: the script.</a:t>
             </a:r>
           </a:p>
         </p:txBody>
@@ -676,13 +667,13 @@
           <a:lstStyle/>
           <a:p>
             <a:r>
-              <a:t>The Slides tab shows the deck as cards — each card is one slide, anchored to the exact line of narration where it will appear. Slides are not just text. The studio pulls real images out of your source article and places them where they fit, and it designs its own figures — charts, timelines, diagrams — whenever the material has data worth showing. An Asset Inventory at the bottom lists every image and figure and tells you exactly which slide uses each one, so nothing is a mystery.</a:t>
+              <a:t>The Script tab shows every line the voice will speak, numbered, with a badge showing which speaker says it. Read it like a director reads a draft. If you want changes, do not edit text — describe what you want in the Revision Instructions box, exactly as you would tell a writer: "Open with a question instead of an announcement." "Cut the part about pricing." "Make host B funnier." The studio rewrites precisely what you asked for and leaves the rest word-for-word untouched. You can revise as many times as you like, and each round takes about a minute. This is the single most important habit in the studio: iterate on the cheap words before you spend time on audio and video.</a:t>
             </a:r>
           </a:p>
           <a:p/>
           <a:p>
             <a:r>
-              <a:t>Slides revise just like the script: plain instructions in the box. "Make every title a question." "Merge slides three and four." "More detail on the budget slide." And you can set expectations up front with the Slide Expectations field — "ultra minimal, one phrase per slide" gives you a keynote; "more informative than the voice-over, with data the narration skips" gives you reference slides worth pausing on.</a:t>
+              <a:t>On to station two: the slides.</a:t>
             </a:r>
           </a:p>
         </p:txBody>
@@ -752,13 +743,13 @@
           <a:lstStyle/>
           <a:p>
             <a:r>
-              <a:t>If you have a company look, the Templates page stores it. Upload a PowerPoint template, a style guide document, or even a screenshot of slides you like; the studio extracts the colors and fonts and applies them to everything it renders — the slideshow, the video, and the PowerPoint. Save it once as a template set and apply it to any future production from a dropdown.</a:t>
+              <a:t>The Slides tab shows the deck as cards — each card is one slide, anchored to the exact line of narration where it will appear. Slides are not just text. The studio pulls real images out of your source article and places them where they fit, and it designs its own figures — charts, timelines, diagrams — whenever the material has data worth showing. An Asset Inventory at the bottom lists every image and figure and tells you exactly which slide uses each one, so nothing is a mystery.</a:t>
             </a:r>
           </a:p>
           <a:p/>
           <a:p>
             <a:r>
-              <a:t>Now station three: the voice.</a:t>
+              <a:t>Slides revise just like the script: plain instructions in the box. "Make every title a question." "Merge slides three and four." "More detail on the budget slide." And you can set expectations up front with the Slide Expectations field — "ultra minimal, one phrase per slide" gives you a keynote; "more informative than the voice-over, with data the narration skips" gives you reference slides worth pausing on.</a:t>
             </a:r>
           </a:p>
         </p:txBody>
@@ -828,7 +819,13 @@
           <a:lstStyle/>
           <a:p>
             <a:r>
-              <a:t>Here is where novices usually expect the hard part — and where the studio does the most for you. The narration is synthesized line by line, and every line can be directed individually. The Voice tab takes revision instructions that reference transcript line numbers: "Line 4: slow down ten percent and pause after the question." "Pronounce Nguyen as win, everywhere it appears." The transcript and captions keep the correct spelling; only the pronunciation changes. Audio re-records automatically after every voice revision, so you hear the result within a minute or two.</a:t>
+              <a:t>If you have a company look, the Templates page stores it. Upload a PowerPoint template, a style guide document, or even a screenshot of slides you like; the studio extracts the colors and fonts and applies them to everything it renders — the slideshow, the video, and the PowerPoint. Save it once as a template set and apply it to any future production from a dropdown.</a:t>
+            </a:r>
+          </a:p>
+          <a:p/>
+          <a:p>
+            <a:r>
+              <a:t>Now for station three: the voice. And here's a reassuring note if you're new.</a:t>
             </a:r>
           </a:p>
         </p:txBody>
@@ -898,19 +895,7 @@
           <a:lstStyle/>
           <a:p>
             <a:r>
-              <a:t>The best review tool in the studio lives on the slide cards: the small play button. It opens the slide full-screen and plays exactly the stretch of narration that belongs to it — not the whole episode, just that slide's segment. Step through with the arrow buttons, or switch on auto-advance and review the whole production slide by slide. This is how you catch the slide that arrives a beat too late or the sentence that needs more air.</a:t>
-            </a:r>
-          </a:p>
-          <a:p/>
-          <a:p>
-            <a:r>
-              <a:t>And when a slide does arrive too late? Every card has an offset field: type minus two to bring the slide in two seconds earlier, press Apply Timing, and the slideshow and video re-render with the new timing in seconds — the audio is never touched.</a:t>
-            </a:r>
-          </a:p>
-          <a:p/>
-          <a:p>
-            <a:r>
-              <a:t>And finally, station four: the outputs.</a:t>
+              <a:t>Here is where novices usually expect the hard part — and where the studio does the most for you. The narration is synthesized line by line, and every line can be directed individually. The Voice tab takes revision instructions that reference transcript line numbers: "Line 4: slow down ten percent and pause after the question." "Pronounce Nguyen as win, everywhere it appears." The transcript and captions keep the correct spelling; only the pronunciation changes. Audio re-records automatically after every voice revision, so you hear the result within a minute or two.</a:t>
             </a:r>
           </a:p>
         </p:txBody>
@@ -980,19 +965,7 @@
           <a:lstStyle/>
           <a:p>
             <a:r>
-              <a:t>The Outputs tab is the packaging department. The Render Production button assembles everything from the current script, slides, and voice direction. Below it, each finished artifact gets a card: the audio as an MP3, a transcript with a timestamp on every line, the web slideshow — a single file you can email to anyone, audio included, slides advancing in sync — the video for uploading anywhere, and the PowerPoint, which carries the narration as speaker notes on every slide so you can present the deck yourself.</a:t>
-            </a:r>
-          </a:p>
-          <a:p/>
-          <a:p>
-            <a:r>
-              <a:t>One honest word about cost. The studio's writing and design run on a paid AI model, and each job's header shows a small chip with its running spend — usually well under a dollar for a full production. Revisions are engineered to be cheap: when you iterate several times within a few minutes, the repeated material is billed at about a tenth of the normal price. The habit that saves money is the same habit that makes good productions: revise in focused bursts.</a:t>
-            </a:r>
-          </a:p>
-          <a:p/>
-          <a:p>
-            <a:r>
-              <a:t>Let's bring it all together with the zero-to-hero path.</a:t>
+              <a:t>The best review tool in the studio lives on the slide cards: the small play button. It opens the slide full-screen and plays exactly the stretch of narration that belongs to it — not the whole episode, just that slide's segment. Step through with the arrow buttons, or switch on auto-advance and review the whole production slide by slide. This is how you catch the slide that arrives a beat too late or the sentence that needs more air.</a:t>
             </a:r>
           </a:p>
         </p:txBody>
@@ -1062,13 +1035,13 @@
           <a:lstStyle/>
           <a:p>
             <a:r>
-              <a:t>So here is the whole method, compressed. Start a generation with a source, a mode, and an audience, and run it only until the script. Read the script; revise it in plain English until it says what you mean. Create the slides; shape them with instructions and, if you have one, your template. Render the production. Review it slide by slide with the play buttons; fix pronunciations and pacing with voice instructions; nudge timing with offsets. Then collect your outputs — and notice that the entire process never once required you to edit audio, design a slide, or touch a video editor.</a:t>
+              <a:t>And when a slide does arrive too late? Every card has an offset field: type minus two to bring the slide in two seconds earlier, press Apply Timing, and the slideshow and video re-render with the new timing in seconds — the audio is never touched.</a:t>
             </a:r>
           </a:p>
           <a:p/>
           <a:p>
             <a:r>
-              <a:t>That is the studio's promise to a beginner: the production skills are built in, so the only skill you bring is knowing what you want to say, to whom. Everything you just heard — this voice, these slides, the figures and the screenshots — was produced by the workbench this guide describes, in one pass, from a written document. Your first production is one pasted link away. Welcome to Fluent Agents Studio.</a:t>
+              <a:t>And finally, station four: the outputs.</a:t>
             </a:r>
           </a:p>
         </p:txBody>
@@ -1138,7 +1111,159 @@
           <a:lstStyle/>
           <a:p>
             <a:r>
-              <a:t>And that brings us to the end of the guide. You now know the whole journey from a single link to a finished production — happy creating.</a:t>
+              <a:t>The Outputs tab is the packaging department. The Render Production button assembles everything from the current script, slides, and voice direction. Below it, each finished artifact gets a card: the audio as an MP3, a transcript with a timestamp on every line, the web slideshow — a single file you can email to anyone, audio included, slides advancing in sync — the video for uploading anywhere, and the PowerPoint, which carries the narration as speaker notes on every slide so you can present the deck yourself.</a:t>
+            </a:r>
+          </a:p>
+        </p:txBody>
+      </p:sp>
+      <p:sp>
+        <p:nvSpPr>
+          <p:cNvPr id="4" name="Slide Number Placeholder 3"/>
+          <p:cNvSpPr>
+            <a:spLocks noGrp="1"/>
+          </p:cNvSpPr>
+          <p:nvPr>
+            <p:ph type="sldNum" idx="5" sz="quarter"/>
+          </p:nvPr>
+        </p:nvSpPr>
+        <p:spPr/>
+      </p:sp>
+    </p:spTree>
+  </p:cSld>
+  <p:clrMapOvr>
+    <a:masterClrMapping/>
+  </p:clrMapOvr>
+</p:notes>
+</file>
+
+<file path=ppt/notesSlides/notesSlide18.xml><?xml version="1.0" encoding="utf-8"?>
+<p:notes xmlns:a="http://schemas.openxmlformats.org/drawingml/2006/main" xmlns:p="http://schemas.openxmlformats.org/presentationml/2006/main" xmlns:r="http://schemas.openxmlformats.org/officeDocument/2006/relationships">
+  <p:cSld>
+    <p:spTree>
+      <p:nvGrpSpPr>
+        <p:cNvPr id="1" name=""/>
+        <p:cNvGrpSpPr/>
+        <p:nvPr/>
+      </p:nvGrpSpPr>
+      <p:grpSpPr>
+        <a:xfrm>
+          <a:off x="0" y="0"/>
+          <a:ext cx="0" cy="0"/>
+          <a:chOff x="0" y="0"/>
+          <a:chExt cx="0" cy="0"/>
+        </a:xfrm>
+      </p:grpSpPr>
+      <p:sp>
+        <p:nvSpPr>
+          <p:cNvPr id="2" name="Slide Image Placeholder 1"/>
+          <p:cNvSpPr>
+            <a:spLocks noGrp="1"/>
+          </p:cNvSpPr>
+          <p:nvPr>
+            <p:ph type="sldImg" idx="2"/>
+          </p:nvPr>
+        </p:nvSpPr>
+        <p:spPr/>
+      </p:sp>
+      <p:sp>
+        <p:nvSpPr>
+          <p:cNvPr id="3" name="Notes Placeholder 2"/>
+          <p:cNvSpPr>
+            <a:spLocks noGrp="1"/>
+          </p:cNvSpPr>
+          <p:nvPr>
+            <p:ph type="body" idx="3" sz="quarter"/>
+          </p:nvPr>
+        </p:nvSpPr>
+        <p:spPr/>
+        <p:txBody>
+          <a:bodyPr/>
+          <a:lstStyle/>
+          <a:p>
+            <a:r>
+              <a:t>One honest word about cost. The studio's writing and design run on a paid AI model, and each job's header shows a small chip with its running spend — usually well under a dollar for a full production. Revisions are engineered to be cheap: when you iterate several times within a few minutes, the repeated material is billed at about a tenth of the normal price. The habit that saves money is the same habit that makes good productions: revise in focused bursts.</a:t>
+            </a:r>
+          </a:p>
+          <a:p/>
+          <a:p>
+            <a:r>
+              <a:t>Let's bring it all together — the zero-to-hero path.</a:t>
+            </a:r>
+          </a:p>
+        </p:txBody>
+      </p:sp>
+      <p:sp>
+        <p:nvSpPr>
+          <p:cNvPr id="4" name="Slide Number Placeholder 3"/>
+          <p:cNvSpPr>
+            <a:spLocks noGrp="1"/>
+          </p:cNvSpPr>
+          <p:nvPr>
+            <p:ph type="sldNum" idx="5" sz="quarter"/>
+          </p:nvPr>
+        </p:nvSpPr>
+        <p:spPr/>
+      </p:sp>
+    </p:spTree>
+  </p:cSld>
+  <p:clrMapOvr>
+    <a:masterClrMapping/>
+  </p:clrMapOvr>
+</p:notes>
+</file>
+
+<file path=ppt/notesSlides/notesSlide19.xml><?xml version="1.0" encoding="utf-8"?>
+<p:notes xmlns:a="http://schemas.openxmlformats.org/drawingml/2006/main" xmlns:p="http://schemas.openxmlformats.org/presentationml/2006/main" xmlns:r="http://schemas.openxmlformats.org/officeDocument/2006/relationships">
+  <p:cSld>
+    <p:spTree>
+      <p:nvGrpSpPr>
+        <p:cNvPr id="1" name=""/>
+        <p:cNvGrpSpPr/>
+        <p:nvPr/>
+      </p:nvGrpSpPr>
+      <p:grpSpPr>
+        <a:xfrm>
+          <a:off x="0" y="0"/>
+          <a:ext cx="0" cy="0"/>
+          <a:chOff x="0" y="0"/>
+          <a:chExt cx="0" cy="0"/>
+        </a:xfrm>
+      </p:grpSpPr>
+      <p:sp>
+        <p:nvSpPr>
+          <p:cNvPr id="2" name="Slide Image Placeholder 1"/>
+          <p:cNvSpPr>
+            <a:spLocks noGrp="1"/>
+          </p:cNvSpPr>
+          <p:nvPr>
+            <p:ph type="sldImg" idx="2"/>
+          </p:nvPr>
+        </p:nvSpPr>
+        <p:spPr/>
+      </p:sp>
+      <p:sp>
+        <p:nvSpPr>
+          <p:cNvPr id="3" name="Notes Placeholder 2"/>
+          <p:cNvSpPr>
+            <a:spLocks noGrp="1"/>
+          </p:cNvSpPr>
+          <p:nvPr>
+            <p:ph type="body" idx="3" sz="quarter"/>
+          </p:nvPr>
+        </p:nvSpPr>
+        <p:spPr/>
+        <p:txBody>
+          <a:bodyPr/>
+          <a:lstStyle/>
+          <a:p>
+            <a:r>
+              <a:t>So here is the whole method, compressed. Start a generation with a source, a mode, and an audience, and run it only until the script. Read the script; revise it in plain English until it says what you mean. Create the slides; shape them with instructions and, if you have one, your template. Render the production. Review it slide by slide with the play buttons; fix pronunciations and pacing with voice instructions; nudge timing with offsets. Then collect your outputs — and notice that the entire process never once required you to edit audio, design a slide, or touch a video editor.</a:t>
+            </a:r>
+          </a:p>
+          <a:p/>
+          <a:p>
+            <a:r>
+              <a:t>That is the studio's promise to a beginner: the production skills are built in, so the only skill you bring is knowing what you want to say, to whom. Everything you just heard — this voice, these slides, the figures and the screenshots — was produced by the workbench this guide describes, in one pass, from a written document. Your first production is one pasted link away. Welcome to Fluent Agents Studio.</a:t>
             </a:r>
           </a:p>
         </p:txBody>
@@ -1214,7 +1339,77 @@
           <a:p/>
           <a:p>
             <a:r>
-              <a:t>Let's take a look at the workbench at a glance.</a:t>
+              <a:t>Let's start by getting our bearings — the workbench at a glance.</a:t>
+            </a:r>
+          </a:p>
+        </p:txBody>
+      </p:sp>
+      <p:sp>
+        <p:nvSpPr>
+          <p:cNvPr id="4" name="Slide Number Placeholder 3"/>
+          <p:cNvSpPr>
+            <a:spLocks noGrp="1"/>
+          </p:cNvSpPr>
+          <p:nvPr>
+            <p:ph type="sldNum" idx="5" sz="quarter"/>
+          </p:nvPr>
+        </p:nvSpPr>
+        <p:spPr/>
+      </p:sp>
+    </p:spTree>
+  </p:cSld>
+  <p:clrMapOvr>
+    <a:masterClrMapping/>
+  </p:clrMapOvr>
+</p:notes>
+</file>
+
+<file path=ppt/notesSlides/notesSlide20.xml><?xml version="1.0" encoding="utf-8"?>
+<p:notes xmlns:a="http://schemas.openxmlformats.org/drawingml/2006/main" xmlns:p="http://schemas.openxmlformats.org/presentationml/2006/main" xmlns:r="http://schemas.openxmlformats.org/officeDocument/2006/relationships">
+  <p:cSld>
+    <p:spTree>
+      <p:nvGrpSpPr>
+        <p:cNvPr id="1" name=""/>
+        <p:cNvGrpSpPr/>
+        <p:nvPr/>
+      </p:nvGrpSpPr>
+      <p:grpSpPr>
+        <a:xfrm>
+          <a:off x="0" y="0"/>
+          <a:ext cx="0" cy="0"/>
+          <a:chOff x="0" y="0"/>
+          <a:chExt cx="0" cy="0"/>
+        </a:xfrm>
+      </p:grpSpPr>
+      <p:sp>
+        <p:nvSpPr>
+          <p:cNvPr id="2" name="Slide Image Placeholder 1"/>
+          <p:cNvSpPr>
+            <a:spLocks noGrp="1"/>
+          </p:cNvSpPr>
+          <p:nvPr>
+            <p:ph type="sldImg" idx="2"/>
+          </p:nvPr>
+        </p:nvSpPr>
+        <p:spPr/>
+      </p:sp>
+      <p:sp>
+        <p:nvSpPr>
+          <p:cNvPr id="3" name="Notes Placeholder 2"/>
+          <p:cNvSpPr>
+            <a:spLocks noGrp="1"/>
+          </p:cNvSpPr>
+          <p:nvPr>
+            <p:ph type="body" idx="3" sz="quarter"/>
+          </p:nvPr>
+        </p:nvSpPr>
+        <p:spPr/>
+        <p:txBody>
+          <a:bodyPr/>
+          <a:lstStyle/>
+          <a:p>
+            <a:r>
+              <a:t>And that's the complete guide. Go paste that link — your first production is waiting.</a:t>
             </a:r>
           </a:p>
         </p:txBody>
@@ -1290,7 +1485,7 @@
           <a:p/>
           <a:p>
             <a:r>
-              <a:t>Now let's create your first production, step by step.</a:t>
+              <a:t>Now let's make something. Here's your first production, step by step.</a:t>
             </a:r>
           </a:p>
         </p:txBody>
@@ -1360,7 +1555,7 @@
           <a:lstStyle/>
           <a:p>
             <a:r>
-              <a:t>Let's walk the form from top to bottom. Under Source, you paste the web address of an article, or switch to PDF upload and pick a file from your computer. This is the raw material — the studio will read it so your listeners don't have to.</a:t>
+              <a:t>Let's walk the form from top to bottom. Under Source, you paste the web address of an article — or use a PDF instead: switch to PDF upload and pick a file, or simply drag the PDF from your computer anywhere onto the Source box and it attaches itself. This is the raw material — the studio will read it so your listeners don't have to.</a:t>
             </a:r>
           </a:p>
         </p:txBody>
@@ -1643,12 +1838,6 @@
               <a:t>Finally the Slides and Captions section. Slides picks your output formats: a web slideshow, a video file, a PowerPoint, or a combination. Captions puts the spoken words on screen — choose Burned to print them permanently into the video, or Toggle to let each viewer switch them on and off. Then press Start Generation and watch the pipeline go to work.</a:t>
             </a:r>
           </a:p>
-          <a:p/>
-          <a:p>
-            <a:r>
-              <a:t>Now, about that pipeline — think of it as four stations on an assembly line.</a:t>
-            </a:r>
-          </a:p>
         </p:txBody>
       </p:sp>
       <p:sp>
@@ -1716,13 +1905,7 @@
           <a:lstStyle/>
           <a:p>
             <a:r>
-              <a:t>Every production moves through the same four stations, and the job page shows them as a strip of lights: Script, Slides, Voice, Outputs. An amber light means that station is finished; a pulsing light means it is working right now. Click any light to jump to that station's page. The order matters, and it is the same order a human production team would use: first the words, then the visuals, then the recording, then the packaging. The workbench is built around one principle — you can stop at any station, change your mind in plain English, and everything downstream updates.</a:t>
-            </a:r>
-          </a:p>
-          <a:p/>
-          <a:p>
-            <a:r>
-              <a:t>Let's start with station one: the script.</a:t>
+              <a:t>So what happens after you press that button? Think of it as an assembly line with four stations.</a:t>
             </a:r>
           </a:p>
         </p:txBody>
@@ -4789,7 +4972,7 @@
         <p:spPr>
           <a:xfrm>
             <a:off x="822960" y="502920"/>
-            <a:ext cx="5577840" cy="2011680"/>
+            <a:ext cx="10424160" cy="2011680"/>
           </a:xfrm>
           <a:prstGeom prst="rect">
             <a:avLst/>
@@ -4825,7 +5008,7 @@
         <p:spPr>
           <a:xfrm>
             <a:off x="822960" y="2377440"/>
-            <a:ext cx="5577840" cy="1645920"/>
+            <a:ext cx="10424160" cy="1645920"/>
           </a:xfrm>
           <a:prstGeom prst="rect">
             <a:avLst/>
@@ -4852,33 +5035,9 @@
           </a:p>
         </p:txBody>
       </p:sp>
-      <p:pic>
-        <p:nvPicPr>
-          <p:cNvPr id="5" name="Picture 4" descr="img_01.jpg"/>
-          <p:cNvPicPr>
-            <a:picLocks noChangeAspect="1"/>
-          </p:cNvPicPr>
-          <p:nvPr/>
-        </p:nvPicPr>
-        <p:blipFill>
-          <a:blip r:embed="rId2"/>
-          <a:stretch>
-            <a:fillRect/>
-          </a:stretch>
-        </p:blipFill>
-        <p:spPr>
-          <a:xfrm>
-            <a:off x="6675120" y="2019974"/>
-            <a:ext cx="4937760" cy="2818050"/>
-          </a:xfrm>
-          <a:prstGeom prst="rect">
-            <a:avLst/>
-          </a:prstGeom>
-        </p:spPr>
-      </p:pic>
-      <p:sp>
-        <p:nvSpPr>
-          <p:cNvPr id="6" name="TextBox 5"/>
+      <p:sp>
+        <p:nvSpPr>
+          <p:cNvPr id="5" name="TextBox 4"/>
           <p:cNvSpPr txBox="1"/>
           <p:nvPr/>
         </p:nvSpPr>
@@ -4907,7 +5066,7 @@
               </a:defRPr>
             </a:pPr>
             <a:r>
-              <a:t>1 / 17</a:t>
+              <a:t>1 / 20</a:t>
             </a:r>
           </a:p>
         </p:txBody>
@@ -5013,7 +5172,7 @@
               </a:defRPr>
             </a:pPr>
             <a:r>
-              <a:t>Station One: The Script</a:t>
+              <a:t>One Principle</a:t>
             </a:r>
           </a:p>
         </p:txBody>
@@ -5049,7 +5208,7 @@
               </a:defRPr>
             </a:pPr>
             <a:r>
-              <a:t>Iterate on the cheap words first</a:t>
+              <a:t>Stop at any station, change your mind in plain English — everything downstream updates</a:t>
             </a:r>
           </a:p>
         </p:txBody>
@@ -5085,7 +5244,7 @@
               </a:defRPr>
             </a:pPr>
             <a:r>
-              <a:t>10 / 17</a:t>
+              <a:t>10 / 20</a:t>
             </a:r>
           </a:p>
         </p:txBody>
@@ -5169,7 +5328,7 @@
         <p:spPr>
           <a:xfrm>
             <a:off x="822960" y="457200"/>
-            <a:ext cx="10424160" cy="1371600"/>
+            <a:ext cx="5577840" cy="1371600"/>
           </a:xfrm>
           <a:prstGeom prst="rect">
             <a:avLst/>
@@ -5191,7 +5350,7 @@
               </a:defRPr>
             </a:pPr>
             <a:r>
-              <a:t>Station Two: Slides</a:t>
+              <a:t>Station 1 — The Script</a:t>
             </a:r>
           </a:p>
         </p:txBody>
@@ -5205,7 +5364,7 @@
         <p:spPr>
           <a:xfrm>
             <a:off x="822960" y="1737360"/>
-            <a:ext cx="10424160" cy="4572000"/>
+            <a:ext cx="5577840" cy="4572000"/>
           </a:xfrm>
           <a:prstGeom prst="rect">
             <a:avLst/>
@@ -5230,7 +5389,7 @@
               </a:defRPr>
             </a:pPr>
             <a:r>
-              <a:t>•  Cards anchored to narration lines</a:t>
+              <a:t>•  Every line numbered, tagged by speaker</a:t>
             </a:r>
           </a:p>
           <a:p>
@@ -5246,7 +5405,7 @@
               </a:defRPr>
             </a:pPr>
             <a:r>
-              <a:t>•  Pulls real images from your source</a:t>
+              <a:t>•  Don't edit — describe the change</a:t>
             </a:r>
           </a:p>
           <a:p>
@@ -5262,30 +5421,38 @@
               </a:defRPr>
             </a:pPr>
             <a:r>
-              <a:t>•  Designs charts, timelines, diagrams</a:t>
-            </a:r>
-          </a:p>
-          <a:p>
-            <a:pPr>
-              <a:spcAft>
-                <a:spcPts val="1200"/>
-              </a:spcAft>
-              <a:defRPr sz="1800">
-                <a:solidFill>
-                  <a:srgbClr val="F2F0EB"/>
-                </a:solidFill>
-                <a:latin typeface="Helvetica Neue"/>
-              </a:defRPr>
-            </a:pPr>
-            <a:r>
-              <a:t>•  Asset Inventory maps every piece</a:t>
-            </a:r>
-          </a:p>
-        </p:txBody>
-      </p:sp>
-      <p:sp>
-        <p:nvSpPr>
-          <p:cNvPr id="5" name="TextBox 4"/>
+              <a:t>•  Each revision takes about a minute</a:t>
+            </a:r>
+          </a:p>
+        </p:txBody>
+      </p:sp>
+      <p:pic>
+        <p:nvPicPr>
+          <p:cNvPr id="5" name="Picture 4" descr="img_02.jpg"/>
+          <p:cNvPicPr>
+            <a:picLocks noChangeAspect="1"/>
+          </p:cNvPicPr>
+          <p:nvPr/>
+        </p:nvPicPr>
+        <p:blipFill>
+          <a:blip r:embed="rId2"/>
+          <a:stretch>
+            <a:fillRect/>
+          </a:stretch>
+        </p:blipFill>
+        <p:spPr>
+          <a:xfrm>
+            <a:off x="6675120" y="2019974"/>
+            <a:ext cx="4937760" cy="2818050"/>
+          </a:xfrm>
+          <a:prstGeom prst="rect">
+            <a:avLst/>
+          </a:prstGeom>
+        </p:spPr>
+      </p:pic>
+      <p:sp>
+        <p:nvSpPr>
+          <p:cNvPr id="6" name="TextBox 5"/>
           <p:cNvSpPr txBox="1"/>
           <p:nvPr/>
         </p:nvSpPr>
@@ -5314,7 +5481,7 @@
               </a:defRPr>
             </a:pPr>
             <a:r>
-              <a:t>11 / 17</a:t>
+              <a:t>11 / 20</a:t>
             </a:r>
           </a:p>
         </p:txBody>
@@ -5420,7 +5587,7 @@
               </a:defRPr>
             </a:pPr>
             <a:r>
-              <a:t>Bring Your Brand</a:t>
+              <a:t>Station 2 — The Slides</a:t>
             </a:r>
           </a:p>
         </p:txBody>
@@ -5459,7 +5626,7 @@
               </a:defRPr>
             </a:pPr>
             <a:r>
-              <a:t>•  Upload a template, style guide, or screenshot</a:t>
+              <a:t>•  One card per slide, anchored to a line</a:t>
             </a:r>
           </a:p>
           <a:p>
@@ -5475,7 +5642,7 @@
               </a:defRPr>
             </a:pPr>
             <a:r>
-              <a:t>•  Colors and fonts applied everywhere</a:t>
+              <a:t>•  Real images plus auto-designed figures</a:t>
             </a:r>
           </a:p>
           <a:p>
@@ -5491,14 +5658,14 @@
               </a:defRPr>
             </a:pPr>
             <a:r>
-              <a:t>•  Save once, reuse from a dropdown</a:t>
+              <a:t>•  Asset Inventory maps every asset</a:t>
             </a:r>
           </a:p>
         </p:txBody>
       </p:sp>
       <p:pic>
         <p:nvPicPr>
-          <p:cNvPr id="5" name="Picture 4" descr="img_04.jpg"/>
+          <p:cNvPr id="5" name="Picture 4" descr="img_03.jpg"/>
           <p:cNvPicPr>
             <a:picLocks noChangeAspect="1"/>
           </p:cNvPicPr>
@@ -5551,7 +5718,7 @@
               </a:defRPr>
             </a:pPr>
             <a:r>
-              <a:t>12 / 17</a:t>
+              <a:t>12 / 20</a:t>
             </a:r>
           </a:p>
         </p:txBody>
@@ -5635,7 +5802,7 @@
         <p:spPr>
           <a:xfrm>
             <a:off x="822960" y="457200"/>
-            <a:ext cx="10424160" cy="1371600"/>
+            <a:ext cx="5577840" cy="1371600"/>
           </a:xfrm>
           <a:prstGeom prst="rect">
             <a:avLst/>
@@ -5657,7 +5824,7 @@
               </a:defRPr>
             </a:pPr>
             <a:r>
-              <a:t>Station Three: The Voice</a:t>
+              <a:t>Bring Your Brand</a:t>
             </a:r>
           </a:p>
         </p:txBody>
@@ -5671,7 +5838,7 @@
         <p:spPr>
           <a:xfrm>
             <a:off x="822960" y="1737360"/>
-            <a:ext cx="10424160" cy="4572000"/>
+            <a:ext cx="5577840" cy="4572000"/>
           </a:xfrm>
           <a:prstGeom prst="rect">
             <a:avLst/>
@@ -5696,7 +5863,7 @@
               </a:defRPr>
             </a:pPr>
             <a:r>
-              <a:t>•  Synthesized line by line</a:t>
+              <a:t>•  Upload PPTX, style guide, or a screenshot</a:t>
             </a:r>
           </a:p>
           <a:p>
@@ -5712,7 +5879,7 @@
               </a:defRPr>
             </a:pPr>
             <a:r>
-              <a:t>•  Direct each line by number</a:t>
+              <a:t>•  Colors and fonts applied everywhere</a:t>
             </a:r>
           </a:p>
           <a:p>
@@ -5728,30 +5895,38 @@
               </a:defRPr>
             </a:pPr>
             <a:r>
-              <a:t>•  Fix pronunciation without changing spelling</a:t>
-            </a:r>
-          </a:p>
-          <a:p>
-            <a:pPr>
-              <a:spcAft>
-                <a:spcPts val="1200"/>
-              </a:spcAft>
-              <a:defRPr sz="1800">
-                <a:solidFill>
-                  <a:srgbClr val="F2F0EB"/>
-                </a:solidFill>
-                <a:latin typeface="Helvetica Neue"/>
-              </a:defRPr>
-            </a:pPr>
-            <a:r>
-              <a:t>•  Audio re-records automatically</a:t>
-            </a:r>
-          </a:p>
-        </p:txBody>
-      </p:sp>
-      <p:sp>
-        <p:nvSpPr>
-          <p:cNvPr id="5" name="TextBox 4"/>
+              <a:t>•  Save once, reuse from a dropdown</a:t>
+            </a:r>
+          </a:p>
+        </p:txBody>
+      </p:sp>
+      <p:pic>
+        <p:nvPicPr>
+          <p:cNvPr id="5" name="Picture 4" descr="img_04.jpg"/>
+          <p:cNvPicPr>
+            <a:picLocks noChangeAspect="1"/>
+          </p:cNvPicPr>
+          <p:nvPr/>
+        </p:nvPicPr>
+        <p:blipFill>
+          <a:blip r:embed="rId2"/>
+          <a:stretch>
+            <a:fillRect/>
+          </a:stretch>
+        </p:blipFill>
+        <p:spPr>
+          <a:xfrm>
+            <a:off x="6675120" y="2019974"/>
+            <a:ext cx="4937760" cy="2818050"/>
+          </a:xfrm>
+          <a:prstGeom prst="rect">
+            <a:avLst/>
+          </a:prstGeom>
+        </p:spPr>
+      </p:pic>
+      <p:sp>
+        <p:nvSpPr>
+          <p:cNvPr id="6" name="TextBox 5"/>
           <p:cNvSpPr txBox="1"/>
           <p:nvPr/>
         </p:nvSpPr>
@@ -5780,7 +5955,7 @@
               </a:defRPr>
             </a:pPr>
             <a:r>
-              <a:t>13 / 17</a:t>
+              <a:t>13 / 20</a:t>
             </a:r>
           </a:p>
         </p:txBody>
@@ -5864,7 +6039,7 @@
         <p:spPr>
           <a:xfrm>
             <a:off x="822960" y="457200"/>
-            <a:ext cx="5577840" cy="1371600"/>
+            <a:ext cx="10424160" cy="1371600"/>
           </a:xfrm>
           <a:prstGeom prst="rect">
             <a:avLst/>
@@ -5886,45 +6061,21 @@
               </a:defRPr>
             </a:pPr>
             <a:r>
-              <a:t>Review, Revise, Re-render</a:t>
-            </a:r>
-          </a:p>
-        </p:txBody>
-      </p:sp>
-      <p:pic>
-        <p:nvPicPr>
-          <p:cNvPr id="4" name="Picture 3" descr="figure_13.png"/>
-          <p:cNvPicPr>
-            <a:picLocks noChangeAspect="1"/>
-          </p:cNvPicPr>
-          <p:nvPr/>
-        </p:nvPicPr>
-        <p:blipFill>
-          <a:blip r:embed="rId2"/>
-          <a:stretch>
-            <a:fillRect/>
-          </a:stretch>
-        </p:blipFill>
-        <p:spPr>
-          <a:xfrm>
-            <a:off x="6675120" y="1898294"/>
-            <a:ext cx="4937760" cy="3061411"/>
-          </a:xfrm>
-          <a:prstGeom prst="rect">
-            <a:avLst/>
-          </a:prstGeom>
-        </p:spPr>
-      </p:pic>
-      <p:sp>
-        <p:nvSpPr>
-          <p:cNvPr id="5" name="TextBox 4"/>
+              <a:t>Station 3 — The Voice</a:t>
+            </a:r>
+          </a:p>
+        </p:txBody>
+      </p:sp>
+      <p:sp>
+        <p:nvSpPr>
+          <p:cNvPr id="4" name="TextBox 3"/>
           <p:cNvSpPr txBox="1"/>
           <p:nvPr/>
         </p:nvSpPr>
         <p:spPr>
           <a:xfrm>
-            <a:off x="10820095" y="6355080"/>
-            <a:ext cx="1005840" cy="365760"/>
+            <a:off x="822960" y="1737360"/>
+            <a:ext cx="10424160" cy="4572000"/>
           </a:xfrm>
           <a:prstGeom prst="rect">
             <a:avLst/>
@@ -5932,6 +6083,93 @@
           <a:noFill/>
         </p:spPr>
         <p:txBody>
+          <a:bodyPr wrap="square">
+            <a:spAutoFit/>
+          </a:bodyPr>
+          <a:lstStyle/>
+          <a:p>
+            <a:pPr>
+              <a:spcAft>
+                <a:spcPts val="1200"/>
+              </a:spcAft>
+              <a:defRPr sz="1800">
+                <a:solidFill>
+                  <a:srgbClr val="F2F0EB"/>
+                </a:solidFill>
+                <a:latin typeface="Helvetica Neue"/>
+              </a:defRPr>
+            </a:pPr>
+            <a:r>
+              <a:t>•  Every line directed individually</a:t>
+            </a:r>
+          </a:p>
+          <a:p>
+            <a:pPr>
+              <a:spcAft>
+                <a:spcPts val="1200"/>
+              </a:spcAft>
+              <a:defRPr sz="1800">
+                <a:solidFill>
+                  <a:srgbClr val="F2F0EB"/>
+                </a:solidFill>
+                <a:latin typeface="Helvetica Neue"/>
+              </a:defRPr>
+            </a:pPr>
+            <a:r>
+              <a:t>•  "Line 4: slow down, pause after the question"</a:t>
+            </a:r>
+          </a:p>
+          <a:p>
+            <a:pPr>
+              <a:spcAft>
+                <a:spcPts val="1200"/>
+              </a:spcAft>
+              <a:defRPr sz="1800">
+                <a:solidFill>
+                  <a:srgbClr val="F2F0EB"/>
+                </a:solidFill>
+                <a:latin typeface="Helvetica Neue"/>
+              </a:defRPr>
+            </a:pPr>
+            <a:r>
+              <a:t>•  Fix pronunciations; spelling stays correct</a:t>
+            </a:r>
+          </a:p>
+          <a:p>
+            <a:pPr>
+              <a:spcAft>
+                <a:spcPts val="1200"/>
+              </a:spcAft>
+              <a:defRPr sz="1800">
+                <a:solidFill>
+                  <a:srgbClr val="F2F0EB"/>
+                </a:solidFill>
+                <a:latin typeface="Helvetica Neue"/>
+              </a:defRPr>
+            </a:pPr>
+            <a:r>
+              <a:t>•  Audio re-records automatically</a:t>
+            </a:r>
+          </a:p>
+        </p:txBody>
+      </p:sp>
+      <p:sp>
+        <p:nvSpPr>
+          <p:cNvPr id="5" name="TextBox 4"/>
+          <p:cNvSpPr txBox="1"/>
+          <p:nvPr/>
+        </p:nvSpPr>
+        <p:spPr>
+          <a:xfrm>
+            <a:off x="10820095" y="6355080"/>
+            <a:ext cx="1005840" cy="365760"/>
+          </a:xfrm>
+          <a:prstGeom prst="rect">
+            <a:avLst/>
+          </a:prstGeom>
+          <a:noFill/>
+        </p:spPr>
+        <p:txBody>
           <a:bodyPr wrap="none">
             <a:spAutoFit/>
           </a:bodyPr>
@@ -5946,7 +6184,7 @@
               </a:defRPr>
             </a:pPr>
             <a:r>
-              <a:t>14 / 17</a:t>
+              <a:t>14 / 20</a:t>
             </a:r>
           </a:p>
         </p:txBody>
@@ -6052,14 +6290,85 @@
               </a:defRPr>
             </a:pPr>
             <a:r>
-              <a:t>Which Output Do I Need?</a:t>
+              <a:t>Review Slide by Slide</a:t>
+            </a:r>
+          </a:p>
+        </p:txBody>
+      </p:sp>
+      <p:sp>
+        <p:nvSpPr>
+          <p:cNvPr id="4" name="TextBox 3"/>
+          <p:cNvSpPr txBox="1"/>
+          <p:nvPr/>
+        </p:nvSpPr>
+        <p:spPr>
+          <a:xfrm>
+            <a:off x="822960" y="1737360"/>
+            <a:ext cx="5577840" cy="4572000"/>
+          </a:xfrm>
+          <a:prstGeom prst="rect">
+            <a:avLst/>
+          </a:prstGeom>
+          <a:noFill/>
+        </p:spPr>
+        <p:txBody>
+          <a:bodyPr wrap="square">
+            <a:spAutoFit/>
+          </a:bodyPr>
+          <a:lstStyle/>
+          <a:p>
+            <a:pPr>
+              <a:spcAft>
+                <a:spcPts val="1200"/>
+              </a:spcAft>
+              <a:defRPr sz="1800">
+                <a:solidFill>
+                  <a:srgbClr val="F2F0EB"/>
+                </a:solidFill>
+                <a:latin typeface="Helvetica Neue"/>
+              </a:defRPr>
+            </a:pPr>
+            <a:r>
+              <a:t>•  Play button on each slide card</a:t>
+            </a:r>
+          </a:p>
+          <a:p>
+            <a:pPr>
+              <a:spcAft>
+                <a:spcPts val="1200"/>
+              </a:spcAft>
+              <a:defRPr sz="1800">
+                <a:solidFill>
+                  <a:srgbClr val="F2F0EB"/>
+                </a:solidFill>
+                <a:latin typeface="Helvetica Neue"/>
+              </a:defRPr>
+            </a:pPr>
+            <a:r>
+              <a:t>•  Plays just that slide's narration</a:t>
+            </a:r>
+          </a:p>
+          <a:p>
+            <a:pPr>
+              <a:spcAft>
+                <a:spcPts val="1200"/>
+              </a:spcAft>
+              <a:defRPr sz="1800">
+                <a:solidFill>
+                  <a:srgbClr val="F2F0EB"/>
+                </a:solidFill>
+                <a:latin typeface="Helvetica Neue"/>
+              </a:defRPr>
+            </a:pPr>
+            <a:r>
+              <a:t>•  Step through or switch on auto-advance</a:t>
             </a:r>
           </a:p>
         </p:txBody>
       </p:sp>
       <p:pic>
         <p:nvPicPr>
-          <p:cNvPr id="4" name="Picture 3" descr="figure_14.png"/>
+          <p:cNvPr id="5" name="Picture 4" descr="img_05.jpg"/>
           <p:cNvPicPr>
             <a:picLocks noChangeAspect="1"/>
           </p:cNvPicPr>
@@ -6073,8 +6382,8 @@
         </p:blipFill>
         <p:spPr>
           <a:xfrm>
-            <a:off x="6675120" y="1898294"/>
-            <a:ext cx="4937760" cy="3061411"/>
+            <a:off x="6675120" y="2019974"/>
+            <a:ext cx="4937760" cy="2818050"/>
           </a:xfrm>
           <a:prstGeom prst="rect">
             <a:avLst/>
@@ -6083,7 +6392,7 @@
       </p:pic>
       <p:sp>
         <p:nvSpPr>
-          <p:cNvPr id="5" name="TextBox 4"/>
+          <p:cNvPr id="6" name="TextBox 5"/>
           <p:cNvSpPr txBox="1"/>
           <p:nvPr/>
         </p:nvSpPr>
@@ -6112,7 +6421,7 @@
               </a:defRPr>
             </a:pPr>
             <a:r>
-              <a:t>15 / 17</a:t>
+              <a:t>15 / 20</a:t>
             </a:r>
           </a:p>
         </p:txBody>
@@ -6196,7 +6505,7 @@
         <p:spPr>
           <a:xfrm>
             <a:off x="822960" y="457200"/>
-            <a:ext cx="10424160" cy="1371600"/>
+            <a:ext cx="5577840" cy="1371600"/>
           </a:xfrm>
           <a:prstGeom prst="rect">
             <a:avLst/>
@@ -6218,7 +6527,7 @@
               </a:defRPr>
             </a:pPr>
             <a:r>
-              <a:t>The Zero-to-Hero Path</a:t>
+              <a:t>Review, Revise, Re-render</a:t>
             </a:r>
           </a:p>
         </p:txBody>
@@ -6232,7 +6541,7 @@
         <p:spPr>
           <a:xfrm>
             <a:off x="822960" y="1737360"/>
-            <a:ext cx="10424160" cy="4572000"/>
+            <a:ext cx="5577840" cy="4572000"/>
           </a:xfrm>
           <a:prstGeom prst="rect">
             <a:avLst/>
@@ -6257,7 +6566,7 @@
               </a:defRPr>
             </a:pPr>
             <a:r>
-              <a:t>•  Generate to Script Draft</a:t>
+              <a:t>•  Offset field nudges timing in seconds</a:t>
             </a:r>
           </a:p>
           <a:p>
@@ -6273,62 +6582,38 @@
               </a:defRPr>
             </a:pPr>
             <a:r>
-              <a:t>•  Revise the words in plain English</a:t>
-            </a:r>
-          </a:p>
-          <a:p>
-            <a:pPr>
-              <a:spcAft>
-                <a:spcPts val="1200"/>
-              </a:spcAft>
-              <a:defRPr sz="1800">
-                <a:solidFill>
-                  <a:srgbClr val="F2F0EB"/>
-                </a:solidFill>
-                <a:latin typeface="Helvetica Neue"/>
-              </a:defRPr>
-            </a:pPr>
-            <a:r>
-              <a:t>•  Create and shape the slides</a:t>
-            </a:r>
-          </a:p>
-          <a:p>
-            <a:pPr>
-              <a:spcAft>
-                <a:spcPts val="1200"/>
-              </a:spcAft>
-              <a:defRPr sz="1800">
-                <a:solidFill>
-                  <a:srgbClr val="F2F0EB"/>
-                </a:solidFill>
-                <a:latin typeface="Helvetica Neue"/>
-              </a:defRPr>
-            </a:pPr>
-            <a:r>
-              <a:t>•  Render, review, fix pacing &amp; timing</a:t>
-            </a:r>
-          </a:p>
-          <a:p>
-            <a:pPr>
-              <a:spcAft>
-                <a:spcPts val="1200"/>
-              </a:spcAft>
-              <a:defRPr sz="1800">
-                <a:solidFill>
-                  <a:srgbClr val="F2F0EB"/>
-                </a:solidFill>
-                <a:latin typeface="Helvetica Neue"/>
-              </a:defRPr>
-            </a:pPr>
-            <a:r>
-              <a:t>•  Collect your outputs — no editing tools</a:t>
-            </a:r>
-          </a:p>
-        </p:txBody>
-      </p:sp>
-      <p:sp>
-        <p:nvSpPr>
-          <p:cNvPr id="5" name="TextBox 4"/>
+              <a:t>•  The audio is never touched</a:t>
+            </a:r>
+          </a:p>
+        </p:txBody>
+      </p:sp>
+      <p:pic>
+        <p:nvPicPr>
+          <p:cNvPr id="5" name="Picture 4" descr="figure_15.png"/>
+          <p:cNvPicPr>
+            <a:picLocks noChangeAspect="1"/>
+          </p:cNvPicPr>
+          <p:nvPr/>
+        </p:nvPicPr>
+        <p:blipFill>
+          <a:blip r:embed="rId2"/>
+          <a:stretch>
+            <a:fillRect/>
+          </a:stretch>
+        </p:blipFill>
+        <p:spPr>
+          <a:xfrm>
+            <a:off x="6675120" y="1898294"/>
+            <a:ext cx="4937760" cy="3061411"/>
+          </a:xfrm>
+          <a:prstGeom prst="rect">
+            <a:avLst/>
+          </a:prstGeom>
+        </p:spPr>
+      </p:pic>
+      <p:sp>
+        <p:nvSpPr>
+          <p:cNvPr id="6" name="TextBox 5"/>
           <p:cNvSpPr txBox="1"/>
           <p:nvPr/>
         </p:nvSpPr>
@@ -6357,7 +6642,7 @@
               </a:defRPr>
             </a:pPr>
             <a:r>
-              <a:t>16 / 17</a:t>
+              <a:t>16 / 20</a:t>
             </a:r>
           </a:p>
         </p:txBody>
@@ -6441,7 +6726,7 @@
         <p:spPr>
           <a:xfrm>
             <a:off x="822960" y="457200"/>
-            <a:ext cx="10424160" cy="1371600"/>
+            <a:ext cx="5577840" cy="1371600"/>
           </a:xfrm>
           <a:prstGeom prst="rect">
             <a:avLst/>
@@ -6463,7 +6748,7 @@
               </a:defRPr>
             </a:pPr>
             <a:r>
-              <a:t>Welcome to Fluent Agents Studio</a:t>
+              <a:t>Station 4 — The Outputs</a:t>
             </a:r>
           </a:p>
         </p:txBody>
@@ -6477,7 +6762,7 @@
         <p:spPr>
           <a:xfrm>
             <a:off x="822960" y="1737360"/>
-            <a:ext cx="10424160" cy="1645920"/>
+            <a:ext cx="5577840" cy="4572000"/>
           </a:xfrm>
           <a:prstGeom prst="rect">
             <a:avLst/>
@@ -6491,22 +6776,81 @@
           <a:lstStyle/>
           <a:p>
             <a:pPr>
-              <a:defRPr sz="2000" i="1">
-                <a:solidFill>
-                  <a:srgbClr val="9AA0AB"/>
+              <a:spcAft>
+                <a:spcPts val="1200"/>
+              </a:spcAft>
+              <a:defRPr sz="1800">
+                <a:solidFill>
+                  <a:srgbClr val="F2F0EB"/>
                 </a:solidFill>
                 <a:latin typeface="Helvetica Neue"/>
               </a:defRPr>
             </a:pPr>
             <a:r>
-              <a:t>Your first production is one pasted link away</a:t>
-            </a:r>
-          </a:p>
-        </p:txBody>
-      </p:sp>
-      <p:sp>
-        <p:nvSpPr>
-          <p:cNvPr id="5" name="TextBox 4"/>
+              <a:t>•  Render assembles from your latest work</a:t>
+            </a:r>
+          </a:p>
+          <a:p>
+            <a:pPr>
+              <a:spcAft>
+                <a:spcPts val="1200"/>
+              </a:spcAft>
+              <a:defRPr sz="1800">
+                <a:solidFill>
+                  <a:srgbClr val="F2F0EB"/>
+                </a:solidFill>
+                <a:latin typeface="Helvetica Neue"/>
+              </a:defRPr>
+            </a:pPr>
+            <a:r>
+              <a:t>•  MP3, transcript, slideshow, video, PPTX</a:t>
+            </a:r>
+          </a:p>
+          <a:p>
+            <a:pPr>
+              <a:spcAft>
+                <a:spcPts val="1200"/>
+              </a:spcAft>
+              <a:defRPr sz="1800">
+                <a:solidFill>
+                  <a:srgbClr val="F2F0EB"/>
+                </a:solidFill>
+                <a:latin typeface="Helvetica Neue"/>
+              </a:defRPr>
+            </a:pPr>
+            <a:r>
+              <a:t>•  Slideshow emails with audio built in</a:t>
+            </a:r>
+          </a:p>
+        </p:txBody>
+      </p:sp>
+      <p:pic>
+        <p:nvPicPr>
+          <p:cNvPr id="5" name="Picture 4" descr="img_06.jpg"/>
+          <p:cNvPicPr>
+            <a:picLocks noChangeAspect="1"/>
+          </p:cNvPicPr>
+          <p:nvPr/>
+        </p:nvPicPr>
+        <p:blipFill>
+          <a:blip r:embed="rId2"/>
+          <a:stretch>
+            <a:fillRect/>
+          </a:stretch>
+        </p:blipFill>
+        <p:spPr>
+          <a:xfrm>
+            <a:off x="6675120" y="2019974"/>
+            <a:ext cx="4937760" cy="2818050"/>
+          </a:xfrm>
+          <a:prstGeom prst="rect">
+            <a:avLst/>
+          </a:prstGeom>
+        </p:spPr>
+      </p:pic>
+      <p:sp>
+        <p:nvSpPr>
+          <p:cNvPr id="6" name="TextBox 5"/>
           <p:cNvSpPr txBox="1"/>
           <p:nvPr/>
         </p:nvSpPr>
@@ -6535,7 +6879,481 @@
               </a:defRPr>
             </a:pPr>
             <a:r>
-              <a:t>17 / 17</a:t>
+              <a:t>17 / 20</a:t>
+            </a:r>
+          </a:p>
+        </p:txBody>
+      </p:sp>
+    </p:spTree>
+  </p:cSld>
+  <p:clrMapOvr>
+    <a:masterClrMapping/>
+  </p:clrMapOvr>
+</p:sld>
+</file>
+
+<file path=ppt/slides/slide18.xml><?xml version="1.0" encoding="utf-8"?>
+<p:sld xmlns:a="http://schemas.openxmlformats.org/drawingml/2006/main" xmlns:p="http://schemas.openxmlformats.org/presentationml/2006/main" xmlns:r="http://schemas.openxmlformats.org/officeDocument/2006/relationships">
+  <p:cSld>
+    <p:bg>
+      <p:bgPr>
+        <a:solidFill>
+          <a:srgbClr val="1E222A"/>
+        </a:solidFill>
+        <a:effectLst/>
+      </p:bgPr>
+    </p:bg>
+    <p:spTree>
+      <p:nvGrpSpPr>
+        <p:cNvPr id="1" name=""/>
+        <p:cNvGrpSpPr/>
+        <p:nvPr/>
+      </p:nvGrpSpPr>
+      <p:grpSpPr/>
+      <p:sp>
+        <p:nvSpPr>
+          <p:cNvPr id="2" name="Rectangle 1"/>
+          <p:cNvSpPr/>
+          <p:nvPr/>
+        </p:nvSpPr>
+        <p:spPr>
+          <a:xfrm>
+            <a:off x="0" y="0"/>
+            <a:ext cx="91440" cy="6858000"/>
+          </a:xfrm>
+          <a:prstGeom prst="rect">
+            <a:avLst/>
+          </a:prstGeom>
+          <a:solidFill>
+            <a:srgbClr val="E8A13C"/>
+          </a:solidFill>
+          <a:ln>
+            <a:noFill/>
+          </a:ln>
+          <a:effectLst/>
+        </p:spPr>
+        <p:style>
+          <a:lnRef idx="1">
+            <a:schemeClr val="accent1"/>
+          </a:lnRef>
+          <a:fillRef idx="3">
+            <a:schemeClr val="accent1"/>
+          </a:fillRef>
+          <a:effectRef idx="2">
+            <a:schemeClr val="accent1"/>
+          </a:effectRef>
+          <a:fontRef idx="minor">
+            <a:schemeClr val="lt1"/>
+          </a:fontRef>
+        </p:style>
+        <p:txBody>
+          <a:bodyPr rtlCol="0" anchor="ctr"/>
+          <a:lstStyle/>
+          <a:p>
+            <a:pPr algn="ctr"/>
+          </a:p>
+        </p:txBody>
+      </p:sp>
+      <p:sp>
+        <p:nvSpPr>
+          <p:cNvPr id="3" name="TextBox 2"/>
+          <p:cNvSpPr txBox="1"/>
+          <p:nvPr/>
+        </p:nvSpPr>
+        <p:spPr>
+          <a:xfrm>
+            <a:off x="822960" y="457200"/>
+            <a:ext cx="10424160" cy="1371600"/>
+          </a:xfrm>
+          <a:prstGeom prst="rect">
+            <a:avLst/>
+          </a:prstGeom>
+          <a:noFill/>
+        </p:spPr>
+        <p:txBody>
+          <a:bodyPr wrap="square">
+            <a:spAutoFit/>
+          </a:bodyPr>
+          <a:lstStyle/>
+          <a:p>
+            <a:pPr>
+              <a:defRPr sz="3000" b="1">
+                <a:solidFill>
+                  <a:srgbClr val="F2F0EB"/>
+                </a:solidFill>
+                <a:latin typeface="Helvetica Neue"/>
+              </a:defRPr>
+            </a:pPr>
+            <a:r>
+              <a:t>A Word About Cost</a:t>
+            </a:r>
+          </a:p>
+        </p:txBody>
+      </p:sp>
+      <p:sp>
+        <p:nvSpPr>
+          <p:cNvPr id="4" name="TextBox 3"/>
+          <p:cNvSpPr txBox="1"/>
+          <p:nvPr/>
+        </p:nvSpPr>
+        <p:spPr>
+          <a:xfrm>
+            <a:off x="822960" y="1737360"/>
+            <a:ext cx="10424160" cy="4572000"/>
+          </a:xfrm>
+          <a:prstGeom prst="rect">
+            <a:avLst/>
+          </a:prstGeom>
+          <a:noFill/>
+        </p:spPr>
+        <p:txBody>
+          <a:bodyPr wrap="square">
+            <a:spAutoFit/>
+          </a:bodyPr>
+          <a:lstStyle/>
+          <a:p>
+            <a:pPr>
+              <a:spcAft>
+                <a:spcPts val="1200"/>
+              </a:spcAft>
+              <a:defRPr sz="1800">
+                <a:solidFill>
+                  <a:srgbClr val="F2F0EB"/>
+                </a:solidFill>
+                <a:latin typeface="Helvetica Neue"/>
+              </a:defRPr>
+            </a:pPr>
+            <a:r>
+              <a:t>•  Running spend shown in a header chip</a:t>
+            </a:r>
+          </a:p>
+          <a:p>
+            <a:pPr>
+              <a:spcAft>
+                <a:spcPts val="1200"/>
+              </a:spcAft>
+              <a:defRPr sz="1800">
+                <a:solidFill>
+                  <a:srgbClr val="F2F0EB"/>
+                </a:solidFill>
+                <a:latin typeface="Helvetica Neue"/>
+              </a:defRPr>
+            </a:pPr>
+            <a:r>
+              <a:t>•  Usually well under a dollar per production</a:t>
+            </a:r>
+          </a:p>
+          <a:p>
+            <a:pPr>
+              <a:spcAft>
+                <a:spcPts val="1200"/>
+              </a:spcAft>
+              <a:defRPr sz="1800">
+                <a:solidFill>
+                  <a:srgbClr val="F2F0EB"/>
+                </a:solidFill>
+                <a:latin typeface="Helvetica Neue"/>
+              </a:defRPr>
+            </a:pPr>
+            <a:r>
+              <a:t>•  Repeat revisions billed ~one-tenth price</a:t>
+            </a:r>
+          </a:p>
+          <a:p>
+            <a:pPr>
+              <a:spcAft>
+                <a:spcPts val="1200"/>
+              </a:spcAft>
+              <a:defRPr sz="1800">
+                <a:solidFill>
+                  <a:srgbClr val="F2F0EB"/>
+                </a:solidFill>
+                <a:latin typeface="Helvetica Neue"/>
+              </a:defRPr>
+            </a:pPr>
+            <a:r>
+              <a:t>•  Revise in focused bursts</a:t>
+            </a:r>
+          </a:p>
+        </p:txBody>
+      </p:sp>
+      <p:sp>
+        <p:nvSpPr>
+          <p:cNvPr id="5" name="TextBox 4"/>
+          <p:cNvSpPr txBox="1"/>
+          <p:nvPr/>
+        </p:nvSpPr>
+        <p:spPr>
+          <a:xfrm>
+            <a:off x="10820095" y="6355080"/>
+            <a:ext cx="1005840" cy="365760"/>
+          </a:xfrm>
+          <a:prstGeom prst="rect">
+            <a:avLst/>
+          </a:prstGeom>
+          <a:noFill/>
+        </p:spPr>
+        <p:txBody>
+          <a:bodyPr wrap="none">
+            <a:spAutoFit/>
+          </a:bodyPr>
+          <a:lstStyle/>
+          <a:p>
+            <a:pPr algn="r">
+              <a:defRPr sz="1200">
+                <a:solidFill>
+                  <a:srgbClr val="9AA0AB"/>
+                </a:solidFill>
+                <a:latin typeface="Helvetica Neue"/>
+              </a:defRPr>
+            </a:pPr>
+            <a:r>
+              <a:t>18 / 20</a:t>
+            </a:r>
+          </a:p>
+        </p:txBody>
+      </p:sp>
+    </p:spTree>
+  </p:cSld>
+  <p:clrMapOvr>
+    <a:masterClrMapping/>
+  </p:clrMapOvr>
+</p:sld>
+</file>
+
+<file path=ppt/slides/slide19.xml><?xml version="1.0" encoding="utf-8"?>
+<p:sld xmlns:a="http://schemas.openxmlformats.org/drawingml/2006/main" xmlns:p="http://schemas.openxmlformats.org/presentationml/2006/main" xmlns:r="http://schemas.openxmlformats.org/officeDocument/2006/relationships">
+  <p:cSld>
+    <p:bg>
+      <p:bgPr>
+        <a:solidFill>
+          <a:srgbClr val="1E222A"/>
+        </a:solidFill>
+        <a:effectLst/>
+      </p:bgPr>
+    </p:bg>
+    <p:spTree>
+      <p:nvGrpSpPr>
+        <p:cNvPr id="1" name=""/>
+        <p:cNvGrpSpPr/>
+        <p:nvPr/>
+      </p:nvGrpSpPr>
+      <p:grpSpPr/>
+      <p:sp>
+        <p:nvSpPr>
+          <p:cNvPr id="2" name="Rectangle 1"/>
+          <p:cNvSpPr/>
+          <p:nvPr/>
+        </p:nvSpPr>
+        <p:spPr>
+          <a:xfrm>
+            <a:off x="0" y="0"/>
+            <a:ext cx="91440" cy="6858000"/>
+          </a:xfrm>
+          <a:prstGeom prst="rect">
+            <a:avLst/>
+          </a:prstGeom>
+          <a:solidFill>
+            <a:srgbClr val="E8A13C"/>
+          </a:solidFill>
+          <a:ln>
+            <a:noFill/>
+          </a:ln>
+          <a:effectLst/>
+        </p:spPr>
+        <p:style>
+          <a:lnRef idx="1">
+            <a:schemeClr val="accent1"/>
+          </a:lnRef>
+          <a:fillRef idx="3">
+            <a:schemeClr val="accent1"/>
+          </a:fillRef>
+          <a:effectRef idx="2">
+            <a:schemeClr val="accent1"/>
+          </a:effectRef>
+          <a:fontRef idx="minor">
+            <a:schemeClr val="lt1"/>
+          </a:fontRef>
+        </p:style>
+        <p:txBody>
+          <a:bodyPr rtlCol="0" anchor="ctr"/>
+          <a:lstStyle/>
+          <a:p>
+            <a:pPr algn="ctr"/>
+          </a:p>
+        </p:txBody>
+      </p:sp>
+      <p:sp>
+        <p:nvSpPr>
+          <p:cNvPr id="3" name="TextBox 2"/>
+          <p:cNvSpPr txBox="1"/>
+          <p:nvPr/>
+        </p:nvSpPr>
+        <p:spPr>
+          <a:xfrm>
+            <a:off x="822960" y="457200"/>
+            <a:ext cx="10424160" cy="1371600"/>
+          </a:xfrm>
+          <a:prstGeom prst="rect">
+            <a:avLst/>
+          </a:prstGeom>
+          <a:noFill/>
+        </p:spPr>
+        <p:txBody>
+          <a:bodyPr wrap="square">
+            <a:spAutoFit/>
+          </a:bodyPr>
+          <a:lstStyle/>
+          <a:p>
+            <a:pPr>
+              <a:defRPr sz="3000" b="1">
+                <a:solidFill>
+                  <a:srgbClr val="F2F0EB"/>
+                </a:solidFill>
+                <a:latin typeface="Helvetica Neue"/>
+              </a:defRPr>
+            </a:pPr>
+            <a:r>
+              <a:t>The Zero-to-Hero Path</a:t>
+            </a:r>
+          </a:p>
+        </p:txBody>
+      </p:sp>
+      <p:sp>
+        <p:nvSpPr>
+          <p:cNvPr id="4" name="TextBox 3"/>
+          <p:cNvSpPr txBox="1"/>
+          <p:nvPr/>
+        </p:nvSpPr>
+        <p:spPr>
+          <a:xfrm>
+            <a:off x="822960" y="1737360"/>
+            <a:ext cx="10424160" cy="4572000"/>
+          </a:xfrm>
+          <a:prstGeom prst="rect">
+            <a:avLst/>
+          </a:prstGeom>
+          <a:noFill/>
+        </p:spPr>
+        <p:txBody>
+          <a:bodyPr wrap="square">
+            <a:spAutoFit/>
+          </a:bodyPr>
+          <a:lstStyle/>
+          <a:p>
+            <a:pPr>
+              <a:spcAft>
+                <a:spcPts val="1200"/>
+              </a:spcAft>
+              <a:defRPr sz="1800">
+                <a:solidFill>
+                  <a:srgbClr val="F2F0EB"/>
+                </a:solidFill>
+                <a:latin typeface="Helvetica Neue"/>
+              </a:defRPr>
+            </a:pPr>
+            <a:r>
+              <a:t>•  1. Source + mode + audience → script</a:t>
+            </a:r>
+          </a:p>
+          <a:p>
+            <a:pPr>
+              <a:spcAft>
+                <a:spcPts val="1200"/>
+              </a:spcAft>
+              <a:defRPr sz="1800">
+                <a:solidFill>
+                  <a:srgbClr val="F2F0EB"/>
+                </a:solidFill>
+                <a:latin typeface="Helvetica Neue"/>
+              </a:defRPr>
+            </a:pPr>
+            <a:r>
+              <a:t>•  2. Revise the script in plain English</a:t>
+            </a:r>
+          </a:p>
+          <a:p>
+            <a:pPr>
+              <a:spcAft>
+                <a:spcPts val="1200"/>
+              </a:spcAft>
+              <a:defRPr sz="1800">
+                <a:solidFill>
+                  <a:srgbClr val="F2F0EB"/>
+                </a:solidFill>
+                <a:latin typeface="Helvetica Neue"/>
+              </a:defRPr>
+            </a:pPr>
+            <a:r>
+              <a:t>•  3. Create and shape the slides</a:t>
+            </a:r>
+          </a:p>
+          <a:p>
+            <a:pPr>
+              <a:spcAft>
+                <a:spcPts val="1200"/>
+              </a:spcAft>
+              <a:defRPr sz="1800">
+                <a:solidFill>
+                  <a:srgbClr val="F2F0EB"/>
+                </a:solidFill>
+                <a:latin typeface="Helvetica Neue"/>
+              </a:defRPr>
+            </a:pPr>
+            <a:r>
+              <a:t>•  4. Render, then review with play buttons</a:t>
+            </a:r>
+          </a:p>
+          <a:p>
+            <a:pPr>
+              <a:spcAft>
+                <a:spcPts val="1200"/>
+              </a:spcAft>
+              <a:defRPr sz="1800">
+                <a:solidFill>
+                  <a:srgbClr val="F2F0EB"/>
+                </a:solidFill>
+                <a:latin typeface="Helvetica Neue"/>
+              </a:defRPr>
+            </a:pPr>
+            <a:r>
+              <a:t>•  5. Fix voice, nudge timing, collect outputs</a:t>
+            </a:r>
+          </a:p>
+        </p:txBody>
+      </p:sp>
+      <p:sp>
+        <p:nvSpPr>
+          <p:cNvPr id="5" name="TextBox 4"/>
+          <p:cNvSpPr txBox="1"/>
+          <p:nvPr/>
+        </p:nvSpPr>
+        <p:spPr>
+          <a:xfrm>
+            <a:off x="10820095" y="6355080"/>
+            <a:ext cx="1005840" cy="365760"/>
+          </a:xfrm>
+          <a:prstGeom prst="rect">
+            <a:avLst/>
+          </a:prstGeom>
+          <a:noFill/>
+        </p:spPr>
+        <p:txBody>
+          <a:bodyPr wrap="none">
+            <a:spAutoFit/>
+          </a:bodyPr>
+          <a:lstStyle/>
+          <a:p>
+            <a:pPr algn="r">
+              <a:defRPr sz="1200">
+                <a:solidFill>
+                  <a:srgbClr val="9AA0AB"/>
+                </a:solidFill>
+                <a:latin typeface="Helvetica Neue"/>
+              </a:defRPr>
+            </a:pPr>
+            <a:r>
+              <a:t>19 / 20</a:t>
             </a:r>
           </a:p>
         </p:txBody>
@@ -6641,7 +7459,7 @@
               </a:defRPr>
             </a:pPr>
             <a:r>
-              <a:t>The Big Idea in One Breath</a:t>
+              <a:t>The Idea in One Breath</a:t>
             </a:r>
           </a:p>
         </p:txBody>
@@ -6680,7 +7498,7 @@
               </a:defRPr>
             </a:pPr>
             <a:r>
-              <a:t>•  Give it a link or PDF to read</a:t>
+              <a:t>•  Give it an article link or a PDF</a:t>
             </a:r>
           </a:p>
           <a:p>
@@ -6712,7 +7530,7 @@
               </a:defRPr>
             </a:pPr>
             <a:r>
-              <a:t>•  You get audio, slideshow, video, PowerPoint</a:t>
+              <a:t>•  Get audio, slideshow, video, PowerPoint</a:t>
             </a:r>
           </a:p>
           <a:p>
@@ -6728,7 +7546,7 @@
               </a:defRPr>
             </a:pPr>
             <a:r>
-              <a:t>•  You direct — the studio produces</a:t>
+              <a:t>•  You direct; the studio produces</a:t>
             </a:r>
           </a:p>
         </p:txBody>
@@ -6764,7 +7582,185 @@
               </a:defRPr>
             </a:pPr>
             <a:r>
-              <a:t>2 / 17</a:t>
+              <a:t>2 / 20</a:t>
+            </a:r>
+          </a:p>
+        </p:txBody>
+      </p:sp>
+    </p:spTree>
+  </p:cSld>
+  <p:clrMapOvr>
+    <a:masterClrMapping/>
+  </p:clrMapOvr>
+</p:sld>
+</file>
+
+<file path=ppt/slides/slide20.xml><?xml version="1.0" encoding="utf-8"?>
+<p:sld xmlns:a="http://schemas.openxmlformats.org/drawingml/2006/main" xmlns:p="http://schemas.openxmlformats.org/presentationml/2006/main" xmlns:r="http://schemas.openxmlformats.org/officeDocument/2006/relationships">
+  <p:cSld>
+    <p:bg>
+      <p:bgPr>
+        <a:solidFill>
+          <a:srgbClr val="1E222A"/>
+        </a:solidFill>
+        <a:effectLst/>
+      </p:bgPr>
+    </p:bg>
+    <p:spTree>
+      <p:nvGrpSpPr>
+        <p:cNvPr id="1" name=""/>
+        <p:cNvGrpSpPr/>
+        <p:nvPr/>
+      </p:nvGrpSpPr>
+      <p:grpSpPr/>
+      <p:sp>
+        <p:nvSpPr>
+          <p:cNvPr id="2" name="Rectangle 1"/>
+          <p:cNvSpPr/>
+          <p:nvPr/>
+        </p:nvSpPr>
+        <p:spPr>
+          <a:xfrm>
+            <a:off x="0" y="0"/>
+            <a:ext cx="91440" cy="6858000"/>
+          </a:xfrm>
+          <a:prstGeom prst="rect">
+            <a:avLst/>
+          </a:prstGeom>
+          <a:solidFill>
+            <a:srgbClr val="E8A13C"/>
+          </a:solidFill>
+          <a:ln>
+            <a:noFill/>
+          </a:ln>
+          <a:effectLst/>
+        </p:spPr>
+        <p:style>
+          <a:lnRef idx="1">
+            <a:schemeClr val="accent1"/>
+          </a:lnRef>
+          <a:fillRef idx="3">
+            <a:schemeClr val="accent1"/>
+          </a:fillRef>
+          <a:effectRef idx="2">
+            <a:schemeClr val="accent1"/>
+          </a:effectRef>
+          <a:fontRef idx="minor">
+            <a:schemeClr val="lt1"/>
+          </a:fontRef>
+        </p:style>
+        <p:txBody>
+          <a:bodyPr rtlCol="0" anchor="ctr"/>
+          <a:lstStyle/>
+          <a:p>
+            <a:pPr algn="ctr"/>
+          </a:p>
+        </p:txBody>
+      </p:sp>
+      <p:sp>
+        <p:nvSpPr>
+          <p:cNvPr id="3" name="TextBox 2"/>
+          <p:cNvSpPr txBox="1"/>
+          <p:nvPr/>
+        </p:nvSpPr>
+        <p:spPr>
+          <a:xfrm>
+            <a:off x="822960" y="457200"/>
+            <a:ext cx="10424160" cy="1371600"/>
+          </a:xfrm>
+          <a:prstGeom prst="rect">
+            <a:avLst/>
+          </a:prstGeom>
+          <a:noFill/>
+        </p:spPr>
+        <p:txBody>
+          <a:bodyPr wrap="square">
+            <a:spAutoFit/>
+          </a:bodyPr>
+          <a:lstStyle/>
+          <a:p>
+            <a:pPr>
+              <a:defRPr sz="3000" b="1">
+                <a:solidFill>
+                  <a:srgbClr val="F2F0EB"/>
+                </a:solidFill>
+                <a:latin typeface="Helvetica Neue"/>
+              </a:defRPr>
+            </a:pPr>
+            <a:r>
+              <a:t>Welcome to Fluent Agents Studio</a:t>
+            </a:r>
+          </a:p>
+        </p:txBody>
+      </p:sp>
+      <p:sp>
+        <p:nvSpPr>
+          <p:cNvPr id="4" name="TextBox 3"/>
+          <p:cNvSpPr txBox="1"/>
+          <p:nvPr/>
+        </p:nvSpPr>
+        <p:spPr>
+          <a:xfrm>
+            <a:off x="822960" y="1737360"/>
+            <a:ext cx="10424160" cy="1645920"/>
+          </a:xfrm>
+          <a:prstGeom prst="rect">
+            <a:avLst/>
+          </a:prstGeom>
+          <a:noFill/>
+        </p:spPr>
+        <p:txBody>
+          <a:bodyPr wrap="square">
+            <a:spAutoFit/>
+          </a:bodyPr>
+          <a:lstStyle/>
+          <a:p>
+            <a:pPr>
+              <a:defRPr sz="2000" i="1">
+                <a:solidFill>
+                  <a:srgbClr val="9AA0AB"/>
+                </a:solidFill>
+                <a:latin typeface="Helvetica Neue"/>
+              </a:defRPr>
+            </a:pPr>
+            <a:r>
+              <a:t>Your first production is one pasted link away</a:t>
+            </a:r>
+          </a:p>
+        </p:txBody>
+      </p:sp>
+      <p:sp>
+        <p:nvSpPr>
+          <p:cNvPr id="5" name="TextBox 4"/>
+          <p:cNvSpPr txBox="1"/>
+          <p:nvPr/>
+        </p:nvSpPr>
+        <p:spPr>
+          <a:xfrm>
+            <a:off x="10820095" y="6355080"/>
+            <a:ext cx="1005840" cy="365760"/>
+          </a:xfrm>
+          <a:prstGeom prst="rect">
+            <a:avLst/>
+          </a:prstGeom>
+          <a:noFill/>
+        </p:spPr>
+        <p:txBody>
+          <a:bodyPr wrap="none">
+            <a:spAutoFit/>
+          </a:bodyPr>
+          <a:lstStyle/>
+          <a:p>
+            <a:pPr algn="r">
+              <a:defRPr sz="1200">
+                <a:solidFill>
+                  <a:srgbClr val="9AA0AB"/>
+                </a:solidFill>
+                <a:latin typeface="Helvetica Neue"/>
+              </a:defRPr>
+            </a:pPr>
+            <a:r>
+              <a:t>20 / 20</a:t>
             </a:r>
           </a:p>
         </p:txBody>
@@ -6848,7 +7844,7 @@
         <p:spPr>
           <a:xfrm>
             <a:off x="822960" y="457200"/>
-            <a:ext cx="5577840" cy="1371600"/>
+            <a:ext cx="10424160" cy="1371600"/>
           </a:xfrm>
           <a:prstGeom prst="rect">
             <a:avLst/>
@@ -6884,7 +7880,7 @@
         <p:spPr>
           <a:xfrm>
             <a:off x="822960" y="1737360"/>
-            <a:ext cx="5577840" cy="4572000"/>
+            <a:ext cx="10424160" cy="4572000"/>
           </a:xfrm>
           <a:prstGeom prst="rect">
             <a:avLst/>
@@ -6909,7 +7905,7 @@
               </a:defRPr>
             </a:pPr>
             <a:r>
-              <a:t>•  Left: your searchable library</a:t>
+              <a:t>•  Left: searchable library, always saved</a:t>
             </a:r>
           </a:p>
           <a:p>
@@ -6925,7 +7921,7 @@
               </a:defRPr>
             </a:pPr>
             <a:r>
-              <a:t>•  Right: the New Generation workspace</a:t>
+              <a:t>•  Right: workspace, New Generation form</a:t>
             </a:r>
           </a:p>
           <a:p>
@@ -6941,54 +7937,14 @@
               </a:defRPr>
             </a:pPr>
             <a:r>
-              <a:t>•  Nothing disappears on restart</a:t>
-            </a:r>
-          </a:p>
-          <a:p>
-            <a:pPr>
-              <a:spcAft>
-                <a:spcPts val="1200"/>
-              </a:spcAft>
-              <a:defRPr sz="1800">
-                <a:solidFill>
-                  <a:srgbClr val="F2F0EB"/>
-                </a:solidFill>
-                <a:latin typeface="Helvetica Neue"/>
-              </a:defRPr>
-            </a:pPr>
-            <a:r>
               <a:t>•  Two buttons: New Generation, Templates</a:t>
             </a:r>
           </a:p>
         </p:txBody>
       </p:sp>
-      <p:pic>
-        <p:nvPicPr>
-          <p:cNvPr id="5" name="Picture 4" descr="img_02.jpg"/>
-          <p:cNvPicPr>
-            <a:picLocks noChangeAspect="1"/>
-          </p:cNvPicPr>
-          <p:nvPr/>
-        </p:nvPicPr>
-        <p:blipFill>
-          <a:blip r:embed="rId2"/>
-          <a:stretch>
-            <a:fillRect/>
-          </a:stretch>
-        </p:blipFill>
-        <p:spPr>
-          <a:xfrm>
-            <a:off x="6675120" y="2019974"/>
-            <a:ext cx="4937760" cy="2818050"/>
-          </a:xfrm>
-          <a:prstGeom prst="rect">
-            <a:avLst/>
-          </a:prstGeom>
-        </p:spPr>
-      </p:pic>
-      <p:sp>
-        <p:nvSpPr>
-          <p:cNvPr id="6" name="TextBox 5"/>
+      <p:sp>
+        <p:nvSpPr>
+          <p:cNvPr id="5" name="TextBox 4"/>
           <p:cNvSpPr txBox="1"/>
           <p:nvPr/>
         </p:nvSpPr>
@@ -7017,7 +7973,7 @@
               </a:defRPr>
             </a:pPr>
             <a:r>
-              <a:t>3 / 17</a:t>
+              <a:t>3 / 20</a:t>
             </a:r>
           </a:p>
         </p:txBody>
@@ -7123,7 +8079,7 @@
               </a:defRPr>
             </a:pPr>
             <a:r>
-              <a:t>Step One: Paste Your Source</a:t>
+              <a:t>Step 1 — Point at a Source</a:t>
             </a:r>
           </a:p>
         </p:txBody>
@@ -7162,7 +8118,7 @@
               </a:defRPr>
             </a:pPr>
             <a:r>
-              <a:t>•  Paste an article URL</a:t>
+              <a:t>•  Paste a URL, or upload a PDF</a:t>
             </a:r>
           </a:p>
           <a:p>
@@ -7178,7 +8134,7 @@
               </a:defRPr>
             </a:pPr>
             <a:r>
-              <a:t>•  Or switch to PDF upload</a:t>
+              <a:t>•  Drag a PDF onto the Source box</a:t>
             </a:r>
           </a:p>
           <a:p>
@@ -7194,14 +8150,14 @@
               </a:defRPr>
             </a:pPr>
             <a:r>
-              <a:t>•  The studio reads it for your listeners</a:t>
+              <a:t>•  The raw material the studio reads</a:t>
             </a:r>
           </a:p>
         </p:txBody>
       </p:sp>
       <p:pic>
         <p:nvPicPr>
-          <p:cNvPr id="5" name="Picture 4" descr="img_03.jpg"/>
+          <p:cNvPr id="5" name="Picture 4" descr="img_01.jpg"/>
           <p:cNvPicPr>
             <a:picLocks noChangeAspect="1"/>
           </p:cNvPicPr>
@@ -7254,7 +8210,7 @@
               </a:defRPr>
             </a:pPr>
             <a:r>
-              <a:t>4 / 17</a:t>
+              <a:t>4 / 20</a:t>
             </a:r>
           </a:p>
         </p:txBody>
@@ -7338,7 +8294,7 @@
         <p:spPr>
           <a:xfrm>
             <a:off x="822960" y="457200"/>
-            <a:ext cx="5577840" cy="1371600"/>
+            <a:ext cx="10424160" cy="1371600"/>
           </a:xfrm>
           <a:prstGeom prst="rect">
             <a:avLst/>
@@ -7360,45 +8316,21 @@
               </a:defRPr>
             </a:pPr>
             <a:r>
-              <a:t>Choose Your Mode</a:t>
-            </a:r>
-          </a:p>
-        </p:txBody>
-      </p:sp>
-      <p:pic>
-        <p:nvPicPr>
-          <p:cNvPr id="4" name="Picture 3" descr="figure_04.png"/>
-          <p:cNvPicPr>
-            <a:picLocks noChangeAspect="1"/>
-          </p:cNvPicPr>
-          <p:nvPr/>
-        </p:nvPicPr>
-        <p:blipFill>
-          <a:blip r:embed="rId2"/>
-          <a:stretch>
-            <a:fillRect/>
-          </a:stretch>
-        </p:blipFill>
-        <p:spPr>
-          <a:xfrm>
-            <a:off x="6675120" y="1898294"/>
-            <a:ext cx="4937760" cy="3061411"/>
-          </a:xfrm>
-          <a:prstGeom prst="rect">
-            <a:avLst/>
-          </a:prstGeom>
-        </p:spPr>
-      </p:pic>
-      <p:sp>
-        <p:nvSpPr>
-          <p:cNvPr id="5" name="TextBox 4"/>
+              <a:t>Step 2 — Choose Your Mode</a:t>
+            </a:r>
+          </a:p>
+        </p:txBody>
+      </p:sp>
+      <p:sp>
+        <p:nvSpPr>
+          <p:cNvPr id="4" name="TextBox 3"/>
           <p:cNvSpPr txBox="1"/>
           <p:nvPr/>
         </p:nvSpPr>
         <p:spPr>
           <a:xfrm>
-            <a:off x="10820095" y="6355080"/>
-            <a:ext cx="1005840" cy="365760"/>
+            <a:off x="822960" y="1737360"/>
+            <a:ext cx="10424160" cy="4572000"/>
           </a:xfrm>
           <a:prstGeom prst="rect">
             <a:avLst/>
@@ -7406,6 +8338,77 @@
           <a:noFill/>
         </p:spPr>
         <p:txBody>
+          <a:bodyPr wrap="square">
+            <a:spAutoFit/>
+          </a:bodyPr>
+          <a:lstStyle/>
+          <a:p>
+            <a:pPr>
+              <a:spcAft>
+                <a:spcPts val="1200"/>
+              </a:spcAft>
+              <a:defRPr sz="1800">
+                <a:solidFill>
+                  <a:srgbClr val="F2F0EB"/>
+                </a:solidFill>
+                <a:latin typeface="Helvetica Neue"/>
+              </a:defRPr>
+            </a:pPr>
+            <a:r>
+              <a:t>•  Podcast: two hosts in conversation</a:t>
+            </a:r>
+          </a:p>
+          <a:p>
+            <a:pPr>
+              <a:spcAft>
+                <a:spcPts val="1200"/>
+              </a:spcAft>
+              <a:defRPr sz="1800">
+                <a:solidFill>
+                  <a:srgbClr val="F2F0EB"/>
+                </a:solidFill>
+                <a:latin typeface="Helvetica Neue"/>
+              </a:defRPr>
+            </a:pPr>
+            <a:r>
+              <a:t>•  Summary: one narrator, 2–4 minutes</a:t>
+            </a:r>
+          </a:p>
+          <a:p>
+            <a:pPr>
+              <a:spcAft>
+                <a:spcPts val="1200"/>
+              </a:spcAft>
+              <a:defRPr sz="1800">
+                <a:solidFill>
+                  <a:srgbClr val="F2F0EB"/>
+                </a:solidFill>
+                <a:latin typeface="Helvetica Neue"/>
+              </a:defRPr>
+            </a:pPr>
+            <a:r>
+              <a:t>•  Readout: full document, read faithfully</a:t>
+            </a:r>
+          </a:p>
+        </p:txBody>
+      </p:sp>
+      <p:sp>
+        <p:nvSpPr>
+          <p:cNvPr id="5" name="TextBox 4"/>
+          <p:cNvSpPr txBox="1"/>
+          <p:nvPr/>
+        </p:nvSpPr>
+        <p:spPr>
+          <a:xfrm>
+            <a:off x="10820095" y="6355080"/>
+            <a:ext cx="1005840" cy="365760"/>
+          </a:xfrm>
+          <a:prstGeom prst="rect">
+            <a:avLst/>
+          </a:prstGeom>
+          <a:noFill/>
+        </p:spPr>
+        <p:txBody>
           <a:bodyPr wrap="none">
             <a:spAutoFit/>
           </a:bodyPr>
@@ -7420,7 +8423,7 @@
               </a:defRPr>
             </a:pPr>
             <a:r>
-              <a:t>5 / 17</a:t>
+              <a:t>5 / 20</a:t>
             </a:r>
           </a:p>
         </p:txBody>
@@ -7504,7 +8507,7 @@
         <p:spPr>
           <a:xfrm>
             <a:off x="822960" y="457200"/>
-            <a:ext cx="5577840" cy="1371600"/>
+            <a:ext cx="10424160" cy="1371600"/>
           </a:xfrm>
           <a:prstGeom prst="rect">
             <a:avLst/>
@@ -7526,7 +8529,7 @@
               </a:defRPr>
             </a:pPr>
             <a:r>
-              <a:t>Run Until: Work in Safe Steps</a:t>
+              <a:t>Step 3 — Run Until</a:t>
             </a:r>
           </a:p>
         </p:txBody>
@@ -7540,7 +8543,7 @@
         <p:spPr>
           <a:xfrm>
             <a:off x="822960" y="1737360"/>
-            <a:ext cx="5577840" cy="4572000"/>
+            <a:ext cx="10424160" cy="4572000"/>
           </a:xfrm>
           <a:prstGeom prst="rect">
             <a:avLst/>
@@ -7581,7 +8584,7 @@
               </a:defRPr>
             </a:pPr>
             <a:r>
-              <a:t>•  Read and adjust before any audio</a:t>
+              <a:t>•  Full Production: all in one pass</a:t>
             </a:r>
           </a:p>
           <a:p>
@@ -7597,54 +8600,14 @@
               </a:defRPr>
             </a:pPr>
             <a:r>
-              <a:t>•  Full Production: all the way in one pass</a:t>
-            </a:r>
-          </a:p>
-          <a:p>
-            <a:pPr>
-              <a:spcAft>
-                <a:spcPts val="1200"/>
-              </a:spcAft>
-              <a:defRPr sz="1800">
-                <a:solidFill>
-                  <a:srgbClr val="F2F0EB"/>
-                </a:solidFill>
-                <a:latin typeface="Helvetica Neue"/>
-              </a:defRPr>
-            </a:pPr>
-            <a:r>
-              <a:t>•  Recommended first move: Script Draft</a:t>
-            </a:r>
-          </a:p>
-        </p:txBody>
-      </p:sp>
-      <p:pic>
-        <p:nvPicPr>
-          <p:cNvPr id="5" name="Picture 4" descr="img_06.jpg"/>
-          <p:cNvPicPr>
-            <a:picLocks noChangeAspect="1"/>
-          </p:cNvPicPr>
-          <p:nvPr/>
-        </p:nvPicPr>
-        <p:blipFill>
-          <a:blip r:embed="rId2"/>
-          <a:stretch>
-            <a:fillRect/>
-          </a:stretch>
-        </p:blipFill>
-        <p:spPr>
-          <a:xfrm>
-            <a:off x="6675120" y="2019974"/>
-            <a:ext cx="4937760" cy="2818050"/>
-          </a:xfrm>
-          <a:prstGeom prst="rect">
-            <a:avLst/>
-          </a:prstGeom>
-        </p:spPr>
-      </p:pic>
-      <p:sp>
-        <p:nvSpPr>
-          <p:cNvPr id="6" name="TextBox 5"/>
+              <a:t>•  Start with a draft — cheaper, clearer</a:t>
+            </a:r>
+          </a:p>
+        </p:txBody>
+      </p:sp>
+      <p:sp>
+        <p:nvSpPr>
+          <p:cNvPr id="5" name="TextBox 4"/>
           <p:cNvSpPr txBox="1"/>
           <p:nvPr/>
         </p:nvSpPr>
@@ -7673,7 +8636,7 @@
               </a:defRPr>
             </a:pPr>
             <a:r>
-              <a:t>6 / 17</a:t>
+              <a:t>6 / 20</a:t>
             </a:r>
           </a:p>
         </p:txBody>
@@ -7779,7 +8742,7 @@
               </a:defRPr>
             </a:pPr>
             <a:r>
-              <a:t>Tailor to Your Audience</a:t>
+              <a:t>Step 4 — Tailor to Your Audience</a:t>
             </a:r>
           </a:p>
         </p:txBody>
@@ -7818,7 +8781,7 @@
               </a:defRPr>
             </a:pPr>
             <a:r>
-              <a:t>•  Describe who will listen</a:t>
+              <a:t>•  Name who will be listening</a:t>
             </a:r>
           </a:p>
           <a:p>
@@ -7834,7 +8797,7 @@
               </a:defRPr>
             </a:pPr>
             <a:r>
-              <a:t>•  Leads with what they care about</a:t>
+              <a:t>•  Script leads with what they care about</a:t>
             </a:r>
           </a:p>
           <a:p>
@@ -7850,23 +8813,7 @@
               </a:defRPr>
             </a:pPr>
             <a:r>
-              <a:t>•  Set host personalities too</a:t>
-            </a:r>
-          </a:p>
-          <a:p>
-            <a:pPr>
-              <a:spcAft>
-                <a:spcPts val="1200"/>
-              </a:spcAft>
-              <a:defRPr sz="1800">
-                <a:solidFill>
-                  <a:srgbClr val="F2F0EB"/>
-                </a:solidFill>
-                <a:latin typeface="Helvetica Neue"/>
-              </a:defRPr>
-            </a:pPr>
-            <a:r>
-              <a:t>•  Voices default until you explore</a:t>
+              <a:t>•  Describe host personalities, pick voices</a:t>
             </a:r>
           </a:p>
         </p:txBody>
@@ -7902,7 +8849,7 @@
               </a:defRPr>
             </a:pPr>
             <a:r>
-              <a:t>7 / 17</a:t>
+              <a:t>7 / 20</a:t>
             </a:r>
           </a:p>
         </p:txBody>
@@ -8008,7 +8955,7 @@
               </a:defRPr>
             </a:pPr>
             <a:r>
-              <a:t>Slides &amp; Captions</a:t>
+              <a:t>Which Output Do I Need?</a:t>
             </a:r>
           </a:p>
         </p:txBody>
@@ -8047,46 +8994,14 @@
               </a:defRPr>
             </a:pPr>
             <a:r>
-              <a:t>•  Pick formats: slideshow, video, PowerPoint</a:t>
-            </a:r>
-          </a:p>
-          <a:p>
-            <a:pPr>
-              <a:spcAft>
-                <a:spcPts val="1200"/>
-              </a:spcAft>
-              <a:defRPr sz="1800">
-                <a:solidFill>
-                  <a:srgbClr val="F2F0EB"/>
-                </a:solidFill>
-                <a:latin typeface="Helvetica Neue"/>
-              </a:defRPr>
-            </a:pPr>
-            <a:r>
-              <a:t>•  Captions: burned in or toggle on/off</a:t>
-            </a:r>
-          </a:p>
-          <a:p>
-            <a:pPr>
-              <a:spcAft>
-                <a:spcPts val="1200"/>
-              </a:spcAft>
-              <a:defRPr sz="1800">
-                <a:solidFill>
-                  <a:srgbClr val="F2F0EB"/>
-                </a:solidFill>
-                <a:latin typeface="Helvetica Neue"/>
-              </a:defRPr>
-            </a:pPr>
-            <a:r>
-              <a:t>•  Then press Start Generation</a:t>
+              <a:t>•  Pick one format or a combination</a:t>
             </a:r>
           </a:p>
         </p:txBody>
       </p:sp>
       <p:pic>
         <p:nvPicPr>
-          <p:cNvPr id="5" name="Picture 4" descr="img_05.jpg"/>
+          <p:cNvPr id="5" name="Picture 4" descr="figure_07.png"/>
           <p:cNvPicPr>
             <a:picLocks noChangeAspect="1"/>
           </p:cNvPicPr>
@@ -8100,8 +9015,8 @@
         </p:blipFill>
         <p:spPr>
           <a:xfrm>
-            <a:off x="6675120" y="2019974"/>
-            <a:ext cx="4937760" cy="2818050"/>
+            <a:off x="6675120" y="1898294"/>
+            <a:ext cx="4937760" cy="3061411"/>
           </a:xfrm>
           <a:prstGeom prst="rect">
             <a:avLst/>
@@ -8139,7 +9054,7 @@
               </a:defRPr>
             </a:pPr>
             <a:r>
-              <a:t>8 / 17</a:t>
+              <a:t>8 / 20</a:t>
             </a:r>
           </a:p>
         </p:txBody>
@@ -8245,14 +9160,69 @@
               </a:defRPr>
             </a:pPr>
             <a:r>
-              <a:t>The Pipeline: Four Stations</a:t>
+              <a:t>Four Stations on One Line</a:t>
+            </a:r>
+          </a:p>
+        </p:txBody>
+      </p:sp>
+      <p:sp>
+        <p:nvSpPr>
+          <p:cNvPr id="4" name="TextBox 3"/>
+          <p:cNvSpPr txBox="1"/>
+          <p:nvPr/>
+        </p:nvSpPr>
+        <p:spPr>
+          <a:xfrm>
+            <a:off x="822960" y="1737360"/>
+            <a:ext cx="5577840" cy="4572000"/>
+          </a:xfrm>
+          <a:prstGeom prst="rect">
+            <a:avLst/>
+          </a:prstGeom>
+          <a:noFill/>
+        </p:spPr>
+        <p:txBody>
+          <a:bodyPr wrap="square">
+            <a:spAutoFit/>
+          </a:bodyPr>
+          <a:lstStyle/>
+          <a:p>
+            <a:pPr>
+              <a:spcAft>
+                <a:spcPts val="1200"/>
+              </a:spcAft>
+              <a:defRPr sz="1800">
+                <a:solidFill>
+                  <a:srgbClr val="F2F0EB"/>
+                </a:solidFill>
+                <a:latin typeface="Helvetica Neue"/>
+              </a:defRPr>
+            </a:pPr>
+            <a:r>
+              <a:t>•  Amber = finished; pulsing = working now</a:t>
+            </a:r>
+          </a:p>
+          <a:p>
+            <a:pPr>
+              <a:spcAft>
+                <a:spcPts val="1200"/>
+              </a:spcAft>
+              <a:defRPr sz="1800">
+                <a:solidFill>
+                  <a:srgbClr val="F2F0EB"/>
+                </a:solidFill>
+                <a:latin typeface="Helvetica Neue"/>
+              </a:defRPr>
+            </a:pPr>
+            <a:r>
+              <a:t>•  Click any light to jump to that station</a:t>
             </a:r>
           </a:p>
         </p:txBody>
       </p:sp>
       <p:pic>
         <p:nvPicPr>
-          <p:cNvPr id="4" name="Picture 3" descr="figure_08.png"/>
+          <p:cNvPr id="5" name="Picture 4" descr="figure_08.png"/>
           <p:cNvPicPr>
             <a:picLocks noChangeAspect="1"/>
           </p:cNvPicPr>
@@ -8276,7 +9246,7 @@
       </p:pic>
       <p:sp>
         <p:nvSpPr>
-          <p:cNvPr id="5" name="TextBox 4"/>
+          <p:cNvPr id="6" name="TextBox 5"/>
           <p:cNvSpPr txBox="1"/>
           <p:nvPr/>
         </p:nvSpPr>
@@ -8305,7 +9275,7 @@
               </a:defRPr>
             </a:pPr>
             <a:r>
-              <a:t>9 / 17</a:t>
+              <a:t>9 / 20</a:t>
             </a:r>
           </a:p>
         </p:txBody>

</xml_diff>

<commit_message>
User guide rewritten for true newcomers, with animations
The narration now assumes the viewer has never opened the app: every
screen is described visually (where it is, what it looks like, what the
buttons are called), every term is defined at first use (voice-over,
captions, render), and the six screenshots — retaken with the current
English UI — appear exactly where the narration walks through those
screens. Produced with animations=on: staggered slide entrances,
bullet build-ins in the video, and three model-animated SVG figures.

Notably, this update exercised the full in-place workflow on one
project: source replaced (new essay + screenshots), script rewritten
via revision, re-rendered — a single library entry with its complete
history in the revision log.

Co-Authored-By: Claude Fable 5 <noreply@anthropic.com>
</commit_message>
<xml_diff>
--- a/docs/user-guide.pptx
+++ b/docs/user-guide.pptx
@@ -20,11 +20,6 @@
     <p:sldId id="268" r:id="rId20"/>
     <p:sldId id="269" r:id="rId21"/>
     <p:sldId id="270" r:id="rId22"/>
-    <p:sldId id="271" r:id="rId23"/>
-    <p:sldId id="272" r:id="rId24"/>
-    <p:sldId id="273" r:id="rId25"/>
-    <p:sldId id="274" r:id="rId26"/>
-    <p:sldId id="275" r:id="rId27"/>
   </p:sldIdLst>
   <p:sldSz cx="12191695" cy="6858000" type="screen4x3"/>
   <p:notesSz cx="6858000" cy="9144000"/>
@@ -521,7 +516,13 @@
           <a:lstStyle/>
           <a:p>
             <a:r>
-              <a:t>Welcome to your complete beginner's guide to Fluent Agents Studio — read start to finish. This guide takes you from opening the studio for the first time to producing a finished video with a professional voice-over, even if you have never made a podcast, a voice-over, or a slideshow in your life. Nothing here assumes experience. If you can paste a web address and describe what you want in a plain sentence, you have every skill this tool requires. And if you're brand new to this whole world, don't worry — I'll walk beside you the entire way, and you'll find the clearest help in the sections on writing your script, shaping your slides, and directing the voice.</a:t>
+              <a:t>Welcome to the complete beginner's guide to Fluent Agents Studio.</a:t>
+            </a:r>
+          </a:p>
+          <a:p/>
+          <a:p>
+            <a:r>
+              <a:t>This guide assumes you have never opened the app, never made a voice-over, and never edited a video in your life. That's fine. By the end of these twelve minutes you'll know exactly what you'll see on every screen, what every button does, and how to go from a web article to a finished, narrated video without touching a single editing tool.</a:t>
             </a:r>
           </a:p>
         </p:txBody>
@@ -591,13 +592,7 @@
           <a:lstStyle/>
           <a:p>
             <a:r>
-              <a:t>Every production moves through the same four stations, and the job page shows them as a strip of lights: Script, Slides, Voice, Outputs. An amber light means that station is finished; a pulsing light means it is working right now. Click any light to jump to that station's page. The order matters, and it is the same order a human production team would use: first the words, then the visuals, then the recording, then the packaging. The workbench is built around one principle — you can stop at any station, change your mind in plain English, and everything downstream updates.</a:t>
-            </a:r>
-          </a:p>
-          <a:p/>
-          <a:p>
-            <a:r>
-              <a:t>Let's visit station one: the script.</a:t>
+              <a:t>Slides revise exactly like the script — same kind of box at the bottom, same plain English: "Make every title a question." "Merge slides three and four." And if your company has a visual identity, click that Templates button back in the top-left corner: it opens a page where you upload a PowerPoint template, a style-guide document, or even a screenshot of slides you like. The studio reads the colors and fonts out of whatever you give it and applies them to everything it renders. Save the files once as a named set, and every future project can use it from a simple dropdown menu.</a:t>
             </a:r>
           </a:p>
         </p:txBody>
@@ -667,13 +662,7 @@
           <a:lstStyle/>
           <a:p>
             <a:r>
-              <a:t>The Script tab shows every line the voice will speak, numbered, with a badge showing which speaker says it. Read it like a director reads a draft. If you want changes, do not edit text — describe what you want in the Revision Instructions box, exactly as you would tell a writer: "Open with a question instead of an announcement." "Cut the part about pricing." "Make host B funnier." The studio rewrites precisely what you asked for and leaves the rest word-for-word untouched. You can revise as many times as you like, and each round takes about a minute. This is the single most important habit in the studio: iterate on the cheap words before you spend time on audio and video.</a:t>
-            </a:r>
-          </a:p>
-          <a:p/>
-          <a:p>
-            <a:r>
-              <a:t>On to station two: the slides.</a:t>
+              <a:t>Now for station three: the voice — the part that sounds hardest and isn't. Each slide card carries a tiny play symbol in its top corner. Click it and the screen dims: your slide appears large in the middle, and a slim control bar sits beneath it with pause, previous and next arrows, a progress line, and an auto-advance switch. What you hear is precisely the stretch of narration that belongs to that slide — not the whole episode. That's what's on screen now: one slide, under review, with its own segment of voice. Step through your whole production this way; it's how you catch the slide that arrives one beat too late or the sentence that needs more air.</a:t>
             </a:r>
           </a:p>
         </p:txBody>
@@ -743,13 +732,7 @@
           <a:lstStyle/>
           <a:p>
             <a:r>
-              <a:t>The Slides tab shows the deck as cards — each card is one slide, anchored to the exact line of narration where it will appear. Slides are not just text. The studio pulls real images out of your source article and places them where they fit, and it designs its own figures — charts, timelines, diagrams — whenever the material has data worth showing. An Asset Inventory at the bottom lists every image and figure and tells you exactly which slide uses each one, so nothing is a mystery.</a:t>
-            </a:r>
-          </a:p>
-          <a:p/>
-          <a:p>
-            <a:r>
-              <a:t>Slides revise just like the script: plain instructions in the box. "Make every title a question." "Merge slides three and four." "More detail on the budget slide." And you can set expectations up front with the Slide Expectations field — "ultra minimal, one phrase per slide" gives you a keynote; "more informative than the voice-over, with data the narration skips" gives you reference slides worth pausing on.</a:t>
+              <a:t>When something sounds off, go to the Voice page — the third light — and give instructions that mention line numbers from the script: "Line 4, slow down ten percent and pause after the question." "Pronounce Nguyen as win, everywhere." The written transcript keeps the correct spelling; only the pronunciation changes, and the audio re-records itself within a minute or two. And if a slide appears at the wrong moment, every card has a small offset box: type minus two to bring it in two seconds earlier, press Apply Timing, and the visuals re-sync without re-recording anything.</a:t>
             </a:r>
           </a:p>
         </p:txBody>
@@ -819,13 +802,7 @@
           <a:lstStyle/>
           <a:p>
             <a:r>
-              <a:t>If you have a company look, the Templates page stores it. Upload a PowerPoint template, a style guide document, or even a screenshot of slides you like; the studio extracts the colors and fonts and applies them to everything it renders — the slideshow, the video, and the PowerPoint. Save it once as a template set and apply it to any future production from a dropdown.</a:t>
-            </a:r>
-          </a:p>
-          <a:p/>
-          <a:p>
-            <a:r>
-              <a:t>Now for station three: the voice. And here's a reassuring note if you're new.</a:t>
+              <a:t>And finally, station four: the outputs — the packaging department. At the top sits an amber Render Production button with menus beside it for slides, captions and animations — press it and the studio assembles everything from your current script, slides and voice direction. Below, each finished file gets its own card: the Audio card holds the episode with a play bar and a download link; the Transcript card shows the full text with a timestamp on every line; the Web Slideshow card opens the synced presentation — a single file, sound included, that you can send to anyone; the Video card previews the movie file; and the PowerPoint card downloads a deck that carries the narration as speaker notes under every slide, so you can present it yourself and read what the voice would have said.</a:t>
             </a:r>
           </a:p>
         </p:txBody>
@@ -895,7 +872,7 @@
           <a:lstStyle/>
           <a:p>
             <a:r>
-              <a:t>Here is where novices usually expect the hard part — and where the studio does the most for you. The narration is synthesized line by line, and every line can be directed individually. The Voice tab takes revision instructions that reference transcript line numbers: "Line 4: slow down ten percent and pause after the question." "Pronounce Nguyen as win, everywhere it appears." The transcript and captions keep the correct spelling; only the pronunciation changes. Audio re-records automatically after every voice revision, so you hear the result within a minute or two.</a:t>
+              <a:t>One honest note about money. The studio's writing and design run on a paid artificial-intelligence service. Next to each project's title you'll find a small capsule reading something like "approximately forty cents model spend" — that's the project's real running cost, usually well under a dollar for a full production. The studio also makes repeat revisions cheap: when you iterate several times within a few minutes, the repeated material is billed at roughly a tenth of normal price. So work the way good producers work anyway — in focused bursts.</a:t>
             </a:r>
           </a:p>
         </p:txBody>
@@ -965,305 +942,7 @@
           <a:lstStyle/>
           <a:p>
             <a:r>
-              <a:t>The best review tool in the studio lives on the slide cards: the small play button. It opens the slide full-screen and plays exactly the stretch of narration that belongs to it — not the whole episode, just that slide's segment. Step through with the arrow buttons, or switch on auto-advance and review the whole production slide by slide. This is how you catch the slide that arrives a beat too late or the sentence that needs more air.</a:t>
-            </a:r>
-          </a:p>
-        </p:txBody>
-      </p:sp>
-      <p:sp>
-        <p:nvSpPr>
-          <p:cNvPr id="4" name="Slide Number Placeholder 3"/>
-          <p:cNvSpPr>
-            <a:spLocks noGrp="1"/>
-          </p:cNvSpPr>
-          <p:nvPr>
-            <p:ph type="sldNum" idx="5" sz="quarter"/>
-          </p:nvPr>
-        </p:nvSpPr>
-        <p:spPr/>
-      </p:sp>
-    </p:spTree>
-  </p:cSld>
-  <p:clrMapOvr>
-    <a:masterClrMapping/>
-  </p:clrMapOvr>
-</p:notes>
-</file>
-
-<file path=ppt/notesSlides/notesSlide16.xml><?xml version="1.0" encoding="utf-8"?>
-<p:notes xmlns:a="http://schemas.openxmlformats.org/drawingml/2006/main" xmlns:p="http://schemas.openxmlformats.org/presentationml/2006/main" xmlns:r="http://schemas.openxmlformats.org/officeDocument/2006/relationships">
-  <p:cSld>
-    <p:spTree>
-      <p:nvGrpSpPr>
-        <p:cNvPr id="1" name=""/>
-        <p:cNvGrpSpPr/>
-        <p:nvPr/>
-      </p:nvGrpSpPr>
-      <p:grpSpPr>
-        <a:xfrm>
-          <a:off x="0" y="0"/>
-          <a:ext cx="0" cy="0"/>
-          <a:chOff x="0" y="0"/>
-          <a:chExt cx="0" cy="0"/>
-        </a:xfrm>
-      </p:grpSpPr>
-      <p:sp>
-        <p:nvSpPr>
-          <p:cNvPr id="2" name="Slide Image Placeholder 1"/>
-          <p:cNvSpPr>
-            <a:spLocks noGrp="1"/>
-          </p:cNvSpPr>
-          <p:nvPr>
-            <p:ph type="sldImg" idx="2"/>
-          </p:nvPr>
-        </p:nvSpPr>
-        <p:spPr/>
-      </p:sp>
-      <p:sp>
-        <p:nvSpPr>
-          <p:cNvPr id="3" name="Notes Placeholder 2"/>
-          <p:cNvSpPr>
-            <a:spLocks noGrp="1"/>
-          </p:cNvSpPr>
-          <p:nvPr>
-            <p:ph type="body" idx="3" sz="quarter"/>
-          </p:nvPr>
-        </p:nvSpPr>
-        <p:spPr/>
-        <p:txBody>
-          <a:bodyPr/>
-          <a:lstStyle/>
-          <a:p>
-            <a:r>
-              <a:t>And when a slide does arrive too late? Every card has an offset field: type minus two to bring the slide in two seconds earlier, press Apply Timing, and the slideshow and video re-render with the new timing in seconds — the audio is never touched.</a:t>
-            </a:r>
-          </a:p>
-          <a:p/>
-          <a:p>
-            <a:r>
-              <a:t>And finally, station four: the outputs.</a:t>
-            </a:r>
-          </a:p>
-        </p:txBody>
-      </p:sp>
-      <p:sp>
-        <p:nvSpPr>
-          <p:cNvPr id="4" name="Slide Number Placeholder 3"/>
-          <p:cNvSpPr>
-            <a:spLocks noGrp="1"/>
-          </p:cNvSpPr>
-          <p:nvPr>
-            <p:ph type="sldNum" idx="5" sz="quarter"/>
-          </p:nvPr>
-        </p:nvSpPr>
-        <p:spPr/>
-      </p:sp>
-    </p:spTree>
-  </p:cSld>
-  <p:clrMapOvr>
-    <a:masterClrMapping/>
-  </p:clrMapOvr>
-</p:notes>
-</file>
-
-<file path=ppt/notesSlides/notesSlide17.xml><?xml version="1.0" encoding="utf-8"?>
-<p:notes xmlns:a="http://schemas.openxmlformats.org/drawingml/2006/main" xmlns:p="http://schemas.openxmlformats.org/presentationml/2006/main" xmlns:r="http://schemas.openxmlformats.org/officeDocument/2006/relationships">
-  <p:cSld>
-    <p:spTree>
-      <p:nvGrpSpPr>
-        <p:cNvPr id="1" name=""/>
-        <p:cNvGrpSpPr/>
-        <p:nvPr/>
-      </p:nvGrpSpPr>
-      <p:grpSpPr>
-        <a:xfrm>
-          <a:off x="0" y="0"/>
-          <a:ext cx="0" cy="0"/>
-          <a:chOff x="0" y="0"/>
-          <a:chExt cx="0" cy="0"/>
-        </a:xfrm>
-      </p:grpSpPr>
-      <p:sp>
-        <p:nvSpPr>
-          <p:cNvPr id="2" name="Slide Image Placeholder 1"/>
-          <p:cNvSpPr>
-            <a:spLocks noGrp="1"/>
-          </p:cNvSpPr>
-          <p:nvPr>
-            <p:ph type="sldImg" idx="2"/>
-          </p:nvPr>
-        </p:nvSpPr>
-        <p:spPr/>
-      </p:sp>
-      <p:sp>
-        <p:nvSpPr>
-          <p:cNvPr id="3" name="Notes Placeholder 2"/>
-          <p:cNvSpPr>
-            <a:spLocks noGrp="1"/>
-          </p:cNvSpPr>
-          <p:nvPr>
-            <p:ph type="body" idx="3" sz="quarter"/>
-          </p:nvPr>
-        </p:nvSpPr>
-        <p:spPr/>
-        <p:txBody>
-          <a:bodyPr/>
-          <a:lstStyle/>
-          <a:p>
-            <a:r>
-              <a:t>The Outputs tab is the packaging department. The Render Production button assembles everything from the current script, slides, and voice direction. Below it, each finished artifact gets a card: the audio as an MP3, a transcript with a timestamp on every line, the web slideshow — a single file you can email to anyone, audio included, slides advancing in sync — the video for uploading anywhere, and the PowerPoint, which carries the narration as speaker notes on every slide so you can present the deck yourself.</a:t>
-            </a:r>
-          </a:p>
-        </p:txBody>
-      </p:sp>
-      <p:sp>
-        <p:nvSpPr>
-          <p:cNvPr id="4" name="Slide Number Placeholder 3"/>
-          <p:cNvSpPr>
-            <a:spLocks noGrp="1"/>
-          </p:cNvSpPr>
-          <p:nvPr>
-            <p:ph type="sldNum" idx="5" sz="quarter"/>
-          </p:nvPr>
-        </p:nvSpPr>
-        <p:spPr/>
-      </p:sp>
-    </p:spTree>
-  </p:cSld>
-  <p:clrMapOvr>
-    <a:masterClrMapping/>
-  </p:clrMapOvr>
-</p:notes>
-</file>
-
-<file path=ppt/notesSlides/notesSlide18.xml><?xml version="1.0" encoding="utf-8"?>
-<p:notes xmlns:a="http://schemas.openxmlformats.org/drawingml/2006/main" xmlns:p="http://schemas.openxmlformats.org/presentationml/2006/main" xmlns:r="http://schemas.openxmlformats.org/officeDocument/2006/relationships">
-  <p:cSld>
-    <p:spTree>
-      <p:nvGrpSpPr>
-        <p:cNvPr id="1" name=""/>
-        <p:cNvGrpSpPr/>
-        <p:nvPr/>
-      </p:nvGrpSpPr>
-      <p:grpSpPr>
-        <a:xfrm>
-          <a:off x="0" y="0"/>
-          <a:ext cx="0" cy="0"/>
-          <a:chOff x="0" y="0"/>
-          <a:chExt cx="0" cy="0"/>
-        </a:xfrm>
-      </p:grpSpPr>
-      <p:sp>
-        <p:nvSpPr>
-          <p:cNvPr id="2" name="Slide Image Placeholder 1"/>
-          <p:cNvSpPr>
-            <a:spLocks noGrp="1"/>
-          </p:cNvSpPr>
-          <p:nvPr>
-            <p:ph type="sldImg" idx="2"/>
-          </p:nvPr>
-        </p:nvSpPr>
-        <p:spPr/>
-      </p:sp>
-      <p:sp>
-        <p:nvSpPr>
-          <p:cNvPr id="3" name="Notes Placeholder 2"/>
-          <p:cNvSpPr>
-            <a:spLocks noGrp="1"/>
-          </p:cNvSpPr>
-          <p:nvPr>
-            <p:ph type="body" idx="3" sz="quarter"/>
-          </p:nvPr>
-        </p:nvSpPr>
-        <p:spPr/>
-        <p:txBody>
-          <a:bodyPr/>
-          <a:lstStyle/>
-          <a:p>
-            <a:r>
-              <a:t>One honest word about cost. The studio's writing and design run on a paid AI model, and each job's header shows a small chip with its running spend — usually well under a dollar for a full production. Revisions are engineered to be cheap: when you iterate several times within a few minutes, the repeated material is billed at about a tenth of the normal price. The habit that saves money is the same habit that makes good productions: revise in focused bursts.</a:t>
-            </a:r>
-          </a:p>
-          <a:p/>
-          <a:p>
-            <a:r>
-              <a:t>Let's bring it all together — the zero-to-hero path.</a:t>
-            </a:r>
-          </a:p>
-        </p:txBody>
-      </p:sp>
-      <p:sp>
-        <p:nvSpPr>
-          <p:cNvPr id="4" name="Slide Number Placeholder 3"/>
-          <p:cNvSpPr>
-            <a:spLocks noGrp="1"/>
-          </p:cNvSpPr>
-          <p:nvPr>
-            <p:ph type="sldNum" idx="5" sz="quarter"/>
-          </p:nvPr>
-        </p:nvSpPr>
-        <p:spPr/>
-      </p:sp>
-    </p:spTree>
-  </p:cSld>
-  <p:clrMapOvr>
-    <a:masterClrMapping/>
-  </p:clrMapOvr>
-</p:notes>
-</file>
-
-<file path=ppt/notesSlides/notesSlide19.xml><?xml version="1.0" encoding="utf-8"?>
-<p:notes xmlns:a="http://schemas.openxmlformats.org/drawingml/2006/main" xmlns:p="http://schemas.openxmlformats.org/presentationml/2006/main" xmlns:r="http://schemas.openxmlformats.org/officeDocument/2006/relationships">
-  <p:cSld>
-    <p:spTree>
-      <p:nvGrpSpPr>
-        <p:cNvPr id="1" name=""/>
-        <p:cNvGrpSpPr/>
-        <p:nvPr/>
-      </p:nvGrpSpPr>
-      <p:grpSpPr>
-        <a:xfrm>
-          <a:off x="0" y="0"/>
-          <a:ext cx="0" cy="0"/>
-          <a:chOff x="0" y="0"/>
-          <a:chExt cx="0" cy="0"/>
-        </a:xfrm>
-      </p:grpSpPr>
-      <p:sp>
-        <p:nvSpPr>
-          <p:cNvPr id="2" name="Slide Image Placeholder 1"/>
-          <p:cNvSpPr>
-            <a:spLocks noGrp="1"/>
-          </p:cNvSpPr>
-          <p:nvPr>
-            <p:ph type="sldImg" idx="2"/>
-          </p:nvPr>
-        </p:nvSpPr>
-        <p:spPr/>
-      </p:sp>
-      <p:sp>
-        <p:nvSpPr>
-          <p:cNvPr id="3" name="Notes Placeholder 2"/>
-          <p:cNvSpPr>
-            <a:spLocks noGrp="1"/>
-          </p:cNvSpPr>
-          <p:nvPr>
-            <p:ph type="body" idx="3" sz="quarter"/>
-          </p:nvPr>
-        </p:nvSpPr>
-        <p:spPr/>
-        <p:txBody>
-          <a:bodyPr/>
-          <a:lstStyle/>
-          <a:p>
-            <a:r>
-              <a:t>So here is the whole method, compressed. Start a generation with a source, a mode, and an audience, and run it only until the script. Read the script; revise it in plain English until it says what you mean. Create the slides; shape them with instructions and, if you have one, your template. Render the production. Review it slide by slide with the play buttons; fix pronunciations and pacing with voice instructions; nudge timing with offsets. Then collect your outputs — and notice that the entire process never once required you to edit audio, design a slide, or touch a video editor.</a:t>
-            </a:r>
-          </a:p>
-          <a:p/>
-          <a:p>
-            <a:r>
-              <a:t>That is the studio's promise to a beginner: the production skills are built in, so the only skill you bring is knowing what you want to say, to whom. Everything you just heard — this voice, these slides, the figures and the screenshots — was produced by the workbench this guide describes, in one pass, from a written document. Your first production is one pasted link away. Welcome to Fluent Agents Studio.</a:t>
+              <a:t>Let's bring it all together — the whole method in one breath. Start a project with a source, a mode, and an audience, and run it only until the script. Read the script and revise it in plain sentences until it says what you mean. Shape the slides the same way, with your template if you have one. Render. Review slide by slide with the little play buttons, fix pronunciation and pacing by line number, nudge timings. Collect five finished files from the Outputs page. Notice what never happened: no audio editing, no slide designing, no video software. The production skills are built into the studio — the only skill you brought was knowing what you wanted to say, and to whom. Everything you've just watched and heard, including these very slides and this voice, was produced by the studio this guide describes. Your turn: one pasted link, and you're a producer.</a:t>
             </a:r>
           </a:p>
         </p:txBody>
@@ -1333,83 +1012,7 @@
           <a:lstStyle/>
           <a:p>
             <a:r>
-              <a:t>First, the idea in one breath. You give the studio something to read — a link to an article, or a PDF. The studio reads it, writes a spoken script about it, records that script with a natural computer voice, designs slides to go with it, and hands you back finished files: an audio episode, a slideshow that plays in your browser, a video, and even a PowerPoint. Your job is not to build any of that. Your job is to decide what you want and say so in ordinary language. The studio does the production work; you do the directing.</a:t>
-            </a:r>
-          </a:p>
-          <a:p/>
-          <a:p>
-            <a:r>
-              <a:t>Let's start by getting our bearings — the workbench at a glance.</a:t>
-            </a:r>
-          </a:p>
-        </p:txBody>
-      </p:sp>
-      <p:sp>
-        <p:nvSpPr>
-          <p:cNvPr id="4" name="Slide Number Placeholder 3"/>
-          <p:cNvSpPr>
-            <a:spLocks noGrp="1"/>
-          </p:cNvSpPr>
-          <p:nvPr>
-            <p:ph type="sldNum" idx="5" sz="quarter"/>
-          </p:nvPr>
-        </p:nvSpPr>
-        <p:spPr/>
-      </p:sp>
-    </p:spTree>
-  </p:cSld>
-  <p:clrMapOvr>
-    <a:masterClrMapping/>
-  </p:clrMapOvr>
-</p:notes>
-</file>
-
-<file path=ppt/notesSlides/notesSlide20.xml><?xml version="1.0" encoding="utf-8"?>
-<p:notes xmlns:a="http://schemas.openxmlformats.org/drawingml/2006/main" xmlns:p="http://schemas.openxmlformats.org/presentationml/2006/main" xmlns:r="http://schemas.openxmlformats.org/officeDocument/2006/relationships">
-  <p:cSld>
-    <p:spTree>
-      <p:nvGrpSpPr>
-        <p:cNvPr id="1" name=""/>
-        <p:cNvGrpSpPr/>
-        <p:nvPr/>
-      </p:nvGrpSpPr>
-      <p:grpSpPr>
-        <a:xfrm>
-          <a:off x="0" y="0"/>
-          <a:ext cx="0" cy="0"/>
-          <a:chOff x="0" y="0"/>
-          <a:chExt cx="0" cy="0"/>
-        </a:xfrm>
-      </p:grpSpPr>
-      <p:sp>
-        <p:nvSpPr>
-          <p:cNvPr id="2" name="Slide Image Placeholder 1"/>
-          <p:cNvSpPr>
-            <a:spLocks noGrp="1"/>
-          </p:cNvSpPr>
-          <p:nvPr>
-            <p:ph type="sldImg" idx="2"/>
-          </p:nvPr>
-        </p:nvSpPr>
-        <p:spPr/>
-      </p:sp>
-      <p:sp>
-        <p:nvSpPr>
-          <p:cNvPr id="3" name="Notes Placeholder 2"/>
-          <p:cNvSpPr>
-            <a:spLocks noGrp="1"/>
-          </p:cNvSpPr>
-          <p:nvPr>
-            <p:ph type="body" idx="3" sz="quarter"/>
-          </p:nvPr>
-        </p:nvSpPr>
-        <p:spPr/>
-        <p:txBody>
-          <a:bodyPr/>
-          <a:lstStyle/>
-          <a:p>
-            <a:r>
-              <a:t>And that's the complete guide. Go paste that link — your first production is waiting.</a:t>
+              <a:t>First, what the studio actually makes. You give it something to read — a link to a web article, or a PDF document. It reads that source and produces, on its own: a spoken audio episode, where a natural-sounding computer voice — that's what a voice-over is — narrates or discusses the material; a slideshow, meaning a set of slides that change on screen in time with the voice; a video file of the same thing that you can upload anywhere; and a PowerPoint you can present yourself. Your entire job is to say what you want in ordinary sentences. Keep that in mind throughout: you never edit anything by hand. You describe, the studio produces.</a:t>
             </a:r>
           </a:p>
         </p:txBody>
@@ -1479,13 +1082,7 @@
           <a:lstStyle/>
           <a:p>
             <a:r>
-              <a:t>When you open the studio in your browser you see two areas. On the left is the library — every production you have ever made, searchable, with small icons showing what each one contains. Nothing here disappears when you restart. On the right is the workspace, which starts on the New Generation form. Two buttons sit at the top of the library: New Generation, which is where every project begins, and Templates, where you can store visual styles to reuse — more on that later.</a:t>
-            </a:r>
-          </a:p>
-          <a:p/>
-          <a:p>
-            <a:r>
-              <a:t>Now let's make something. Here's your first production, step by step.</a:t>
+              <a:t>So let's take your first look at the studio. When you open it in your browser, you're looking at a dark page split into two areas. Down the left side runs a narrow column — that's the library, the list of everything you've ever produced, with a search box above it. Nothing in the library disappears when you close the app. At the top of that column sit two buttons: an amber one labeled New Generation — amber is the studio's signature orange-gold color, and that button is where every project begins — and a plain one labeled Templates, which we'll come back to. The large area to the right is your workspace, and it opens on a form titled "From source to sound." That form is what you're seeing on the slide right now.</a:t>
             </a:r>
           </a:p>
         </p:txBody>
@@ -1555,7 +1152,7 @@
           <a:lstStyle/>
           <a:p>
             <a:r>
-              <a:t>Let's walk the form from top to bottom. Under Source, you paste the web address of an article — or use a PDF instead: switch to PDF upload and pick a file, or simply drag the PDF from your computer anywhere onto the Source box and it attaches itself. This is the raw material — the studio will read it so your listeners don't have to.</a:t>
+              <a:t>Now let's fill in the form, top to bottom. It reads in three boxes. The first box is labeled Source. It has two small round buttons — URL and PDF upload — and a wide text field. Paste a web address into the field, or click PDF upload and choose a file. Easier still: drag a PDF from your computer anywhere onto that box and it attaches itself, showing the file's name in amber so you know it took.</a:t>
             </a:r>
           </a:p>
         </p:txBody>
@@ -1625,7 +1222,7 @@
           <a:lstStyle/>
           <a:p>
             <a:r>
-              <a:t>Mode decides what kind of listening experience you get, and there are three. Podcast turns the material into a conversation between two hosts who explain it to each other — the most entertaining choice for general audiences. Summary produces one narrator delivering the short version, two to four minutes — ideal when people just need the gist. Readout is the full document read aloud, faithfully, start to finish — the audiobook treatment.</a:t>
+              <a:t>The second box, Production, is where you make the three decisions that matter. The Mode menu decides the kind of listening experience: Podcast turns your source into a lively conversation between two hosts; Summary gives you one narrator delivering the short version in a few minutes; Readout is the whole document read aloud faithfully, like an audiobook. The Run Until menu decides how far the studio goes before pausing for you: choose Script Draft and it stops after writing the words — the cheap, safe place to start; choose Full Production and it goes all the way. And the Audience field is a plain-text box where you describe who will listen — type "complete beginners" or "busy executives who want numbers," and the writing, the examples, and the level of explanation all shift to fit those people. Below these sit optional personality fields — describe a host as "an enthusiastic teacher who loves analogies" and that is exactly who you'll hear — and voice pickers, which you can safely leave empty.</a:t>
             </a:r>
           </a:p>
         </p:txBody>
@@ -1695,7 +1292,7 @@
           <a:lstStyle/>
           <a:p>
             <a:r>
-              <a:t>Run Until is the most useful control for beginners, because it lets you work in safe steps. Choose Script Draft and the studio stops after writing the words, so you can read and adjust them before any audio exists. Choose Full Production and it goes all the way in one pass. Starting with a script draft costs less and teaches you the most, so that is the recommended first move.</a:t>
+              <a:t>The third box, Slides and Captions, chooses your outputs. Slides picks the formats: web slideshow, video, PowerPoint, or a combination. Captions are the spoken words shown as text on screen — pick Burned to print them permanently into the video, or Toggle so each viewer can turn them on and off. Animations, when switched on, makes slide content glide in element by element instead of appearing all at once — you're seeing that effect on these very slides. Then the amber Start Generation button at the bottom sets it all in motion.</a:t>
             </a:r>
           </a:p>
         </p:txBody>
@@ -1765,7 +1362,7 @@
           <a:lstStyle/>
           <a:p>
             <a:r>
-              <a:t>The Audience field is where the magic of tailoring happens. Type who will listen — "high-school students seeing this for the first time," or "busy executives who want the numbers" — and the script will lead with what those people care about, choose examples that land for them, and pitch explanations at the right level. The personality fields work the same way for the speakers themselves: describe host A as "an enthusiastic teacher who loves analogies" and that is exactly who shows up. The voice fields choose which synthetic voice speaks each part; leave them empty for sensible defaults, and know there are hundreds to pick from later.</a:t>
+              <a:t>Now let's talk about the project page and the four lights. The moment you start, the studio opens your project's own page. The project's title sits large at the top, with a small status capsule on the right that says whether it's working or done. And just below the title runs the most important thing on the page: a horizontal strip with four dots connected by a line, labeled Script, Slides, Voice, and Outputs. Think of it as four stations on an assembly line — first the words get written, then the visuals get designed, then the voice gets recorded, then everything gets packaged. A solid amber dot means that station is finished; a pulsing dot means it's working right now. Each label is clickable and takes you to that station's page. The studio's whole philosophy lives in this strip: you can stop at any station, say what you'd like changed, and everything after it updates automatically.</a:t>
             </a:r>
           </a:p>
         </p:txBody>
@@ -1835,7 +1432,7 @@
           <a:lstStyle/>
           <a:p>
             <a:r>
-              <a:t>Finally the Slides and Captions section. Slides picks your output formats: a web slideshow, a video file, a PowerPoint, or a combination. Captions puts the spoken words on screen — choose Burned to print them permanently into the video, or Toggle to let each viewer switch them on and off. Then press Start Generation and watch the pipeline go to work.</a:t>
+              <a:t>Let's visit station one: the script. Click Script — the first light — and you see the transcript: every sentence the voice will speak, laid out as a numbered list, each line carrying a small letter badge showing which speaker says it. What's on the slide now is a real script page. Read it the way a director reads a draft. When you want changes, look at the bottom of the page: there's a large text box labeled Revision Instructions with an amber Revise Script button beside it. Type what you want in plain words — "Open with a question instead of an announcement," "Cut the part about pricing," "Make the second host funnier" — and the studio rewrites exactly what you asked for, leaving every other line word-for-word untouched. A revision takes about a minute, and this is the single most important habit to learn: polish the words while they're cheap, before any audio or video exists.</a:t>
             </a:r>
           </a:p>
         </p:txBody>
@@ -1905,7 +1502,7 @@
           <a:lstStyle/>
           <a:p>
             <a:r>
-              <a:t>So what happens after you press that button? Think of it as an assembly line with four stations.</a:t>
+              <a:t>On to station two: the slides. Click Slides and the deck appears as a grid of small cards, one card per slide, like a storyboard. Each card shows the slide's number, the moment in the audio when it will appear, its title and bullet points, and — when the slide carries a picture or a chart — a small preview of it. The pictures aren't decoration pulled from a stock library: the studio lifts real images out of your source document, and it draws its own charts, timelines, and diagrams whenever the material contains data worth showing. Scroll to the bottom of this page and you'll find the Asset Inventory — a gallery of every image and figure with a note saying exactly which slide uses each one, so nothing in your production is a mystery.</a:t>
             </a:r>
           </a:p>
         </p:txBody>
@@ -5066,7 +4663,7 @@
               </a:defRPr>
             </a:pPr>
             <a:r>
-              <a:t>1 / 20</a:t>
+              <a:t>1 / 15</a:t>
             </a:r>
           </a:p>
         </p:txBody>
@@ -5150,7 +4747,7 @@
         <p:spPr>
           <a:xfrm>
             <a:off x="822960" y="457200"/>
-            <a:ext cx="10424160" cy="1371600"/>
+            <a:ext cx="5577840" cy="1371600"/>
           </a:xfrm>
           <a:prstGeom prst="rect">
             <a:avLst/>
@@ -5172,7 +4769,7 @@
               </a:defRPr>
             </a:pPr>
             <a:r>
-              <a:t>One Principle</a:t>
+              <a:t>Templates — your brand</a:t>
             </a:r>
           </a:p>
         </p:txBody>
@@ -5186,7 +4783,7 @@
         <p:spPr>
           <a:xfrm>
             <a:off x="822960" y="1737360"/>
-            <a:ext cx="10424160" cy="1645920"/>
+            <a:ext cx="5577840" cy="4572000"/>
           </a:xfrm>
           <a:prstGeom prst="rect">
             <a:avLst/>
@@ -5200,22 +4797,81 @@
           <a:lstStyle/>
           <a:p>
             <a:pPr>
-              <a:defRPr sz="2000" i="1">
+              <a:spcAft>
+                <a:spcPts val="1200"/>
+              </a:spcAft>
+              <a:defRPr sz="1800">
                 <a:solidFill>
-                  <a:srgbClr val="9AA0AB"/>
+                  <a:srgbClr val="F2F0EB"/>
                 </a:solidFill>
                 <a:latin typeface="Helvetica Neue"/>
               </a:defRPr>
             </a:pPr>
             <a:r>
-              <a:t>Stop at any station, change your mind in plain English — everything downstream updates</a:t>
-            </a:r>
-          </a:p>
-        </p:txBody>
-      </p:sp>
-      <p:sp>
-        <p:nvSpPr>
-          <p:cNvPr id="5" name="TextBox 4"/>
+              <a:t>•  Upload a theme, style guide, or screenshot</a:t>
+            </a:r>
+          </a:p>
+          <a:p>
+            <a:pPr>
+              <a:spcAft>
+                <a:spcPts val="1200"/>
+              </a:spcAft>
+              <a:defRPr sz="1800">
+                <a:solidFill>
+                  <a:srgbClr val="F2F0EB"/>
+                </a:solidFill>
+                <a:latin typeface="Helvetica Neue"/>
+              </a:defRPr>
+            </a:pPr>
+            <a:r>
+              <a:t>•  Studio reads your colors and fonts</a:t>
+            </a:r>
+          </a:p>
+          <a:p>
+            <a:pPr>
+              <a:spcAft>
+                <a:spcPts val="1200"/>
+              </a:spcAft>
+              <a:defRPr sz="1800">
+                <a:solidFill>
+                  <a:srgbClr val="F2F0EB"/>
+                </a:solidFill>
+                <a:latin typeface="Helvetica Neue"/>
+              </a:defRPr>
+            </a:pPr>
+            <a:r>
+              <a:t>•  Save once, reuse from a dropdown</a:t>
+            </a:r>
+          </a:p>
+        </p:txBody>
+      </p:sp>
+      <p:pic>
+        <p:nvPicPr>
+          <p:cNvPr id="5" name="Picture 4" descr="img_04.jpg"/>
+          <p:cNvPicPr>
+            <a:picLocks noChangeAspect="1"/>
+          </p:cNvPicPr>
+          <p:nvPr/>
+        </p:nvPicPr>
+        <p:blipFill>
+          <a:blip r:embed="rId2"/>
+          <a:stretch>
+            <a:fillRect/>
+          </a:stretch>
+        </p:blipFill>
+        <p:spPr>
+          <a:xfrm>
+            <a:off x="6675120" y="2019974"/>
+            <a:ext cx="4937760" cy="2818050"/>
+          </a:xfrm>
+          <a:prstGeom prst="rect">
+            <a:avLst/>
+          </a:prstGeom>
+        </p:spPr>
+      </p:pic>
+      <p:sp>
+        <p:nvSpPr>
+          <p:cNvPr id="6" name="TextBox 5"/>
           <p:cNvSpPr txBox="1"/>
           <p:nvPr/>
         </p:nvSpPr>
@@ -5244,7 +4900,7 @@
               </a:defRPr>
             </a:pPr>
             <a:r>
-              <a:t>10 / 20</a:t>
+              <a:t>10 / 15</a:t>
             </a:r>
           </a:p>
         </p:txBody>
@@ -5350,7 +5006,7 @@
               </a:defRPr>
             </a:pPr>
             <a:r>
-              <a:t>Station 1 — The Script</a:t>
+              <a:t>Station 3 — Voice review</a:t>
             </a:r>
           </a:p>
         </p:txBody>
@@ -5389,7 +5045,7 @@
               </a:defRPr>
             </a:pPr>
             <a:r>
-              <a:t>•  Every line numbered, tagged by speaker</a:t>
+              <a:t>•  Play button dims screen, shows slide large</a:t>
             </a:r>
           </a:p>
           <a:p>
@@ -5405,30 +5061,14 @@
               </a:defRPr>
             </a:pPr>
             <a:r>
-              <a:t>•  Don't edit — describe the change</a:t>
-            </a:r>
-          </a:p>
-          <a:p>
-            <a:pPr>
-              <a:spcAft>
-                <a:spcPts val="1200"/>
-              </a:spcAft>
-              <a:defRPr sz="1800">
-                <a:solidFill>
-                  <a:srgbClr val="F2F0EB"/>
-                </a:solidFill>
-                <a:latin typeface="Helvetica Neue"/>
-              </a:defRPr>
-            </a:pPr>
-            <a:r>
-              <a:t>•  Each revision takes about a minute</a:t>
+              <a:t>•  You hear only that slide's narration</a:t>
             </a:r>
           </a:p>
         </p:txBody>
       </p:sp>
       <p:pic>
         <p:nvPicPr>
-          <p:cNvPr id="5" name="Picture 4" descr="img_02.jpg"/>
+          <p:cNvPr id="5" name="Picture 4" descr="img_05.jpg"/>
           <p:cNvPicPr>
             <a:picLocks noChangeAspect="1"/>
           </p:cNvPicPr>
@@ -5481,7 +5121,7 @@
               </a:defRPr>
             </a:pPr>
             <a:r>
-              <a:t>11 / 20</a:t>
+              <a:t>11 / 15</a:t>
             </a:r>
           </a:p>
         </p:txBody>
@@ -5587,7 +5227,7 @@
               </a:defRPr>
             </a:pPr>
             <a:r>
-              <a:t>Station 2 — The Slides</a:t>
+              <a:t>Fixing what's off</a:t>
             </a:r>
           </a:p>
         </p:txBody>
@@ -5626,46 +5266,14 @@
               </a:defRPr>
             </a:pPr>
             <a:r>
-              <a:t>•  One card per slide, anchored to a line</a:t>
-            </a:r>
-          </a:p>
-          <a:p>
-            <a:pPr>
-              <a:spcAft>
-                <a:spcPts val="1200"/>
-              </a:spcAft>
-              <a:defRPr sz="1800">
-                <a:solidFill>
-                  <a:srgbClr val="F2F0EB"/>
-                </a:solidFill>
-                <a:latin typeface="Helvetica Neue"/>
-              </a:defRPr>
-            </a:pPr>
-            <a:r>
-              <a:t>•  Real images plus auto-designed figures</a:t>
-            </a:r>
-          </a:p>
-          <a:p>
-            <a:pPr>
-              <a:spcAft>
-                <a:spcPts val="1200"/>
-              </a:spcAft>
-              <a:defRPr sz="1800">
-                <a:solidFill>
-                  <a:srgbClr val="F2F0EB"/>
-                </a:solidFill>
-                <a:latin typeface="Helvetica Neue"/>
-              </a:defRPr>
-            </a:pPr>
-            <a:r>
-              <a:t>•  Asset Inventory maps every asset</a:t>
+              <a:t>•  Direct by line number; audio re-records in ~1 min</a:t>
             </a:r>
           </a:p>
         </p:txBody>
       </p:sp>
       <p:pic>
         <p:nvPicPr>
-          <p:cNvPr id="5" name="Picture 4" descr="img_03.jpg"/>
+          <p:cNvPr id="5" name="Picture 4" descr="figure_11.png"/>
           <p:cNvPicPr>
             <a:picLocks noChangeAspect="1"/>
           </p:cNvPicPr>
@@ -5679,8 +5287,8 @@
         </p:blipFill>
         <p:spPr>
           <a:xfrm>
-            <a:off x="6675120" y="2019974"/>
-            <a:ext cx="4937760" cy="2818050"/>
+            <a:off x="6675120" y="1898294"/>
+            <a:ext cx="4937760" cy="3061411"/>
           </a:xfrm>
           <a:prstGeom prst="rect">
             <a:avLst/>
@@ -5718,7 +5326,7 @@
               </a:defRPr>
             </a:pPr>
             <a:r>
-              <a:t>12 / 20</a:t>
+              <a:t>12 / 15</a:t>
             </a:r>
           </a:p>
         </p:txBody>
@@ -5824,7 +5432,7 @@
               </a:defRPr>
             </a:pPr>
             <a:r>
-              <a:t>Bring Your Brand</a:t>
+              <a:t>Station 4 — Outputs</a:t>
             </a:r>
           </a:p>
         </p:txBody>
@@ -5863,7 +5471,7 @@
               </a:defRPr>
             </a:pPr>
             <a:r>
-              <a:t>•  Upload PPTX, style guide, or a screenshot</a:t>
+              <a:t>•  Five finished files, each on its own card</a:t>
             </a:r>
           </a:p>
           <a:p>
@@ -5879,30 +5487,14 @@
               </a:defRPr>
             </a:pPr>
             <a:r>
-              <a:t>•  Colors and fonts applied everywhere</a:t>
-            </a:r>
-          </a:p>
-          <a:p>
-            <a:pPr>
-              <a:spcAft>
-                <a:spcPts val="1200"/>
-              </a:spcAft>
-              <a:defRPr sz="1800">
-                <a:solidFill>
-                  <a:srgbClr val="F2F0EB"/>
-                </a:solidFill>
-                <a:latin typeface="Helvetica Neue"/>
-              </a:defRPr>
-            </a:pPr>
-            <a:r>
-              <a:t>•  Save once, reuse from a dropdown</a:t>
+              <a:t>•  ~40¢ per full production; quick reruns ~1/10 cost</a:t>
             </a:r>
           </a:p>
         </p:txBody>
       </p:sp>
       <p:pic>
         <p:nvPicPr>
-          <p:cNvPr id="5" name="Picture 4" descr="img_04.jpg"/>
+          <p:cNvPr id="5" name="Picture 4" descr="img_06.jpg"/>
           <p:cNvPicPr>
             <a:picLocks noChangeAspect="1"/>
           </p:cNvPicPr>
@@ -5955,7 +5547,7 @@
               </a:defRPr>
             </a:pPr>
             <a:r>
-              <a:t>13 / 20</a:t>
+              <a:t>13 / 15</a:t>
             </a:r>
           </a:p>
         </p:txBody>
@@ -6039,7 +5631,7 @@
         <p:spPr>
           <a:xfrm>
             <a:off x="822960" y="457200"/>
-            <a:ext cx="10424160" cy="1371600"/>
+            <a:ext cx="5577840" cy="1371600"/>
           </a:xfrm>
           <a:prstGeom prst="rect">
             <a:avLst/>
@@ -6061,7 +5653,7 @@
               </a:defRPr>
             </a:pPr>
             <a:r>
-              <a:t>Station 3 — The Voice</a:t>
+              <a:t>Which output do I need?</a:t>
             </a:r>
           </a:p>
         </p:txBody>
@@ -6075,7 +5667,7 @@
         <p:spPr>
           <a:xfrm>
             <a:off x="822960" y="1737360"/>
-            <a:ext cx="10424160" cy="4572000"/>
+            <a:ext cx="5577840" cy="4572000"/>
           </a:xfrm>
           <a:prstGeom prst="rect">
             <a:avLst/>
@@ -6100,62 +5692,38 @@
               </a:defRPr>
             </a:pPr>
             <a:r>
-              <a:t>•  Every line directed individually</a:t>
-            </a:r>
-          </a:p>
-          <a:p>
-            <a:pPr>
-              <a:spcAft>
-                <a:spcPts val="1200"/>
-              </a:spcAft>
-              <a:defRPr sz="1800">
-                <a:solidFill>
-                  <a:srgbClr val="F2F0EB"/>
-                </a:solidFill>
-                <a:latin typeface="Helvetica Neue"/>
-              </a:defRPr>
-            </a:pPr>
-            <a:r>
-              <a:t>•  "Line 4: slow down, pause after the question"</a:t>
-            </a:r>
-          </a:p>
-          <a:p>
-            <a:pPr>
-              <a:spcAft>
-                <a:spcPts val="1200"/>
-              </a:spcAft>
-              <a:defRPr sz="1800">
-                <a:solidFill>
-                  <a:srgbClr val="F2F0EB"/>
-                </a:solidFill>
-                <a:latin typeface="Helvetica Neue"/>
-              </a:defRPr>
-            </a:pPr>
-            <a:r>
-              <a:t>•  Fix pronunciations; spelling stays correct</a:t>
-            </a:r>
-          </a:p>
-          <a:p>
-            <a:pPr>
-              <a:spcAft>
-                <a:spcPts val="1200"/>
-              </a:spcAft>
-              <a:defRPr sz="1800">
-                <a:solidFill>
-                  <a:srgbClr val="F2F0EB"/>
-                </a:solidFill>
-                <a:latin typeface="Helvetica Neue"/>
-              </a:defRPr>
-            </a:pPr>
-            <a:r>
-              <a:t>•  Audio re-records automatically</a:t>
-            </a:r>
-          </a:p>
-        </p:txBody>
-      </p:sp>
-      <p:sp>
-        <p:nvSpPr>
-          <p:cNvPr id="5" name="TextBox 4"/>
+              <a:t>•  Render assembles all five from your current work</a:t>
+            </a:r>
+          </a:p>
+        </p:txBody>
+      </p:sp>
+      <p:pic>
+        <p:nvPicPr>
+          <p:cNvPr id="5" name="Picture 4" descr="figure_13.png"/>
+          <p:cNvPicPr>
+            <a:picLocks noChangeAspect="1"/>
+          </p:cNvPicPr>
+          <p:nvPr/>
+        </p:nvPicPr>
+        <p:blipFill>
+          <a:blip r:embed="rId2"/>
+          <a:stretch>
+            <a:fillRect/>
+          </a:stretch>
+        </p:blipFill>
+        <p:spPr>
+          <a:xfrm>
+            <a:off x="6675120" y="1898294"/>
+            <a:ext cx="4937760" cy="3061411"/>
+          </a:xfrm>
+          <a:prstGeom prst="rect">
+            <a:avLst/>
+          </a:prstGeom>
+        </p:spPr>
+      </p:pic>
+      <p:sp>
+        <p:nvSpPr>
+          <p:cNvPr id="6" name="TextBox 5"/>
           <p:cNvSpPr txBox="1"/>
           <p:nvPr/>
         </p:nvSpPr>
@@ -6184,7 +5752,7 @@
               </a:defRPr>
             </a:pPr>
             <a:r>
-              <a:t>14 / 20</a:t>
+              <a:t>14 / 15</a:t>
             </a:r>
           </a:p>
         </p:txBody>
@@ -6268,7 +5836,7 @@
         <p:spPr>
           <a:xfrm>
             <a:off x="822960" y="457200"/>
-            <a:ext cx="5577840" cy="1371600"/>
+            <a:ext cx="10424160" cy="1371600"/>
           </a:xfrm>
           <a:prstGeom prst="rect">
             <a:avLst/>
@@ -6290,7 +5858,7 @@
               </a:defRPr>
             </a:pPr>
             <a:r>
-              <a:t>Review Slide by Slide</a:t>
+              <a:t>Your turn</a:t>
             </a:r>
           </a:p>
         </p:txBody>
@@ -6304,7 +5872,7 @@
         <p:spPr>
           <a:xfrm>
             <a:off x="822960" y="1737360"/>
-            <a:ext cx="5577840" cy="4572000"/>
+            <a:ext cx="10424160" cy="1645920"/>
           </a:xfrm>
           <a:prstGeom prst="rect">
             <a:avLst/>
@@ -6318,81 +5886,22 @@
           <a:lstStyle/>
           <a:p>
             <a:pPr>
-              <a:spcAft>
-                <a:spcPts val="1200"/>
-              </a:spcAft>
-              <a:defRPr sz="1800">
+              <a:defRPr sz="2000" i="1">
                 <a:solidFill>
-                  <a:srgbClr val="F2F0EB"/>
+                  <a:srgbClr val="9AA0AB"/>
                 </a:solidFill>
                 <a:latin typeface="Helvetica Neue"/>
               </a:defRPr>
             </a:pPr>
             <a:r>
-              <a:t>•  Play button on each slide card</a:t>
-            </a:r>
-          </a:p>
-          <a:p>
-            <a:pPr>
-              <a:spcAft>
-                <a:spcPts val="1200"/>
-              </a:spcAft>
-              <a:defRPr sz="1800">
-                <a:solidFill>
-                  <a:srgbClr val="F2F0EB"/>
-                </a:solidFill>
-                <a:latin typeface="Helvetica Neue"/>
-              </a:defRPr>
-            </a:pPr>
-            <a:r>
-              <a:t>•  Plays just that slide's narration</a:t>
-            </a:r>
-          </a:p>
-          <a:p>
-            <a:pPr>
-              <a:spcAft>
-                <a:spcPts val="1200"/>
-              </a:spcAft>
-              <a:defRPr sz="1800">
-                <a:solidFill>
-                  <a:srgbClr val="F2F0EB"/>
-                </a:solidFill>
-                <a:latin typeface="Helvetica Neue"/>
-              </a:defRPr>
-            </a:pPr>
-            <a:r>
-              <a:t>•  Step through or switch on auto-advance</a:t>
-            </a:r>
-          </a:p>
-        </p:txBody>
-      </p:sp>
-      <p:pic>
-        <p:nvPicPr>
-          <p:cNvPr id="5" name="Picture 4" descr="img_05.jpg"/>
-          <p:cNvPicPr>
-            <a:picLocks noChangeAspect="1"/>
-          </p:cNvPicPr>
-          <p:nvPr/>
-        </p:nvPicPr>
-        <p:blipFill>
-          <a:blip r:embed="rId2"/>
-          <a:stretch>
-            <a:fillRect/>
-          </a:stretch>
-        </p:blipFill>
-        <p:spPr>
-          <a:xfrm>
-            <a:off x="6675120" y="2019974"/>
-            <a:ext cx="4937760" cy="2818050"/>
-          </a:xfrm>
-          <a:prstGeom prst="rect">
-            <a:avLst/>
-          </a:prstGeom>
-        </p:spPr>
-      </p:pic>
-      <p:sp>
-        <p:nvSpPr>
-          <p:cNvPr id="6" name="TextBox 5"/>
+              <a:t>One pasted link, and you're a producer.</a:t>
+            </a:r>
+          </a:p>
+        </p:txBody>
+      </p:sp>
+      <p:sp>
+        <p:nvSpPr>
+          <p:cNvPr id="5" name="TextBox 4"/>
           <p:cNvSpPr txBox="1"/>
           <p:nvPr/>
         </p:nvSpPr>
@@ -6421,939 +5930,7 @@
               </a:defRPr>
             </a:pPr>
             <a:r>
-              <a:t>15 / 20</a:t>
-            </a:r>
-          </a:p>
-        </p:txBody>
-      </p:sp>
-    </p:spTree>
-  </p:cSld>
-  <p:clrMapOvr>
-    <a:masterClrMapping/>
-  </p:clrMapOvr>
-</p:sld>
-</file>
-
-<file path=ppt/slides/slide16.xml><?xml version="1.0" encoding="utf-8"?>
-<p:sld xmlns:a="http://schemas.openxmlformats.org/drawingml/2006/main" xmlns:p="http://schemas.openxmlformats.org/presentationml/2006/main" xmlns:r="http://schemas.openxmlformats.org/officeDocument/2006/relationships">
-  <p:cSld>
-    <p:bg>
-      <p:bgPr>
-        <a:solidFill>
-          <a:srgbClr val="1E222A"/>
-        </a:solidFill>
-        <a:effectLst/>
-      </p:bgPr>
-    </p:bg>
-    <p:spTree>
-      <p:nvGrpSpPr>
-        <p:cNvPr id="1" name=""/>
-        <p:cNvGrpSpPr/>
-        <p:nvPr/>
-      </p:nvGrpSpPr>
-      <p:grpSpPr/>
-      <p:sp>
-        <p:nvSpPr>
-          <p:cNvPr id="2" name="Rectangle 1"/>
-          <p:cNvSpPr/>
-          <p:nvPr/>
-        </p:nvSpPr>
-        <p:spPr>
-          <a:xfrm>
-            <a:off x="0" y="0"/>
-            <a:ext cx="91440" cy="6858000"/>
-          </a:xfrm>
-          <a:prstGeom prst="rect">
-            <a:avLst/>
-          </a:prstGeom>
-          <a:solidFill>
-            <a:srgbClr val="E8A13C"/>
-          </a:solidFill>
-          <a:ln>
-            <a:noFill/>
-          </a:ln>
-          <a:effectLst/>
-        </p:spPr>
-        <p:style>
-          <a:lnRef idx="1">
-            <a:schemeClr val="accent1"/>
-          </a:lnRef>
-          <a:fillRef idx="3">
-            <a:schemeClr val="accent1"/>
-          </a:fillRef>
-          <a:effectRef idx="2">
-            <a:schemeClr val="accent1"/>
-          </a:effectRef>
-          <a:fontRef idx="minor">
-            <a:schemeClr val="lt1"/>
-          </a:fontRef>
-        </p:style>
-        <p:txBody>
-          <a:bodyPr rtlCol="0" anchor="ctr"/>
-          <a:lstStyle/>
-          <a:p>
-            <a:pPr algn="ctr"/>
-          </a:p>
-        </p:txBody>
-      </p:sp>
-      <p:sp>
-        <p:nvSpPr>
-          <p:cNvPr id="3" name="TextBox 2"/>
-          <p:cNvSpPr txBox="1"/>
-          <p:nvPr/>
-        </p:nvSpPr>
-        <p:spPr>
-          <a:xfrm>
-            <a:off x="822960" y="457200"/>
-            <a:ext cx="5577840" cy="1371600"/>
-          </a:xfrm>
-          <a:prstGeom prst="rect">
-            <a:avLst/>
-          </a:prstGeom>
-          <a:noFill/>
-        </p:spPr>
-        <p:txBody>
-          <a:bodyPr wrap="square">
-            <a:spAutoFit/>
-          </a:bodyPr>
-          <a:lstStyle/>
-          <a:p>
-            <a:pPr>
-              <a:defRPr sz="3000" b="1">
-                <a:solidFill>
-                  <a:srgbClr val="F2F0EB"/>
-                </a:solidFill>
-                <a:latin typeface="Helvetica Neue"/>
-              </a:defRPr>
-            </a:pPr>
-            <a:r>
-              <a:t>Review, Revise, Re-render</a:t>
-            </a:r>
-          </a:p>
-        </p:txBody>
-      </p:sp>
-      <p:sp>
-        <p:nvSpPr>
-          <p:cNvPr id="4" name="TextBox 3"/>
-          <p:cNvSpPr txBox="1"/>
-          <p:nvPr/>
-        </p:nvSpPr>
-        <p:spPr>
-          <a:xfrm>
-            <a:off x="822960" y="1737360"/>
-            <a:ext cx="5577840" cy="4572000"/>
-          </a:xfrm>
-          <a:prstGeom prst="rect">
-            <a:avLst/>
-          </a:prstGeom>
-          <a:noFill/>
-        </p:spPr>
-        <p:txBody>
-          <a:bodyPr wrap="square">
-            <a:spAutoFit/>
-          </a:bodyPr>
-          <a:lstStyle/>
-          <a:p>
-            <a:pPr>
-              <a:spcAft>
-                <a:spcPts val="1200"/>
-              </a:spcAft>
-              <a:defRPr sz="1800">
-                <a:solidFill>
-                  <a:srgbClr val="F2F0EB"/>
-                </a:solidFill>
-                <a:latin typeface="Helvetica Neue"/>
-              </a:defRPr>
-            </a:pPr>
-            <a:r>
-              <a:t>•  Offset field nudges timing in seconds</a:t>
-            </a:r>
-          </a:p>
-          <a:p>
-            <a:pPr>
-              <a:spcAft>
-                <a:spcPts val="1200"/>
-              </a:spcAft>
-              <a:defRPr sz="1800">
-                <a:solidFill>
-                  <a:srgbClr val="F2F0EB"/>
-                </a:solidFill>
-                <a:latin typeface="Helvetica Neue"/>
-              </a:defRPr>
-            </a:pPr>
-            <a:r>
-              <a:t>•  The audio is never touched</a:t>
-            </a:r>
-          </a:p>
-        </p:txBody>
-      </p:sp>
-      <p:pic>
-        <p:nvPicPr>
-          <p:cNvPr id="5" name="Picture 4" descr="figure_15.png"/>
-          <p:cNvPicPr>
-            <a:picLocks noChangeAspect="1"/>
-          </p:cNvPicPr>
-          <p:nvPr/>
-        </p:nvPicPr>
-        <p:blipFill>
-          <a:blip r:embed="rId2"/>
-          <a:stretch>
-            <a:fillRect/>
-          </a:stretch>
-        </p:blipFill>
-        <p:spPr>
-          <a:xfrm>
-            <a:off x="6675120" y="1898294"/>
-            <a:ext cx="4937760" cy="3061411"/>
-          </a:xfrm>
-          <a:prstGeom prst="rect">
-            <a:avLst/>
-          </a:prstGeom>
-        </p:spPr>
-      </p:pic>
-      <p:sp>
-        <p:nvSpPr>
-          <p:cNvPr id="6" name="TextBox 5"/>
-          <p:cNvSpPr txBox="1"/>
-          <p:nvPr/>
-        </p:nvSpPr>
-        <p:spPr>
-          <a:xfrm>
-            <a:off x="10820095" y="6355080"/>
-            <a:ext cx="1005840" cy="365760"/>
-          </a:xfrm>
-          <a:prstGeom prst="rect">
-            <a:avLst/>
-          </a:prstGeom>
-          <a:noFill/>
-        </p:spPr>
-        <p:txBody>
-          <a:bodyPr wrap="none">
-            <a:spAutoFit/>
-          </a:bodyPr>
-          <a:lstStyle/>
-          <a:p>
-            <a:pPr algn="r">
-              <a:defRPr sz="1200">
-                <a:solidFill>
-                  <a:srgbClr val="9AA0AB"/>
-                </a:solidFill>
-                <a:latin typeface="Helvetica Neue"/>
-              </a:defRPr>
-            </a:pPr>
-            <a:r>
-              <a:t>16 / 20</a:t>
-            </a:r>
-          </a:p>
-        </p:txBody>
-      </p:sp>
-    </p:spTree>
-  </p:cSld>
-  <p:clrMapOvr>
-    <a:masterClrMapping/>
-  </p:clrMapOvr>
-</p:sld>
-</file>
-
-<file path=ppt/slides/slide17.xml><?xml version="1.0" encoding="utf-8"?>
-<p:sld xmlns:a="http://schemas.openxmlformats.org/drawingml/2006/main" xmlns:p="http://schemas.openxmlformats.org/presentationml/2006/main" xmlns:r="http://schemas.openxmlformats.org/officeDocument/2006/relationships">
-  <p:cSld>
-    <p:bg>
-      <p:bgPr>
-        <a:solidFill>
-          <a:srgbClr val="1E222A"/>
-        </a:solidFill>
-        <a:effectLst/>
-      </p:bgPr>
-    </p:bg>
-    <p:spTree>
-      <p:nvGrpSpPr>
-        <p:cNvPr id="1" name=""/>
-        <p:cNvGrpSpPr/>
-        <p:nvPr/>
-      </p:nvGrpSpPr>
-      <p:grpSpPr/>
-      <p:sp>
-        <p:nvSpPr>
-          <p:cNvPr id="2" name="Rectangle 1"/>
-          <p:cNvSpPr/>
-          <p:nvPr/>
-        </p:nvSpPr>
-        <p:spPr>
-          <a:xfrm>
-            <a:off x="0" y="0"/>
-            <a:ext cx="91440" cy="6858000"/>
-          </a:xfrm>
-          <a:prstGeom prst="rect">
-            <a:avLst/>
-          </a:prstGeom>
-          <a:solidFill>
-            <a:srgbClr val="E8A13C"/>
-          </a:solidFill>
-          <a:ln>
-            <a:noFill/>
-          </a:ln>
-          <a:effectLst/>
-        </p:spPr>
-        <p:style>
-          <a:lnRef idx="1">
-            <a:schemeClr val="accent1"/>
-          </a:lnRef>
-          <a:fillRef idx="3">
-            <a:schemeClr val="accent1"/>
-          </a:fillRef>
-          <a:effectRef idx="2">
-            <a:schemeClr val="accent1"/>
-          </a:effectRef>
-          <a:fontRef idx="minor">
-            <a:schemeClr val="lt1"/>
-          </a:fontRef>
-        </p:style>
-        <p:txBody>
-          <a:bodyPr rtlCol="0" anchor="ctr"/>
-          <a:lstStyle/>
-          <a:p>
-            <a:pPr algn="ctr"/>
-          </a:p>
-        </p:txBody>
-      </p:sp>
-      <p:sp>
-        <p:nvSpPr>
-          <p:cNvPr id="3" name="TextBox 2"/>
-          <p:cNvSpPr txBox="1"/>
-          <p:nvPr/>
-        </p:nvSpPr>
-        <p:spPr>
-          <a:xfrm>
-            <a:off x="822960" y="457200"/>
-            <a:ext cx="5577840" cy="1371600"/>
-          </a:xfrm>
-          <a:prstGeom prst="rect">
-            <a:avLst/>
-          </a:prstGeom>
-          <a:noFill/>
-        </p:spPr>
-        <p:txBody>
-          <a:bodyPr wrap="square">
-            <a:spAutoFit/>
-          </a:bodyPr>
-          <a:lstStyle/>
-          <a:p>
-            <a:pPr>
-              <a:defRPr sz="3000" b="1">
-                <a:solidFill>
-                  <a:srgbClr val="F2F0EB"/>
-                </a:solidFill>
-                <a:latin typeface="Helvetica Neue"/>
-              </a:defRPr>
-            </a:pPr>
-            <a:r>
-              <a:t>Station 4 — The Outputs</a:t>
-            </a:r>
-          </a:p>
-        </p:txBody>
-      </p:sp>
-      <p:sp>
-        <p:nvSpPr>
-          <p:cNvPr id="4" name="TextBox 3"/>
-          <p:cNvSpPr txBox="1"/>
-          <p:nvPr/>
-        </p:nvSpPr>
-        <p:spPr>
-          <a:xfrm>
-            <a:off x="822960" y="1737360"/>
-            <a:ext cx="5577840" cy="4572000"/>
-          </a:xfrm>
-          <a:prstGeom prst="rect">
-            <a:avLst/>
-          </a:prstGeom>
-          <a:noFill/>
-        </p:spPr>
-        <p:txBody>
-          <a:bodyPr wrap="square">
-            <a:spAutoFit/>
-          </a:bodyPr>
-          <a:lstStyle/>
-          <a:p>
-            <a:pPr>
-              <a:spcAft>
-                <a:spcPts val="1200"/>
-              </a:spcAft>
-              <a:defRPr sz="1800">
-                <a:solidFill>
-                  <a:srgbClr val="F2F0EB"/>
-                </a:solidFill>
-                <a:latin typeface="Helvetica Neue"/>
-              </a:defRPr>
-            </a:pPr>
-            <a:r>
-              <a:t>•  Render assembles from your latest work</a:t>
-            </a:r>
-          </a:p>
-          <a:p>
-            <a:pPr>
-              <a:spcAft>
-                <a:spcPts val="1200"/>
-              </a:spcAft>
-              <a:defRPr sz="1800">
-                <a:solidFill>
-                  <a:srgbClr val="F2F0EB"/>
-                </a:solidFill>
-                <a:latin typeface="Helvetica Neue"/>
-              </a:defRPr>
-            </a:pPr>
-            <a:r>
-              <a:t>•  MP3, transcript, slideshow, video, PPTX</a:t>
-            </a:r>
-          </a:p>
-          <a:p>
-            <a:pPr>
-              <a:spcAft>
-                <a:spcPts val="1200"/>
-              </a:spcAft>
-              <a:defRPr sz="1800">
-                <a:solidFill>
-                  <a:srgbClr val="F2F0EB"/>
-                </a:solidFill>
-                <a:latin typeface="Helvetica Neue"/>
-              </a:defRPr>
-            </a:pPr>
-            <a:r>
-              <a:t>•  Slideshow emails with audio built in</a:t>
-            </a:r>
-          </a:p>
-        </p:txBody>
-      </p:sp>
-      <p:pic>
-        <p:nvPicPr>
-          <p:cNvPr id="5" name="Picture 4" descr="img_06.jpg"/>
-          <p:cNvPicPr>
-            <a:picLocks noChangeAspect="1"/>
-          </p:cNvPicPr>
-          <p:nvPr/>
-        </p:nvPicPr>
-        <p:blipFill>
-          <a:blip r:embed="rId2"/>
-          <a:stretch>
-            <a:fillRect/>
-          </a:stretch>
-        </p:blipFill>
-        <p:spPr>
-          <a:xfrm>
-            <a:off x="6675120" y="2019974"/>
-            <a:ext cx="4937760" cy="2818050"/>
-          </a:xfrm>
-          <a:prstGeom prst="rect">
-            <a:avLst/>
-          </a:prstGeom>
-        </p:spPr>
-      </p:pic>
-      <p:sp>
-        <p:nvSpPr>
-          <p:cNvPr id="6" name="TextBox 5"/>
-          <p:cNvSpPr txBox="1"/>
-          <p:nvPr/>
-        </p:nvSpPr>
-        <p:spPr>
-          <a:xfrm>
-            <a:off x="10820095" y="6355080"/>
-            <a:ext cx="1005840" cy="365760"/>
-          </a:xfrm>
-          <a:prstGeom prst="rect">
-            <a:avLst/>
-          </a:prstGeom>
-          <a:noFill/>
-        </p:spPr>
-        <p:txBody>
-          <a:bodyPr wrap="none">
-            <a:spAutoFit/>
-          </a:bodyPr>
-          <a:lstStyle/>
-          <a:p>
-            <a:pPr algn="r">
-              <a:defRPr sz="1200">
-                <a:solidFill>
-                  <a:srgbClr val="9AA0AB"/>
-                </a:solidFill>
-                <a:latin typeface="Helvetica Neue"/>
-              </a:defRPr>
-            </a:pPr>
-            <a:r>
-              <a:t>17 / 20</a:t>
-            </a:r>
-          </a:p>
-        </p:txBody>
-      </p:sp>
-    </p:spTree>
-  </p:cSld>
-  <p:clrMapOvr>
-    <a:masterClrMapping/>
-  </p:clrMapOvr>
-</p:sld>
-</file>
-
-<file path=ppt/slides/slide18.xml><?xml version="1.0" encoding="utf-8"?>
-<p:sld xmlns:a="http://schemas.openxmlformats.org/drawingml/2006/main" xmlns:p="http://schemas.openxmlformats.org/presentationml/2006/main" xmlns:r="http://schemas.openxmlformats.org/officeDocument/2006/relationships">
-  <p:cSld>
-    <p:bg>
-      <p:bgPr>
-        <a:solidFill>
-          <a:srgbClr val="1E222A"/>
-        </a:solidFill>
-        <a:effectLst/>
-      </p:bgPr>
-    </p:bg>
-    <p:spTree>
-      <p:nvGrpSpPr>
-        <p:cNvPr id="1" name=""/>
-        <p:cNvGrpSpPr/>
-        <p:nvPr/>
-      </p:nvGrpSpPr>
-      <p:grpSpPr/>
-      <p:sp>
-        <p:nvSpPr>
-          <p:cNvPr id="2" name="Rectangle 1"/>
-          <p:cNvSpPr/>
-          <p:nvPr/>
-        </p:nvSpPr>
-        <p:spPr>
-          <a:xfrm>
-            <a:off x="0" y="0"/>
-            <a:ext cx="91440" cy="6858000"/>
-          </a:xfrm>
-          <a:prstGeom prst="rect">
-            <a:avLst/>
-          </a:prstGeom>
-          <a:solidFill>
-            <a:srgbClr val="E8A13C"/>
-          </a:solidFill>
-          <a:ln>
-            <a:noFill/>
-          </a:ln>
-          <a:effectLst/>
-        </p:spPr>
-        <p:style>
-          <a:lnRef idx="1">
-            <a:schemeClr val="accent1"/>
-          </a:lnRef>
-          <a:fillRef idx="3">
-            <a:schemeClr val="accent1"/>
-          </a:fillRef>
-          <a:effectRef idx="2">
-            <a:schemeClr val="accent1"/>
-          </a:effectRef>
-          <a:fontRef idx="minor">
-            <a:schemeClr val="lt1"/>
-          </a:fontRef>
-        </p:style>
-        <p:txBody>
-          <a:bodyPr rtlCol="0" anchor="ctr"/>
-          <a:lstStyle/>
-          <a:p>
-            <a:pPr algn="ctr"/>
-          </a:p>
-        </p:txBody>
-      </p:sp>
-      <p:sp>
-        <p:nvSpPr>
-          <p:cNvPr id="3" name="TextBox 2"/>
-          <p:cNvSpPr txBox="1"/>
-          <p:nvPr/>
-        </p:nvSpPr>
-        <p:spPr>
-          <a:xfrm>
-            <a:off x="822960" y="457200"/>
-            <a:ext cx="10424160" cy="1371600"/>
-          </a:xfrm>
-          <a:prstGeom prst="rect">
-            <a:avLst/>
-          </a:prstGeom>
-          <a:noFill/>
-        </p:spPr>
-        <p:txBody>
-          <a:bodyPr wrap="square">
-            <a:spAutoFit/>
-          </a:bodyPr>
-          <a:lstStyle/>
-          <a:p>
-            <a:pPr>
-              <a:defRPr sz="3000" b="1">
-                <a:solidFill>
-                  <a:srgbClr val="F2F0EB"/>
-                </a:solidFill>
-                <a:latin typeface="Helvetica Neue"/>
-              </a:defRPr>
-            </a:pPr>
-            <a:r>
-              <a:t>A Word About Cost</a:t>
-            </a:r>
-          </a:p>
-        </p:txBody>
-      </p:sp>
-      <p:sp>
-        <p:nvSpPr>
-          <p:cNvPr id="4" name="TextBox 3"/>
-          <p:cNvSpPr txBox="1"/>
-          <p:nvPr/>
-        </p:nvSpPr>
-        <p:spPr>
-          <a:xfrm>
-            <a:off x="822960" y="1737360"/>
-            <a:ext cx="10424160" cy="4572000"/>
-          </a:xfrm>
-          <a:prstGeom prst="rect">
-            <a:avLst/>
-          </a:prstGeom>
-          <a:noFill/>
-        </p:spPr>
-        <p:txBody>
-          <a:bodyPr wrap="square">
-            <a:spAutoFit/>
-          </a:bodyPr>
-          <a:lstStyle/>
-          <a:p>
-            <a:pPr>
-              <a:spcAft>
-                <a:spcPts val="1200"/>
-              </a:spcAft>
-              <a:defRPr sz="1800">
-                <a:solidFill>
-                  <a:srgbClr val="F2F0EB"/>
-                </a:solidFill>
-                <a:latin typeface="Helvetica Neue"/>
-              </a:defRPr>
-            </a:pPr>
-            <a:r>
-              <a:t>•  Running spend shown in a header chip</a:t>
-            </a:r>
-          </a:p>
-          <a:p>
-            <a:pPr>
-              <a:spcAft>
-                <a:spcPts val="1200"/>
-              </a:spcAft>
-              <a:defRPr sz="1800">
-                <a:solidFill>
-                  <a:srgbClr val="F2F0EB"/>
-                </a:solidFill>
-                <a:latin typeface="Helvetica Neue"/>
-              </a:defRPr>
-            </a:pPr>
-            <a:r>
-              <a:t>•  Usually well under a dollar per production</a:t>
-            </a:r>
-          </a:p>
-          <a:p>
-            <a:pPr>
-              <a:spcAft>
-                <a:spcPts val="1200"/>
-              </a:spcAft>
-              <a:defRPr sz="1800">
-                <a:solidFill>
-                  <a:srgbClr val="F2F0EB"/>
-                </a:solidFill>
-                <a:latin typeface="Helvetica Neue"/>
-              </a:defRPr>
-            </a:pPr>
-            <a:r>
-              <a:t>•  Repeat revisions billed ~one-tenth price</a:t>
-            </a:r>
-          </a:p>
-          <a:p>
-            <a:pPr>
-              <a:spcAft>
-                <a:spcPts val="1200"/>
-              </a:spcAft>
-              <a:defRPr sz="1800">
-                <a:solidFill>
-                  <a:srgbClr val="F2F0EB"/>
-                </a:solidFill>
-                <a:latin typeface="Helvetica Neue"/>
-              </a:defRPr>
-            </a:pPr>
-            <a:r>
-              <a:t>•  Revise in focused bursts</a:t>
-            </a:r>
-          </a:p>
-        </p:txBody>
-      </p:sp>
-      <p:sp>
-        <p:nvSpPr>
-          <p:cNvPr id="5" name="TextBox 4"/>
-          <p:cNvSpPr txBox="1"/>
-          <p:nvPr/>
-        </p:nvSpPr>
-        <p:spPr>
-          <a:xfrm>
-            <a:off x="10820095" y="6355080"/>
-            <a:ext cx="1005840" cy="365760"/>
-          </a:xfrm>
-          <a:prstGeom prst="rect">
-            <a:avLst/>
-          </a:prstGeom>
-          <a:noFill/>
-        </p:spPr>
-        <p:txBody>
-          <a:bodyPr wrap="none">
-            <a:spAutoFit/>
-          </a:bodyPr>
-          <a:lstStyle/>
-          <a:p>
-            <a:pPr algn="r">
-              <a:defRPr sz="1200">
-                <a:solidFill>
-                  <a:srgbClr val="9AA0AB"/>
-                </a:solidFill>
-                <a:latin typeface="Helvetica Neue"/>
-              </a:defRPr>
-            </a:pPr>
-            <a:r>
-              <a:t>18 / 20</a:t>
-            </a:r>
-          </a:p>
-        </p:txBody>
-      </p:sp>
-    </p:spTree>
-  </p:cSld>
-  <p:clrMapOvr>
-    <a:masterClrMapping/>
-  </p:clrMapOvr>
-</p:sld>
-</file>
-
-<file path=ppt/slides/slide19.xml><?xml version="1.0" encoding="utf-8"?>
-<p:sld xmlns:a="http://schemas.openxmlformats.org/drawingml/2006/main" xmlns:p="http://schemas.openxmlformats.org/presentationml/2006/main" xmlns:r="http://schemas.openxmlformats.org/officeDocument/2006/relationships">
-  <p:cSld>
-    <p:bg>
-      <p:bgPr>
-        <a:solidFill>
-          <a:srgbClr val="1E222A"/>
-        </a:solidFill>
-        <a:effectLst/>
-      </p:bgPr>
-    </p:bg>
-    <p:spTree>
-      <p:nvGrpSpPr>
-        <p:cNvPr id="1" name=""/>
-        <p:cNvGrpSpPr/>
-        <p:nvPr/>
-      </p:nvGrpSpPr>
-      <p:grpSpPr/>
-      <p:sp>
-        <p:nvSpPr>
-          <p:cNvPr id="2" name="Rectangle 1"/>
-          <p:cNvSpPr/>
-          <p:nvPr/>
-        </p:nvSpPr>
-        <p:spPr>
-          <a:xfrm>
-            <a:off x="0" y="0"/>
-            <a:ext cx="91440" cy="6858000"/>
-          </a:xfrm>
-          <a:prstGeom prst="rect">
-            <a:avLst/>
-          </a:prstGeom>
-          <a:solidFill>
-            <a:srgbClr val="E8A13C"/>
-          </a:solidFill>
-          <a:ln>
-            <a:noFill/>
-          </a:ln>
-          <a:effectLst/>
-        </p:spPr>
-        <p:style>
-          <a:lnRef idx="1">
-            <a:schemeClr val="accent1"/>
-          </a:lnRef>
-          <a:fillRef idx="3">
-            <a:schemeClr val="accent1"/>
-          </a:fillRef>
-          <a:effectRef idx="2">
-            <a:schemeClr val="accent1"/>
-          </a:effectRef>
-          <a:fontRef idx="minor">
-            <a:schemeClr val="lt1"/>
-          </a:fontRef>
-        </p:style>
-        <p:txBody>
-          <a:bodyPr rtlCol="0" anchor="ctr"/>
-          <a:lstStyle/>
-          <a:p>
-            <a:pPr algn="ctr"/>
-          </a:p>
-        </p:txBody>
-      </p:sp>
-      <p:sp>
-        <p:nvSpPr>
-          <p:cNvPr id="3" name="TextBox 2"/>
-          <p:cNvSpPr txBox="1"/>
-          <p:nvPr/>
-        </p:nvSpPr>
-        <p:spPr>
-          <a:xfrm>
-            <a:off x="822960" y="457200"/>
-            <a:ext cx="10424160" cy="1371600"/>
-          </a:xfrm>
-          <a:prstGeom prst="rect">
-            <a:avLst/>
-          </a:prstGeom>
-          <a:noFill/>
-        </p:spPr>
-        <p:txBody>
-          <a:bodyPr wrap="square">
-            <a:spAutoFit/>
-          </a:bodyPr>
-          <a:lstStyle/>
-          <a:p>
-            <a:pPr>
-              <a:defRPr sz="3000" b="1">
-                <a:solidFill>
-                  <a:srgbClr val="F2F0EB"/>
-                </a:solidFill>
-                <a:latin typeface="Helvetica Neue"/>
-              </a:defRPr>
-            </a:pPr>
-            <a:r>
-              <a:t>The Zero-to-Hero Path</a:t>
-            </a:r>
-          </a:p>
-        </p:txBody>
-      </p:sp>
-      <p:sp>
-        <p:nvSpPr>
-          <p:cNvPr id="4" name="TextBox 3"/>
-          <p:cNvSpPr txBox="1"/>
-          <p:nvPr/>
-        </p:nvSpPr>
-        <p:spPr>
-          <a:xfrm>
-            <a:off x="822960" y="1737360"/>
-            <a:ext cx="10424160" cy="4572000"/>
-          </a:xfrm>
-          <a:prstGeom prst="rect">
-            <a:avLst/>
-          </a:prstGeom>
-          <a:noFill/>
-        </p:spPr>
-        <p:txBody>
-          <a:bodyPr wrap="square">
-            <a:spAutoFit/>
-          </a:bodyPr>
-          <a:lstStyle/>
-          <a:p>
-            <a:pPr>
-              <a:spcAft>
-                <a:spcPts val="1200"/>
-              </a:spcAft>
-              <a:defRPr sz="1800">
-                <a:solidFill>
-                  <a:srgbClr val="F2F0EB"/>
-                </a:solidFill>
-                <a:latin typeface="Helvetica Neue"/>
-              </a:defRPr>
-            </a:pPr>
-            <a:r>
-              <a:t>•  1. Source + mode + audience → script</a:t>
-            </a:r>
-          </a:p>
-          <a:p>
-            <a:pPr>
-              <a:spcAft>
-                <a:spcPts val="1200"/>
-              </a:spcAft>
-              <a:defRPr sz="1800">
-                <a:solidFill>
-                  <a:srgbClr val="F2F0EB"/>
-                </a:solidFill>
-                <a:latin typeface="Helvetica Neue"/>
-              </a:defRPr>
-            </a:pPr>
-            <a:r>
-              <a:t>•  2. Revise the script in plain English</a:t>
-            </a:r>
-          </a:p>
-          <a:p>
-            <a:pPr>
-              <a:spcAft>
-                <a:spcPts val="1200"/>
-              </a:spcAft>
-              <a:defRPr sz="1800">
-                <a:solidFill>
-                  <a:srgbClr val="F2F0EB"/>
-                </a:solidFill>
-                <a:latin typeface="Helvetica Neue"/>
-              </a:defRPr>
-            </a:pPr>
-            <a:r>
-              <a:t>•  3. Create and shape the slides</a:t>
-            </a:r>
-          </a:p>
-          <a:p>
-            <a:pPr>
-              <a:spcAft>
-                <a:spcPts val="1200"/>
-              </a:spcAft>
-              <a:defRPr sz="1800">
-                <a:solidFill>
-                  <a:srgbClr val="F2F0EB"/>
-                </a:solidFill>
-                <a:latin typeface="Helvetica Neue"/>
-              </a:defRPr>
-            </a:pPr>
-            <a:r>
-              <a:t>•  4. Render, then review with play buttons</a:t>
-            </a:r>
-          </a:p>
-          <a:p>
-            <a:pPr>
-              <a:spcAft>
-                <a:spcPts val="1200"/>
-              </a:spcAft>
-              <a:defRPr sz="1800">
-                <a:solidFill>
-                  <a:srgbClr val="F2F0EB"/>
-                </a:solidFill>
-                <a:latin typeface="Helvetica Neue"/>
-              </a:defRPr>
-            </a:pPr>
-            <a:r>
-              <a:t>•  5. Fix voice, nudge timing, collect outputs</a:t>
-            </a:r>
-          </a:p>
-        </p:txBody>
-      </p:sp>
-      <p:sp>
-        <p:nvSpPr>
-          <p:cNvPr id="5" name="TextBox 4"/>
-          <p:cNvSpPr txBox="1"/>
-          <p:nvPr/>
-        </p:nvSpPr>
-        <p:spPr>
-          <a:xfrm>
-            <a:off x="10820095" y="6355080"/>
-            <a:ext cx="1005840" cy="365760"/>
-          </a:xfrm>
-          <a:prstGeom prst="rect">
-            <a:avLst/>
-          </a:prstGeom>
-          <a:noFill/>
-        </p:spPr>
-        <p:txBody>
-          <a:bodyPr wrap="none">
-            <a:spAutoFit/>
-          </a:bodyPr>
-          <a:lstStyle/>
-          <a:p>
-            <a:pPr algn="r">
-              <a:defRPr sz="1200">
-                <a:solidFill>
-                  <a:srgbClr val="9AA0AB"/>
-                </a:solidFill>
-                <a:latin typeface="Helvetica Neue"/>
-              </a:defRPr>
-            </a:pPr>
-            <a:r>
-              <a:t>19 / 20</a:t>
+              <a:t>15 / 15</a:t>
             </a:r>
           </a:p>
         </p:txBody>
@@ -7459,7 +6036,7 @@
               </a:defRPr>
             </a:pPr>
             <a:r>
-              <a:t>The Idea in One Breath</a:t>
+              <a:t>The core idea</a:t>
             </a:r>
           </a:p>
         </p:txBody>
@@ -7473,7 +6050,7 @@
         <p:spPr>
           <a:xfrm>
             <a:off x="822960" y="1737360"/>
-            <a:ext cx="10424160" cy="4572000"/>
+            <a:ext cx="10424160" cy="1645920"/>
           </a:xfrm>
           <a:prstGeom prst="rect">
             <a:avLst/>
@@ -7487,66 +6064,15 @@
           <a:lstStyle/>
           <a:p>
             <a:pPr>
-              <a:spcAft>
-                <a:spcPts val="1200"/>
-              </a:spcAft>
-              <a:defRPr sz="1800">
+              <a:defRPr sz="2000" i="1">
                 <a:solidFill>
-                  <a:srgbClr val="F2F0EB"/>
+                  <a:srgbClr val="9AA0AB"/>
                 </a:solidFill>
                 <a:latin typeface="Helvetica Neue"/>
               </a:defRPr>
             </a:pPr>
             <a:r>
-              <a:t>•  Give it an article link or a PDF</a:t>
-            </a:r>
-          </a:p>
-          <a:p>
-            <a:pPr>
-              <a:spcAft>
-                <a:spcPts val="1200"/>
-              </a:spcAft>
-              <a:defRPr sz="1800">
-                <a:solidFill>
-                  <a:srgbClr val="F2F0EB"/>
-                </a:solidFill>
-                <a:latin typeface="Helvetica Neue"/>
-              </a:defRPr>
-            </a:pPr>
-            <a:r>
-              <a:t>•  It writes, records, and designs slides</a:t>
-            </a:r>
-          </a:p>
-          <a:p>
-            <a:pPr>
-              <a:spcAft>
-                <a:spcPts val="1200"/>
-              </a:spcAft>
-              <a:defRPr sz="1800">
-                <a:solidFill>
-                  <a:srgbClr val="F2F0EB"/>
-                </a:solidFill>
-                <a:latin typeface="Helvetica Neue"/>
-              </a:defRPr>
-            </a:pPr>
-            <a:r>
-              <a:t>•  Get audio, slideshow, video, PowerPoint</a:t>
-            </a:r>
-          </a:p>
-          <a:p>
-            <a:pPr>
-              <a:spcAft>
-                <a:spcPts val="1200"/>
-              </a:spcAft>
-              <a:defRPr sz="1800">
-                <a:solidFill>
-                  <a:srgbClr val="F2F0EB"/>
-                </a:solidFill>
-                <a:latin typeface="Helvetica Neue"/>
-              </a:defRPr>
-            </a:pPr>
-            <a:r>
-              <a:t>•  You direct; the studio produces</a:t>
+              <a:t>You describe. The studio produces.</a:t>
             </a:r>
           </a:p>
         </p:txBody>
@@ -7582,185 +6108,7 @@
               </a:defRPr>
             </a:pPr>
             <a:r>
-              <a:t>2 / 20</a:t>
-            </a:r>
-          </a:p>
-        </p:txBody>
-      </p:sp>
-    </p:spTree>
-  </p:cSld>
-  <p:clrMapOvr>
-    <a:masterClrMapping/>
-  </p:clrMapOvr>
-</p:sld>
-</file>
-
-<file path=ppt/slides/slide20.xml><?xml version="1.0" encoding="utf-8"?>
-<p:sld xmlns:a="http://schemas.openxmlformats.org/drawingml/2006/main" xmlns:p="http://schemas.openxmlformats.org/presentationml/2006/main" xmlns:r="http://schemas.openxmlformats.org/officeDocument/2006/relationships">
-  <p:cSld>
-    <p:bg>
-      <p:bgPr>
-        <a:solidFill>
-          <a:srgbClr val="1E222A"/>
-        </a:solidFill>
-        <a:effectLst/>
-      </p:bgPr>
-    </p:bg>
-    <p:spTree>
-      <p:nvGrpSpPr>
-        <p:cNvPr id="1" name=""/>
-        <p:cNvGrpSpPr/>
-        <p:nvPr/>
-      </p:nvGrpSpPr>
-      <p:grpSpPr/>
-      <p:sp>
-        <p:nvSpPr>
-          <p:cNvPr id="2" name="Rectangle 1"/>
-          <p:cNvSpPr/>
-          <p:nvPr/>
-        </p:nvSpPr>
-        <p:spPr>
-          <a:xfrm>
-            <a:off x="0" y="0"/>
-            <a:ext cx="91440" cy="6858000"/>
-          </a:xfrm>
-          <a:prstGeom prst="rect">
-            <a:avLst/>
-          </a:prstGeom>
-          <a:solidFill>
-            <a:srgbClr val="E8A13C"/>
-          </a:solidFill>
-          <a:ln>
-            <a:noFill/>
-          </a:ln>
-          <a:effectLst/>
-        </p:spPr>
-        <p:style>
-          <a:lnRef idx="1">
-            <a:schemeClr val="accent1"/>
-          </a:lnRef>
-          <a:fillRef idx="3">
-            <a:schemeClr val="accent1"/>
-          </a:fillRef>
-          <a:effectRef idx="2">
-            <a:schemeClr val="accent1"/>
-          </a:effectRef>
-          <a:fontRef idx="minor">
-            <a:schemeClr val="lt1"/>
-          </a:fontRef>
-        </p:style>
-        <p:txBody>
-          <a:bodyPr rtlCol="0" anchor="ctr"/>
-          <a:lstStyle/>
-          <a:p>
-            <a:pPr algn="ctr"/>
-          </a:p>
-        </p:txBody>
-      </p:sp>
-      <p:sp>
-        <p:nvSpPr>
-          <p:cNvPr id="3" name="TextBox 2"/>
-          <p:cNvSpPr txBox="1"/>
-          <p:nvPr/>
-        </p:nvSpPr>
-        <p:spPr>
-          <a:xfrm>
-            <a:off x="822960" y="457200"/>
-            <a:ext cx="10424160" cy="1371600"/>
-          </a:xfrm>
-          <a:prstGeom prst="rect">
-            <a:avLst/>
-          </a:prstGeom>
-          <a:noFill/>
-        </p:spPr>
-        <p:txBody>
-          <a:bodyPr wrap="square">
-            <a:spAutoFit/>
-          </a:bodyPr>
-          <a:lstStyle/>
-          <a:p>
-            <a:pPr>
-              <a:defRPr sz="3000" b="1">
-                <a:solidFill>
-                  <a:srgbClr val="F2F0EB"/>
-                </a:solidFill>
-                <a:latin typeface="Helvetica Neue"/>
-              </a:defRPr>
-            </a:pPr>
-            <a:r>
-              <a:t>Welcome to Fluent Agents Studio</a:t>
-            </a:r>
-          </a:p>
-        </p:txBody>
-      </p:sp>
-      <p:sp>
-        <p:nvSpPr>
-          <p:cNvPr id="4" name="TextBox 3"/>
-          <p:cNvSpPr txBox="1"/>
-          <p:nvPr/>
-        </p:nvSpPr>
-        <p:spPr>
-          <a:xfrm>
-            <a:off x="822960" y="1737360"/>
-            <a:ext cx="10424160" cy="1645920"/>
-          </a:xfrm>
-          <a:prstGeom prst="rect">
-            <a:avLst/>
-          </a:prstGeom>
-          <a:noFill/>
-        </p:spPr>
-        <p:txBody>
-          <a:bodyPr wrap="square">
-            <a:spAutoFit/>
-          </a:bodyPr>
-          <a:lstStyle/>
-          <a:p>
-            <a:pPr>
-              <a:defRPr sz="2000" i="1">
-                <a:solidFill>
-                  <a:srgbClr val="9AA0AB"/>
-                </a:solidFill>
-                <a:latin typeface="Helvetica Neue"/>
-              </a:defRPr>
-            </a:pPr>
-            <a:r>
-              <a:t>Your first production is one pasted link away</a:t>
-            </a:r>
-          </a:p>
-        </p:txBody>
-      </p:sp>
-      <p:sp>
-        <p:nvSpPr>
-          <p:cNvPr id="5" name="TextBox 4"/>
-          <p:cNvSpPr txBox="1"/>
-          <p:nvPr/>
-        </p:nvSpPr>
-        <p:spPr>
-          <a:xfrm>
-            <a:off x="10820095" y="6355080"/>
-            <a:ext cx="1005840" cy="365760"/>
-          </a:xfrm>
-          <a:prstGeom prst="rect">
-            <a:avLst/>
-          </a:prstGeom>
-          <a:noFill/>
-        </p:spPr>
-        <p:txBody>
-          <a:bodyPr wrap="none">
-            <a:spAutoFit/>
-          </a:bodyPr>
-          <a:lstStyle/>
-          <a:p>
-            <a:pPr algn="r">
-              <a:defRPr sz="1200">
-                <a:solidFill>
-                  <a:srgbClr val="9AA0AB"/>
-                </a:solidFill>
-                <a:latin typeface="Helvetica Neue"/>
-              </a:defRPr>
-            </a:pPr>
-            <a:r>
-              <a:t>20 / 20</a:t>
+              <a:t>2 / 15</a:t>
             </a:r>
           </a:p>
         </p:txBody>
@@ -7844,7 +6192,7 @@
         <p:spPr>
           <a:xfrm>
             <a:off x="822960" y="457200"/>
-            <a:ext cx="10424160" cy="1371600"/>
+            <a:ext cx="5577840" cy="1371600"/>
           </a:xfrm>
           <a:prstGeom prst="rect">
             <a:avLst/>
@@ -7866,7 +6214,7 @@
               </a:defRPr>
             </a:pPr>
             <a:r>
-              <a:t>The Workbench at a Glance</a:t>
+              <a:t>Your first look</a:t>
             </a:r>
           </a:p>
         </p:txBody>
@@ -7880,7 +6228,7 @@
         <p:spPr>
           <a:xfrm>
             <a:off x="822960" y="1737360"/>
-            <a:ext cx="10424160" cy="4572000"/>
+            <a:ext cx="5577840" cy="4572000"/>
           </a:xfrm>
           <a:prstGeom prst="rect">
             <a:avLst/>
@@ -7905,7 +6253,7 @@
               </a:defRPr>
             </a:pPr>
             <a:r>
-              <a:t>•  Left: searchable library, always saved</a:t>
+              <a:t>•  Left: library of everything you've made</a:t>
             </a:r>
           </a:p>
           <a:p>
@@ -7921,7 +6269,7 @@
               </a:defRPr>
             </a:pPr>
             <a:r>
-              <a:t>•  Right: workspace, New Generation form</a:t>
+              <a:t>•  Amber New Generation starts every project</a:t>
             </a:r>
           </a:p>
           <a:p>
@@ -7937,14 +6285,38 @@
               </a:defRPr>
             </a:pPr>
             <a:r>
-              <a:t>•  Two buttons: New Generation, Templates</a:t>
-            </a:r>
-          </a:p>
-        </p:txBody>
-      </p:sp>
-      <p:sp>
-        <p:nvSpPr>
-          <p:cNvPr id="5" name="TextBox 4"/>
+              <a:t>•  Right: workspace — "From source to sound"</a:t>
+            </a:r>
+          </a:p>
+        </p:txBody>
+      </p:sp>
+      <p:pic>
+        <p:nvPicPr>
+          <p:cNvPr id="5" name="Picture 4" descr="img_01.jpg"/>
+          <p:cNvPicPr>
+            <a:picLocks noChangeAspect="1"/>
+          </p:cNvPicPr>
+          <p:nvPr/>
+        </p:nvPicPr>
+        <p:blipFill>
+          <a:blip r:embed="rId2"/>
+          <a:stretch>
+            <a:fillRect/>
+          </a:stretch>
+        </p:blipFill>
+        <p:spPr>
+          <a:xfrm>
+            <a:off x="6675120" y="2019974"/>
+            <a:ext cx="4937760" cy="2818050"/>
+          </a:xfrm>
+          <a:prstGeom prst="rect">
+            <a:avLst/>
+          </a:prstGeom>
+        </p:spPr>
+      </p:pic>
+      <p:sp>
+        <p:nvSpPr>
+          <p:cNvPr id="6" name="TextBox 5"/>
           <p:cNvSpPr txBox="1"/>
           <p:nvPr/>
         </p:nvSpPr>
@@ -7973,7 +6345,7 @@
               </a:defRPr>
             </a:pPr>
             <a:r>
-              <a:t>3 / 20</a:t>
+              <a:t>3 / 15</a:t>
             </a:r>
           </a:p>
         </p:txBody>
@@ -8057,7 +6429,7 @@
         <p:spPr>
           <a:xfrm>
             <a:off x="822960" y="457200"/>
-            <a:ext cx="5577840" cy="1371600"/>
+            <a:ext cx="10424160" cy="1371600"/>
           </a:xfrm>
           <a:prstGeom prst="rect">
             <a:avLst/>
@@ -8079,7 +6451,7 @@
               </a:defRPr>
             </a:pPr>
             <a:r>
-              <a:t>Step 1 — Point at a Source</a:t>
+              <a:t>Step 1 — the Source box</a:t>
             </a:r>
           </a:p>
         </p:txBody>
@@ -8093,7 +6465,7 @@
         <p:spPr>
           <a:xfrm>
             <a:off x="822960" y="1737360"/>
-            <a:ext cx="5577840" cy="4572000"/>
+            <a:ext cx="10424160" cy="4572000"/>
           </a:xfrm>
           <a:prstGeom prst="rect">
             <a:avLst/>
@@ -8118,7 +6490,7 @@
               </a:defRPr>
             </a:pPr>
             <a:r>
-              <a:t>•  Paste a URL, or upload a PDF</a:t>
+              <a:t>•  Choose URL or PDF upload</a:t>
             </a:r>
           </a:p>
           <a:p>
@@ -8134,7 +6506,7 @@
               </a:defRPr>
             </a:pPr>
             <a:r>
-              <a:t>•  Drag a PDF onto the Source box</a:t>
+              <a:t>•  Paste a web address in the field</a:t>
             </a:r>
           </a:p>
           <a:p>
@@ -8150,38 +6522,30 @@
               </a:defRPr>
             </a:pPr>
             <a:r>
-              <a:t>•  The raw material the studio reads</a:t>
-            </a:r>
-          </a:p>
-        </p:txBody>
-      </p:sp>
-      <p:pic>
-        <p:nvPicPr>
-          <p:cNvPr id="5" name="Picture 4" descr="img_01.jpg"/>
-          <p:cNvPicPr>
-            <a:picLocks noChangeAspect="1"/>
-          </p:cNvPicPr>
-          <p:nvPr/>
-        </p:nvPicPr>
-        <p:blipFill>
-          <a:blip r:embed="rId2"/>
-          <a:stretch>
-            <a:fillRect/>
-          </a:stretch>
-        </p:blipFill>
-        <p:spPr>
-          <a:xfrm>
-            <a:off x="6675120" y="2019974"/>
-            <a:ext cx="4937760" cy="2818050"/>
-          </a:xfrm>
-          <a:prstGeom prst="rect">
-            <a:avLst/>
-          </a:prstGeom>
-        </p:spPr>
-      </p:pic>
-      <p:sp>
-        <p:nvSpPr>
-          <p:cNvPr id="6" name="TextBox 5"/>
+              <a:t>•  Or drag a PDF onto the box</a:t>
+            </a:r>
+          </a:p>
+          <a:p>
+            <a:pPr>
+              <a:spcAft>
+                <a:spcPts val="1200"/>
+              </a:spcAft>
+              <a:defRPr sz="1800">
+                <a:solidFill>
+                  <a:srgbClr val="F2F0EB"/>
+                </a:solidFill>
+                <a:latin typeface="Helvetica Neue"/>
+              </a:defRPr>
+            </a:pPr>
+            <a:r>
+              <a:t>•  Filename shows in amber when attached</a:t>
+            </a:r>
+          </a:p>
+        </p:txBody>
+      </p:sp>
+      <p:sp>
+        <p:nvSpPr>
+          <p:cNvPr id="5" name="TextBox 4"/>
           <p:cNvSpPr txBox="1"/>
           <p:nvPr/>
         </p:nvSpPr>
@@ -8210,7 +6574,7 @@
               </a:defRPr>
             </a:pPr>
             <a:r>
-              <a:t>4 / 20</a:t>
+              <a:t>4 / 15</a:t>
             </a:r>
           </a:p>
         </p:txBody>
@@ -8316,7 +6680,7 @@
               </a:defRPr>
             </a:pPr>
             <a:r>
-              <a:t>Step 2 — Choose Your Mode</a:t>
+              <a:t>Step 2 — the three decisions</a:t>
             </a:r>
           </a:p>
         </p:txBody>
@@ -8355,7 +6719,7 @@
               </a:defRPr>
             </a:pPr>
             <a:r>
-              <a:t>•  Podcast: two hosts in conversation</a:t>
+              <a:t>•  Mode: Podcast, Summary, or Readout</a:t>
             </a:r>
           </a:p>
           <a:p>
@@ -8371,7 +6735,7 @@
               </a:defRPr>
             </a:pPr>
             <a:r>
-              <a:t>•  Summary: one narrator, 2–4 minutes</a:t>
+              <a:t>•  Run Until: Script Draft (cheap start) or Full</a:t>
             </a:r>
           </a:p>
           <a:p>
@@ -8387,7 +6751,23 @@
               </a:defRPr>
             </a:pPr>
             <a:r>
-              <a:t>•  Readout: full document, read faithfully</a:t>
+              <a:t>•  Audience: describe who's listening</a:t>
+            </a:r>
+          </a:p>
+          <a:p>
+            <a:pPr>
+              <a:spcAft>
+                <a:spcPts val="1200"/>
+              </a:spcAft>
+              <a:defRPr sz="1800">
+                <a:solidFill>
+                  <a:srgbClr val="F2F0EB"/>
+                </a:solidFill>
+                <a:latin typeface="Helvetica Neue"/>
+              </a:defRPr>
+            </a:pPr>
+            <a:r>
+              <a:t>•  Personality &amp; voices — optional</a:t>
             </a:r>
           </a:p>
         </p:txBody>
@@ -8423,7 +6803,7 @@
               </a:defRPr>
             </a:pPr>
             <a:r>
-              <a:t>5 / 20</a:t>
+              <a:t>5 / 15</a:t>
             </a:r>
           </a:p>
         </p:txBody>
@@ -8529,7 +6909,7 @@
               </a:defRPr>
             </a:pPr>
             <a:r>
-              <a:t>Step 3 — Run Until</a:t>
+              <a:t>Step 3 — Slides &amp; Captions</a:t>
             </a:r>
           </a:p>
         </p:txBody>
@@ -8568,7 +6948,7 @@
               </a:defRPr>
             </a:pPr>
             <a:r>
-              <a:t>•  Script Draft: stop after the words</a:t>
+              <a:t>•  Slides: web, video, PowerPoint, or combo</a:t>
             </a:r>
           </a:p>
           <a:p>
@@ -8584,7 +6964,7 @@
               </a:defRPr>
             </a:pPr>
             <a:r>
-              <a:t>•  Full Production: all in one pass</a:t>
+              <a:t>•  Captions: Burned in, or Toggle on/off</a:t>
             </a:r>
           </a:p>
           <a:p>
@@ -8600,7 +6980,23 @@
               </a:defRPr>
             </a:pPr>
             <a:r>
-              <a:t>•  Start with a draft — cheaper, clearer</a:t>
+              <a:t>•  Animations glide content in element by element</a:t>
+            </a:r>
+          </a:p>
+          <a:p>
+            <a:pPr>
+              <a:spcAft>
+                <a:spcPts val="1200"/>
+              </a:spcAft>
+              <a:defRPr sz="1800">
+                <a:solidFill>
+                  <a:srgbClr val="F2F0EB"/>
+                </a:solidFill>
+                <a:latin typeface="Helvetica Neue"/>
+              </a:defRPr>
+            </a:pPr>
+            <a:r>
+              <a:t>•  Amber Start Generation begins it all</a:t>
             </a:r>
           </a:p>
         </p:txBody>
@@ -8636,7 +7032,7 @@
               </a:defRPr>
             </a:pPr>
             <a:r>
-              <a:t>6 / 20</a:t>
+              <a:t>6 / 15</a:t>
             </a:r>
           </a:p>
         </p:txBody>
@@ -8720,7 +7116,7 @@
         <p:spPr>
           <a:xfrm>
             <a:off x="822960" y="457200"/>
-            <a:ext cx="10424160" cy="1371600"/>
+            <a:ext cx="5577840" cy="1371600"/>
           </a:xfrm>
           <a:prstGeom prst="rect">
             <a:avLst/>
@@ -8742,7 +7138,7 @@
               </a:defRPr>
             </a:pPr>
             <a:r>
-              <a:t>Step 4 — Tailor to Your Audience</a:t>
+              <a:t>The four stations</a:t>
             </a:r>
           </a:p>
         </p:txBody>
@@ -8756,7 +7152,7 @@
         <p:spPr>
           <a:xfrm>
             <a:off x="822960" y="1737360"/>
-            <a:ext cx="10424160" cy="4572000"/>
+            <a:ext cx="5577840" cy="4572000"/>
           </a:xfrm>
           <a:prstGeom prst="rect">
             <a:avLst/>
@@ -8781,46 +7177,38 @@
               </a:defRPr>
             </a:pPr>
             <a:r>
-              <a:t>•  Name who will be listening</a:t>
-            </a:r>
-          </a:p>
-          <a:p>
-            <a:pPr>
-              <a:spcAft>
-                <a:spcPts val="1200"/>
-              </a:spcAft>
-              <a:defRPr sz="1800">
-                <a:solidFill>
-                  <a:srgbClr val="F2F0EB"/>
-                </a:solidFill>
-                <a:latin typeface="Helvetica Neue"/>
-              </a:defRPr>
-            </a:pPr>
-            <a:r>
-              <a:t>•  Script leads with what they care about</a:t>
-            </a:r>
-          </a:p>
-          <a:p>
-            <a:pPr>
-              <a:spcAft>
-                <a:spcPts val="1200"/>
-              </a:spcAft>
-              <a:defRPr sz="1800">
-                <a:solidFill>
-                  <a:srgbClr val="F2F0EB"/>
-                </a:solidFill>
-                <a:latin typeface="Helvetica Neue"/>
-              </a:defRPr>
-            </a:pPr>
-            <a:r>
-              <a:t>•  Describe host personalities, pick voices</a:t>
-            </a:r>
-          </a:p>
-        </p:txBody>
-      </p:sp>
-      <p:sp>
-        <p:nvSpPr>
-          <p:cNvPr id="5" name="TextBox 4"/>
+              <a:t>•  Stop anywhere; later stations update automatically</a:t>
+            </a:r>
+          </a:p>
+        </p:txBody>
+      </p:sp>
+      <p:pic>
+        <p:nvPicPr>
+          <p:cNvPr id="5" name="Picture 4" descr="figure_06.png"/>
+          <p:cNvPicPr>
+            <a:picLocks noChangeAspect="1"/>
+          </p:cNvPicPr>
+          <p:nvPr/>
+        </p:nvPicPr>
+        <p:blipFill>
+          <a:blip r:embed="rId2"/>
+          <a:stretch>
+            <a:fillRect/>
+          </a:stretch>
+        </p:blipFill>
+        <p:spPr>
+          <a:xfrm>
+            <a:off x="6675120" y="1898294"/>
+            <a:ext cx="4937760" cy="3061411"/>
+          </a:xfrm>
+          <a:prstGeom prst="rect">
+            <a:avLst/>
+          </a:prstGeom>
+        </p:spPr>
+      </p:pic>
+      <p:sp>
+        <p:nvSpPr>
+          <p:cNvPr id="6" name="TextBox 5"/>
           <p:cNvSpPr txBox="1"/>
           <p:nvPr/>
         </p:nvSpPr>
@@ -8849,7 +7237,7 @@
               </a:defRPr>
             </a:pPr>
             <a:r>
-              <a:t>7 / 20</a:t>
+              <a:t>7 / 15</a:t>
             </a:r>
           </a:p>
         </p:txBody>
@@ -8955,7 +7343,7 @@
               </a:defRPr>
             </a:pPr>
             <a:r>
-              <a:t>Which Output Do I Need?</a:t>
+              <a:t>Station 1 — Script</a:t>
             </a:r>
           </a:p>
         </p:txBody>
@@ -8994,14 +7382,30 @@
               </a:defRPr>
             </a:pPr>
             <a:r>
-              <a:t>•  Pick one format or a combination</a:t>
+              <a:t>•  Every spoken line, numbered, with speaker badges</a:t>
+            </a:r>
+          </a:p>
+          <a:p>
+            <a:pPr>
+              <a:spcAft>
+                <a:spcPts val="1200"/>
+              </a:spcAft>
+              <a:defRPr sz="1800">
+                <a:solidFill>
+                  <a:srgbClr val="F2F0EB"/>
+                </a:solidFill>
+                <a:latin typeface="Helvetica Neue"/>
+              </a:defRPr>
+            </a:pPr>
+            <a:r>
+              <a:t>•  Revise in plain words; other lines stay untouched</a:t>
             </a:r>
           </a:p>
         </p:txBody>
       </p:sp>
       <p:pic>
         <p:nvPicPr>
-          <p:cNvPr id="5" name="Picture 4" descr="figure_07.png"/>
+          <p:cNvPr id="5" name="Picture 4" descr="img_02.jpg"/>
           <p:cNvPicPr>
             <a:picLocks noChangeAspect="1"/>
           </p:cNvPicPr>
@@ -9015,8 +7419,8 @@
         </p:blipFill>
         <p:spPr>
           <a:xfrm>
-            <a:off x="6675120" y="1898294"/>
-            <a:ext cx="4937760" cy="3061411"/>
+            <a:off x="6675120" y="2019974"/>
+            <a:ext cx="4937760" cy="2818050"/>
           </a:xfrm>
           <a:prstGeom prst="rect">
             <a:avLst/>
@@ -9054,7 +7458,7 @@
               </a:defRPr>
             </a:pPr>
             <a:r>
-              <a:t>8 / 20</a:t>
+              <a:t>8 / 15</a:t>
             </a:r>
           </a:p>
         </p:txBody>
@@ -9160,7 +7564,7 @@
               </a:defRPr>
             </a:pPr>
             <a:r>
-              <a:t>Four Stations on One Line</a:t>
+              <a:t>Station 2 — Slides</a:t>
             </a:r>
           </a:p>
         </p:txBody>
@@ -9199,7 +7603,7 @@
               </a:defRPr>
             </a:pPr>
             <a:r>
-              <a:t>•  Amber = finished; pulsing = working now</a:t>
+              <a:t>•  Storyboard of cards, one per slide</a:t>
             </a:r>
           </a:p>
           <a:p>
@@ -9215,14 +7619,30 @@
               </a:defRPr>
             </a:pPr>
             <a:r>
-              <a:t>•  Click any light to jump to that station</a:t>
+              <a:t>•  Real images and auto-drawn charts</a:t>
+            </a:r>
+          </a:p>
+          <a:p>
+            <a:pPr>
+              <a:spcAft>
+                <a:spcPts val="1200"/>
+              </a:spcAft>
+              <a:defRPr sz="1800">
+                <a:solidFill>
+                  <a:srgbClr val="F2F0EB"/>
+                </a:solidFill>
+                <a:latin typeface="Helvetica Neue"/>
+              </a:defRPr>
+            </a:pPr>
+            <a:r>
+              <a:t>•  Asset Inventory lists every visual</a:t>
             </a:r>
           </a:p>
         </p:txBody>
       </p:sp>
       <p:pic>
         <p:nvPicPr>
-          <p:cNvPr id="5" name="Picture 4" descr="figure_08.png"/>
+          <p:cNvPr id="5" name="Picture 4" descr="img_03.jpg"/>
           <p:cNvPicPr>
             <a:picLocks noChangeAspect="1"/>
           </p:cNvPicPr>
@@ -9236,8 +7656,8 @@
         </p:blipFill>
         <p:spPr>
           <a:xfrm>
-            <a:off x="6675120" y="1898294"/>
-            <a:ext cx="4937760" cy="3061411"/>
+            <a:off x="6675120" y="2019974"/>
+            <a:ext cx="4937760" cy="2818050"/>
           </a:xfrm>
           <a:prstGeom prst="rect">
             <a:avLst/>
@@ -9275,7 +7695,7 @@
               </a:defRPr>
             </a:pPr>
             <a:r>
-              <a:t>9 / 20</a:t>
+              <a:t>9 / 15</a:t>
             </a:r>
           </a:p>
         </p:txBody>

</xml_diff>